<commit_message>
Finalize Digital Minds submission and repository
</commit_message>
<xml_diff>
--- a/Digital_Minds_Track3_Slides.pptx
+++ b/Digital_Minds_Track3_Slides.pptx
@@ -5,14 +5,14 @@
     <p:sldMasterId id="2147483648" r:id="rId1"/>
   </p:sldMasterIdLst>
   <p:sldIdLst>
-    <p:sldId id="256" r:id="rId7"/>
-    <p:sldId id="257" r:id="rId8"/>
-    <p:sldId id="258" r:id="rId9"/>
-    <p:sldId id="259" r:id="rId10"/>
-    <p:sldId id="260" r:id="rId11"/>
-    <p:sldId id="261" r:id="rId12"/>
+    <p:sldId id="256" r:id="rId2"/>
+    <p:sldId id="257" r:id="rId3"/>
+    <p:sldId id="258" r:id="rId4"/>
+    <p:sldId id="259" r:id="rId5"/>
+    <p:sldId id="260" r:id="rId6"/>
+    <p:sldId id="261" r:id="rId7"/>
   </p:sldIdLst>
-  <p:sldSz cx="12191695" cy="6858000" type="screen4x3"/>
+  <p:sldSz cx="12192000" cy="6858000"/>
   <p:notesSz cx="6858000" cy="9144000"/>
   <p:defaultTextStyle>
     <a:defPPr>
@@ -109,6 +109,22 @@
       </a:defRPr>
     </a:lvl9pPr>
   </p:defaultTextStyle>
+  <p:extLst>
+    <p:ext uri="{EFAFB233-063F-42B5-8137-9DF3F51BA10A}">
+      <p15:sldGuideLst xmlns:p15="http://schemas.microsoft.com/office/powerpoint/2012/main">
+        <p15:guide id="1" orient="horz" pos="2160">
+          <p15:clr>
+            <a:srgbClr val="A4A3A4"/>
+          </p15:clr>
+        </p15:guide>
+        <p15:guide id="2" pos="2880">
+          <p15:clr>
+            <a:srgbClr val="A4A3A4"/>
+          </p15:clr>
+        </p15:guide>
+      </p15:sldGuideLst>
+    </p:ext>
+  </p:extLst>
 </p:presentation>
 </file>
 
@@ -150,10 +166,9 @@
           <a:lstStyle/>
           <a:p>
             <a:r>
-              <a:rPr lang="en-US" smtClean="0"/>
+              <a:rPr lang="en-US"/>
               <a:t>Click to edit Master title style</a:t>
             </a:r>
-            <a:endParaRPr lang="en-US"/>
           </a:p>
         </p:txBody>
       </p:sp>
@@ -269,10 +284,9 @@
           </a:lstStyle>
           <a:p>
             <a:r>
-              <a:rPr lang="en-US" smtClean="0"/>
+              <a:rPr lang="en-US"/>
               <a:t>Click to edit Master subtitle style</a:t>
             </a:r>
-            <a:endParaRPr lang="en-US"/>
           </a:p>
         </p:txBody>
       </p:sp>
@@ -293,7 +307,7 @@
           <a:p>
             <a:fld id="{5BCAD085-E8A6-8845-BD4E-CB4CCA059FC4}" type="datetimeFigureOut">
               <a:rPr lang="en-US" smtClean="0"/>
-              <a:t>1/27/13</a:t>
+              <a:t>8/16/2026</a:t>
             </a:fld>
             <a:endParaRPr lang="en-US"/>
           </a:p>
@@ -387,10 +401,9 @@
           <a:lstStyle/>
           <a:p>
             <a:r>
-              <a:rPr lang="en-US" smtClean="0"/>
+              <a:rPr lang="en-US"/>
               <a:t>Click to edit Master title style</a:t>
             </a:r>
-            <a:endParaRPr lang="en-US"/>
           </a:p>
         </p:txBody>
       </p:sp>
@@ -411,38 +424,37 @@
           <a:p>
             <a:pPr lvl="0"/>
             <a:r>
-              <a:rPr lang="en-US" smtClean="0"/>
+              <a:rPr lang="en-US"/>
               <a:t>Click to edit Master text styles</a:t>
             </a:r>
           </a:p>
           <a:p>
             <a:pPr lvl="1"/>
             <a:r>
-              <a:rPr lang="en-US" smtClean="0"/>
+              <a:rPr lang="en-US"/>
               <a:t>Second level</a:t>
             </a:r>
           </a:p>
           <a:p>
             <a:pPr lvl="2"/>
             <a:r>
-              <a:rPr lang="en-US" smtClean="0"/>
+              <a:rPr lang="en-US"/>
               <a:t>Third level</a:t>
             </a:r>
           </a:p>
           <a:p>
             <a:pPr lvl="3"/>
             <a:r>
-              <a:rPr lang="en-US" smtClean="0"/>
+              <a:rPr lang="en-US"/>
               <a:t>Fourth level</a:t>
             </a:r>
           </a:p>
           <a:p>
             <a:pPr lvl="4"/>
             <a:r>
-              <a:rPr lang="en-US" smtClean="0"/>
+              <a:rPr lang="en-US"/>
               <a:t>Fifth level</a:t>
             </a:r>
-            <a:endParaRPr lang="en-US"/>
           </a:p>
         </p:txBody>
       </p:sp>
@@ -463,7 +475,7 @@
           <a:p>
             <a:fld id="{5BCAD085-E8A6-8845-BD4E-CB4CCA059FC4}" type="datetimeFigureOut">
               <a:rPr lang="en-US" smtClean="0"/>
-              <a:t>1/27/13</a:t>
+              <a:t>8/16/2026</a:t>
             </a:fld>
             <a:endParaRPr lang="en-US"/>
           </a:p>
@@ -562,10 +574,9 @@
           <a:lstStyle/>
           <a:p>
             <a:r>
-              <a:rPr lang="en-US" smtClean="0"/>
+              <a:rPr lang="en-US"/>
               <a:t>Click to edit Master title style</a:t>
             </a:r>
-            <a:endParaRPr lang="en-US"/>
           </a:p>
         </p:txBody>
       </p:sp>
@@ -591,38 +602,37 @@
           <a:p>
             <a:pPr lvl="0"/>
             <a:r>
-              <a:rPr lang="en-US" smtClean="0"/>
+              <a:rPr lang="en-US"/>
               <a:t>Click to edit Master text styles</a:t>
             </a:r>
           </a:p>
           <a:p>
             <a:pPr lvl="1"/>
             <a:r>
-              <a:rPr lang="en-US" smtClean="0"/>
+              <a:rPr lang="en-US"/>
               <a:t>Second level</a:t>
             </a:r>
           </a:p>
           <a:p>
             <a:pPr lvl="2"/>
             <a:r>
-              <a:rPr lang="en-US" smtClean="0"/>
+              <a:rPr lang="en-US"/>
               <a:t>Third level</a:t>
             </a:r>
           </a:p>
           <a:p>
             <a:pPr lvl="3"/>
             <a:r>
-              <a:rPr lang="en-US" smtClean="0"/>
+              <a:rPr lang="en-US"/>
               <a:t>Fourth level</a:t>
             </a:r>
           </a:p>
           <a:p>
             <a:pPr lvl="4"/>
             <a:r>
-              <a:rPr lang="en-US" smtClean="0"/>
+              <a:rPr lang="en-US"/>
               <a:t>Fifth level</a:t>
             </a:r>
-            <a:endParaRPr lang="en-US"/>
           </a:p>
         </p:txBody>
       </p:sp>
@@ -643,7 +653,7 @@
           <a:p>
             <a:fld id="{5BCAD085-E8A6-8845-BD4E-CB4CCA059FC4}" type="datetimeFigureOut">
               <a:rPr lang="en-US" smtClean="0"/>
-              <a:t>1/27/13</a:t>
+              <a:t>8/16/2026</a:t>
             </a:fld>
             <a:endParaRPr lang="en-US"/>
           </a:p>
@@ -737,10 +747,9 @@
           <a:lstStyle/>
           <a:p>
             <a:r>
-              <a:rPr lang="en-US" smtClean="0"/>
+              <a:rPr lang="en-US"/>
               <a:t>Click to edit Master title style</a:t>
             </a:r>
-            <a:endParaRPr lang="en-US"/>
           </a:p>
         </p:txBody>
       </p:sp>
@@ -761,38 +770,37 @@
           <a:p>
             <a:pPr lvl="0"/>
             <a:r>
-              <a:rPr lang="en-US" smtClean="0"/>
+              <a:rPr lang="en-US"/>
               <a:t>Click to edit Master text styles</a:t>
             </a:r>
           </a:p>
           <a:p>
             <a:pPr lvl="1"/>
             <a:r>
-              <a:rPr lang="en-US" smtClean="0"/>
+              <a:rPr lang="en-US"/>
               <a:t>Second level</a:t>
             </a:r>
           </a:p>
           <a:p>
             <a:pPr lvl="2"/>
             <a:r>
-              <a:rPr lang="en-US" smtClean="0"/>
+              <a:rPr lang="en-US"/>
               <a:t>Third level</a:t>
             </a:r>
           </a:p>
           <a:p>
             <a:pPr lvl="3"/>
             <a:r>
-              <a:rPr lang="en-US" smtClean="0"/>
+              <a:rPr lang="en-US"/>
               <a:t>Fourth level</a:t>
             </a:r>
           </a:p>
           <a:p>
             <a:pPr lvl="4"/>
             <a:r>
-              <a:rPr lang="en-US" smtClean="0"/>
+              <a:rPr lang="en-US"/>
               <a:t>Fifth level</a:t>
             </a:r>
-            <a:endParaRPr lang="en-US"/>
           </a:p>
         </p:txBody>
       </p:sp>
@@ -813,7 +821,7 @@
           <a:p>
             <a:fld id="{5BCAD085-E8A6-8845-BD4E-CB4CCA059FC4}" type="datetimeFigureOut">
               <a:rPr lang="en-US" smtClean="0"/>
-              <a:t>1/27/13</a:t>
+              <a:t>8/16/2026</a:t>
             </a:fld>
             <a:endParaRPr lang="en-US"/>
           </a:p>
@@ -916,10 +924,9 @@
           </a:lstStyle>
           <a:p>
             <a:r>
-              <a:rPr lang="en-US" smtClean="0"/>
+              <a:rPr lang="en-US"/>
               <a:t>Click to edit Master title style</a:t>
             </a:r>
-            <a:endParaRPr lang="en-US"/>
           </a:p>
         </p:txBody>
       </p:sp>
@@ -1036,7 +1043,7 @@
           <a:p>
             <a:pPr lvl="0"/>
             <a:r>
-              <a:rPr lang="en-US" smtClean="0"/>
+              <a:rPr lang="en-US"/>
               <a:t>Click to edit Master text styles</a:t>
             </a:r>
           </a:p>
@@ -1059,7 +1066,7 @@
           <a:p>
             <a:fld id="{5BCAD085-E8A6-8845-BD4E-CB4CCA059FC4}" type="datetimeFigureOut">
               <a:rPr lang="en-US" smtClean="0"/>
-              <a:t>1/27/13</a:t>
+              <a:t>8/16/2026</a:t>
             </a:fld>
             <a:endParaRPr lang="en-US"/>
           </a:p>
@@ -1153,10 +1160,9 @@
           <a:lstStyle/>
           <a:p>
             <a:r>
-              <a:rPr lang="en-US" smtClean="0"/>
+              <a:rPr lang="en-US"/>
               <a:t>Click to edit Master title style</a:t>
             </a:r>
-            <a:endParaRPr lang="en-US"/>
           </a:p>
         </p:txBody>
       </p:sp>
@@ -1210,38 +1216,37 @@
           <a:p>
             <a:pPr lvl="0"/>
             <a:r>
-              <a:rPr lang="en-US" smtClean="0"/>
+              <a:rPr lang="en-US"/>
               <a:t>Click to edit Master text styles</a:t>
             </a:r>
           </a:p>
           <a:p>
             <a:pPr lvl="1"/>
             <a:r>
-              <a:rPr lang="en-US" smtClean="0"/>
+              <a:rPr lang="en-US"/>
               <a:t>Second level</a:t>
             </a:r>
           </a:p>
           <a:p>
             <a:pPr lvl="2"/>
             <a:r>
-              <a:rPr lang="en-US" smtClean="0"/>
+              <a:rPr lang="en-US"/>
               <a:t>Third level</a:t>
             </a:r>
           </a:p>
           <a:p>
             <a:pPr lvl="3"/>
             <a:r>
-              <a:rPr lang="en-US" smtClean="0"/>
+              <a:rPr lang="en-US"/>
               <a:t>Fourth level</a:t>
             </a:r>
           </a:p>
           <a:p>
             <a:pPr lvl="4"/>
             <a:r>
-              <a:rPr lang="en-US" smtClean="0"/>
+              <a:rPr lang="en-US"/>
               <a:t>Fifth level</a:t>
             </a:r>
-            <a:endParaRPr lang="en-US"/>
           </a:p>
         </p:txBody>
       </p:sp>
@@ -1295,38 +1300,37 @@
           <a:p>
             <a:pPr lvl="0"/>
             <a:r>
-              <a:rPr lang="en-US" smtClean="0"/>
+              <a:rPr lang="en-US"/>
               <a:t>Click to edit Master text styles</a:t>
             </a:r>
           </a:p>
           <a:p>
             <a:pPr lvl="1"/>
             <a:r>
-              <a:rPr lang="en-US" smtClean="0"/>
+              <a:rPr lang="en-US"/>
               <a:t>Second level</a:t>
             </a:r>
           </a:p>
           <a:p>
             <a:pPr lvl="2"/>
             <a:r>
-              <a:rPr lang="en-US" smtClean="0"/>
+              <a:rPr lang="en-US"/>
               <a:t>Third level</a:t>
             </a:r>
           </a:p>
           <a:p>
             <a:pPr lvl="3"/>
             <a:r>
-              <a:rPr lang="en-US" smtClean="0"/>
+              <a:rPr lang="en-US"/>
               <a:t>Fourth level</a:t>
             </a:r>
           </a:p>
           <a:p>
             <a:pPr lvl="4"/>
             <a:r>
-              <a:rPr lang="en-US" smtClean="0"/>
+              <a:rPr lang="en-US"/>
               <a:t>Fifth level</a:t>
             </a:r>
-            <a:endParaRPr lang="en-US"/>
           </a:p>
         </p:txBody>
       </p:sp>
@@ -1347,7 +1351,7 @@
           <a:p>
             <a:fld id="{5BCAD085-E8A6-8845-BD4E-CB4CCA059FC4}" type="datetimeFigureOut">
               <a:rPr lang="en-US" smtClean="0"/>
-              <a:t>1/27/13</a:t>
+              <a:t>8/16/2026</a:t>
             </a:fld>
             <a:endParaRPr lang="en-US"/>
           </a:p>
@@ -1445,10 +1449,9 @@
           </a:lstStyle>
           <a:p>
             <a:r>
-              <a:rPr lang="en-US" smtClean="0"/>
+              <a:rPr lang="en-US"/>
               <a:t>Click to edit Master title style</a:t>
             </a:r>
-            <a:endParaRPr lang="en-US"/>
           </a:p>
         </p:txBody>
       </p:sp>
@@ -1511,7 +1514,7 @@
           <a:p>
             <a:pPr lvl="0"/>
             <a:r>
-              <a:rPr lang="en-US" smtClean="0"/>
+              <a:rPr lang="en-US"/>
               <a:t>Click to edit Master text styles</a:t>
             </a:r>
           </a:p>
@@ -1567,38 +1570,37 @@
           <a:p>
             <a:pPr lvl="0"/>
             <a:r>
-              <a:rPr lang="en-US" smtClean="0"/>
+              <a:rPr lang="en-US"/>
               <a:t>Click to edit Master text styles</a:t>
             </a:r>
           </a:p>
           <a:p>
             <a:pPr lvl="1"/>
             <a:r>
-              <a:rPr lang="en-US" smtClean="0"/>
+              <a:rPr lang="en-US"/>
               <a:t>Second level</a:t>
             </a:r>
           </a:p>
           <a:p>
             <a:pPr lvl="2"/>
             <a:r>
-              <a:rPr lang="en-US" smtClean="0"/>
+              <a:rPr lang="en-US"/>
               <a:t>Third level</a:t>
             </a:r>
           </a:p>
           <a:p>
             <a:pPr lvl="3"/>
             <a:r>
-              <a:rPr lang="en-US" smtClean="0"/>
+              <a:rPr lang="en-US"/>
               <a:t>Fourth level</a:t>
             </a:r>
           </a:p>
           <a:p>
             <a:pPr lvl="4"/>
             <a:r>
-              <a:rPr lang="en-US" smtClean="0"/>
+              <a:rPr lang="en-US"/>
               <a:t>Fifth level</a:t>
             </a:r>
-            <a:endParaRPr lang="en-US"/>
           </a:p>
         </p:txBody>
       </p:sp>
@@ -1661,7 +1663,7 @@
           <a:p>
             <a:pPr lvl="0"/>
             <a:r>
-              <a:rPr lang="en-US" smtClean="0"/>
+              <a:rPr lang="en-US"/>
               <a:t>Click to edit Master text styles</a:t>
             </a:r>
           </a:p>
@@ -1717,38 +1719,37 @@
           <a:p>
             <a:pPr lvl="0"/>
             <a:r>
-              <a:rPr lang="en-US" smtClean="0"/>
+              <a:rPr lang="en-US"/>
               <a:t>Click to edit Master text styles</a:t>
             </a:r>
           </a:p>
           <a:p>
             <a:pPr lvl="1"/>
             <a:r>
-              <a:rPr lang="en-US" smtClean="0"/>
+              <a:rPr lang="en-US"/>
               <a:t>Second level</a:t>
             </a:r>
           </a:p>
           <a:p>
             <a:pPr lvl="2"/>
             <a:r>
-              <a:rPr lang="en-US" smtClean="0"/>
+              <a:rPr lang="en-US"/>
               <a:t>Third level</a:t>
             </a:r>
           </a:p>
           <a:p>
             <a:pPr lvl="3"/>
             <a:r>
-              <a:rPr lang="en-US" smtClean="0"/>
+              <a:rPr lang="en-US"/>
               <a:t>Fourth level</a:t>
             </a:r>
           </a:p>
           <a:p>
             <a:pPr lvl="4"/>
             <a:r>
-              <a:rPr lang="en-US" smtClean="0"/>
+              <a:rPr lang="en-US"/>
               <a:t>Fifth level</a:t>
             </a:r>
-            <a:endParaRPr lang="en-US"/>
           </a:p>
         </p:txBody>
       </p:sp>
@@ -1769,7 +1770,7 @@
           <a:p>
             <a:fld id="{5BCAD085-E8A6-8845-BD4E-CB4CCA059FC4}" type="datetimeFigureOut">
               <a:rPr lang="en-US" smtClean="0"/>
-              <a:t>1/27/13</a:t>
+              <a:t>8/16/2026</a:t>
             </a:fld>
             <a:endParaRPr lang="en-US"/>
           </a:p>
@@ -1863,10 +1864,9 @@
           <a:lstStyle/>
           <a:p>
             <a:r>
-              <a:rPr lang="en-US" smtClean="0"/>
+              <a:rPr lang="en-US"/>
               <a:t>Click to edit Master title style</a:t>
             </a:r>
-            <a:endParaRPr lang="en-US"/>
           </a:p>
         </p:txBody>
       </p:sp>
@@ -1887,7 +1887,7 @@
           <a:p>
             <a:fld id="{5BCAD085-E8A6-8845-BD4E-CB4CCA059FC4}" type="datetimeFigureOut">
               <a:rPr lang="en-US" smtClean="0"/>
-              <a:t>1/27/13</a:t>
+              <a:t>8/16/2026</a:t>
             </a:fld>
             <a:endParaRPr lang="en-US"/>
           </a:p>
@@ -1982,7 +1982,7 @@
           <a:p>
             <a:fld id="{5BCAD085-E8A6-8845-BD4E-CB4CCA059FC4}" type="datetimeFigureOut">
               <a:rPr lang="en-US" smtClean="0"/>
-              <a:t>1/27/13</a:t>
+              <a:t>8/16/2026</a:t>
             </a:fld>
             <a:endParaRPr lang="en-US"/>
           </a:p>
@@ -2085,10 +2085,9 @@
           </a:lstStyle>
           <a:p>
             <a:r>
-              <a:rPr lang="en-US" smtClean="0"/>
+              <a:rPr lang="en-US"/>
               <a:t>Click to edit Master title style</a:t>
             </a:r>
-            <a:endParaRPr lang="en-US"/>
           </a:p>
         </p:txBody>
       </p:sp>
@@ -2142,38 +2141,37 @@
           <a:p>
             <a:pPr lvl="0"/>
             <a:r>
-              <a:rPr lang="en-US" smtClean="0"/>
+              <a:rPr lang="en-US"/>
               <a:t>Click to edit Master text styles</a:t>
             </a:r>
           </a:p>
           <a:p>
             <a:pPr lvl="1"/>
             <a:r>
-              <a:rPr lang="en-US" smtClean="0"/>
+              <a:rPr lang="en-US"/>
               <a:t>Second level</a:t>
             </a:r>
           </a:p>
           <a:p>
             <a:pPr lvl="2"/>
             <a:r>
-              <a:rPr lang="en-US" smtClean="0"/>
+              <a:rPr lang="en-US"/>
               <a:t>Third level</a:t>
             </a:r>
           </a:p>
           <a:p>
             <a:pPr lvl="3"/>
             <a:r>
-              <a:rPr lang="en-US" smtClean="0"/>
+              <a:rPr lang="en-US"/>
               <a:t>Fourth level</a:t>
             </a:r>
           </a:p>
           <a:p>
             <a:pPr lvl="4"/>
             <a:r>
-              <a:rPr lang="en-US" smtClean="0"/>
+              <a:rPr lang="en-US"/>
               <a:t>Fifth level</a:t>
             </a:r>
-            <a:endParaRPr lang="en-US"/>
           </a:p>
         </p:txBody>
       </p:sp>
@@ -2236,7 +2234,7 @@
           <a:p>
             <a:pPr lvl="0"/>
             <a:r>
-              <a:rPr lang="en-US" smtClean="0"/>
+              <a:rPr lang="en-US"/>
               <a:t>Click to edit Master text styles</a:t>
             </a:r>
           </a:p>
@@ -2259,7 +2257,7 @@
           <a:p>
             <a:fld id="{5BCAD085-E8A6-8845-BD4E-CB4CCA059FC4}" type="datetimeFigureOut">
               <a:rPr lang="en-US" smtClean="0"/>
-              <a:t>1/27/13</a:t>
+              <a:t>8/16/2026</a:t>
             </a:fld>
             <a:endParaRPr lang="en-US"/>
           </a:p>
@@ -2362,10 +2360,9 @@
           </a:lstStyle>
           <a:p>
             <a:r>
-              <a:rPr lang="en-US" smtClean="0"/>
+              <a:rPr lang="en-US"/>
               <a:t>Click to edit Master title style</a:t>
             </a:r>
-            <a:endParaRPr lang="en-US"/>
           </a:p>
         </p:txBody>
       </p:sp>
@@ -2489,7 +2486,7 @@
           <a:p>
             <a:pPr lvl="0"/>
             <a:r>
-              <a:rPr lang="en-US" smtClean="0"/>
+              <a:rPr lang="en-US"/>
               <a:t>Click to edit Master text styles</a:t>
             </a:r>
           </a:p>
@@ -2512,7 +2509,7 @@
           <a:p>
             <a:fld id="{5BCAD085-E8A6-8845-BD4E-CB4CCA059FC4}" type="datetimeFigureOut">
               <a:rPr lang="en-US" smtClean="0"/>
-              <a:t>1/27/13</a:t>
+              <a:t>8/16/2026</a:t>
             </a:fld>
             <a:endParaRPr lang="en-US"/>
           </a:p>
@@ -2621,10 +2618,9 @@
           <a:lstStyle/>
           <a:p>
             <a:r>
-              <a:rPr lang="en-US" smtClean="0"/>
+              <a:rPr lang="en-US"/>
               <a:t>Click to edit Master title style</a:t>
             </a:r>
-            <a:endParaRPr lang="en-US"/>
           </a:p>
         </p:txBody>
       </p:sp>
@@ -2655,38 +2651,37 @@
           <a:p>
             <a:pPr lvl="0"/>
             <a:r>
-              <a:rPr lang="en-US" smtClean="0"/>
+              <a:rPr lang="en-US"/>
               <a:t>Click to edit Master text styles</a:t>
             </a:r>
           </a:p>
           <a:p>
             <a:pPr lvl="1"/>
             <a:r>
-              <a:rPr lang="en-US" smtClean="0"/>
+              <a:rPr lang="en-US"/>
               <a:t>Second level</a:t>
             </a:r>
           </a:p>
           <a:p>
             <a:pPr lvl="2"/>
             <a:r>
-              <a:rPr lang="en-US" smtClean="0"/>
+              <a:rPr lang="en-US"/>
               <a:t>Third level</a:t>
             </a:r>
           </a:p>
           <a:p>
             <a:pPr lvl="3"/>
             <a:r>
-              <a:rPr lang="en-US" smtClean="0"/>
+              <a:rPr lang="en-US"/>
               <a:t>Fourth level</a:t>
             </a:r>
           </a:p>
           <a:p>
             <a:pPr lvl="4"/>
             <a:r>
-              <a:rPr lang="en-US" smtClean="0"/>
+              <a:rPr lang="en-US"/>
               <a:t>Fifth level</a:t>
             </a:r>
-            <a:endParaRPr lang="en-US"/>
           </a:p>
         </p:txBody>
       </p:sp>
@@ -2725,7 +2720,7 @@
           <a:p>
             <a:fld id="{5BCAD085-E8A6-8845-BD4E-CB4CCA059FC4}" type="datetimeFigureOut">
               <a:rPr lang="en-US" smtClean="0"/>
-              <a:t>1/27/13</a:t>
+              <a:t>8/16/2026</a:t>
             </a:fld>
             <a:endParaRPr lang="en-US"/>
           </a:p>
@@ -3084,7 +3079,7 @@
 </file>
 
 <file path=ppt/slides/slide1.xml><?xml version="1.0" encoding="utf-8"?>
-<p:sld xmlns:a="http://schemas.openxmlformats.org/drawingml/2006/main" xmlns:p="http://schemas.openxmlformats.org/presentationml/2006/main" xmlns:r="http://schemas.openxmlformats.org/officeDocument/2006/relationships">
+<p:sld xmlns:a="http://schemas.openxmlformats.org/drawingml/2006/main" xmlns:r="http://schemas.openxmlformats.org/officeDocument/2006/relationships" xmlns:p="http://schemas.openxmlformats.org/presentationml/2006/main">
   <p:cSld>
     <p:bg>
       <p:bgPr>
@@ -3100,7 +3095,14 @@
         <p:cNvGrpSpPr/>
         <p:nvPr/>
       </p:nvGrpSpPr>
-      <p:grpSpPr/>
+      <p:grpSpPr>
+        <a:xfrm>
+          <a:off x="0" y="0"/>
+          <a:ext cx="0" cy="0"/>
+          <a:chOff x="0" y="0"/>
+          <a:chExt cx="0" cy="0"/>
+        </a:xfrm>
+      </p:grpSpPr>
       <p:sp>
         <p:nvSpPr>
           <p:cNvPr id="2" name="Rectangle 1"/>
@@ -3142,6 +3144,7 @@
           <a:lstStyle/>
           <a:p>
             <a:pPr algn="ctr"/>
+            <a:endParaRPr/>
           </a:p>
         </p:txBody>
       </p:sp>
@@ -3162,7 +3165,7 @@
           <a:noFill/>
         </p:spPr>
         <p:txBody>
-          <a:bodyPr wrap="square" lIns="0" rIns="0" tIns="0" bIns="0">
+          <a:bodyPr wrap="square" lIns="0" tIns="0" rIns="0" bIns="0">
             <a:spAutoFit/>
           </a:bodyPr>
           <a:lstStyle/>
@@ -3201,7 +3204,7 @@
           <a:noFill/>
         </p:spPr>
         <p:txBody>
-          <a:bodyPr wrap="square" lIns="0" rIns="0" tIns="0" bIns="0">
+          <a:bodyPr wrap="square" lIns="0" tIns="0" rIns="0" bIns="0">
             <a:spAutoFit/>
           </a:bodyPr>
           <a:lstStyle/>
@@ -3221,7 +3224,7 @@
                 </a:solidFill>
                 <a:latin typeface="Calibri"/>
               </a:rPr>
-              <a:t>Beaten by Eighteen Features</a:t>
+              <a:t>Beaten by a Cheap Surface Classifier</a:t>
             </a:r>
           </a:p>
           <a:p>
@@ -3286,6 +3289,7 @@
           <a:lstStyle/>
           <a:p>
             <a:pPr algn="ctr"/>
+            <a:endParaRPr/>
           </a:p>
         </p:txBody>
       </p:sp>
@@ -3306,7 +3310,7 @@
           <a:noFill/>
         </p:spPr>
         <p:txBody>
-          <a:bodyPr wrap="square" lIns="0" rIns="0" tIns="0" bIns="0">
+          <a:bodyPr wrap="square" lIns="0" tIns="0" rIns="0" bIns="0">
             <a:spAutoFit/>
           </a:bodyPr>
           <a:lstStyle/>
@@ -3320,13 +3324,31 @@
               </a:spcAft>
             </a:pPr>
             <a:r>
-              <a:rPr sz="2100" b="0">
+              <a:rPr sz="2100" b="0" dirty="0">
                 <a:solidFill>
                   <a:srgbClr val="98A3B0"/>
                 </a:solidFill>
                 <a:latin typeface="Calibri"/>
               </a:rPr>
-              <a:t>Does behavioural self-prediction provide information unavailable to an external observer?</a:t>
+              <a:t>Does </a:t>
+            </a:r>
+            <a:r>
+              <a:rPr sz="2100" b="0" dirty="0" err="1">
+                <a:solidFill>
+                  <a:srgbClr val="98A3B0"/>
+                </a:solidFill>
+                <a:latin typeface="Calibri"/>
+              </a:rPr>
+              <a:t>behavioural</a:t>
+            </a:r>
+            <a:r>
+              <a:rPr sz="2100" b="0" dirty="0">
+                <a:solidFill>
+                  <a:srgbClr val="98A3B0"/>
+                </a:solidFill>
+                <a:latin typeface="Calibri"/>
+              </a:rPr>
+              <a:t> self-prediction provide information unavailable to an external observer?</a:t>
             </a:r>
           </a:p>
         </p:txBody>
@@ -3348,7 +3370,7 @@
           <a:noFill/>
         </p:spPr>
         <p:txBody>
-          <a:bodyPr wrap="square" lIns="0" rIns="0" tIns="0" bIns="0">
+          <a:bodyPr wrap="square" lIns="0" tIns="0" rIns="0" bIns="0">
             <a:spAutoFit/>
           </a:bodyPr>
           <a:lstStyle/>
@@ -3425,7 +3447,7 @@
           <a:noFill/>
         </p:spPr>
         <p:txBody>
-          <a:bodyPr wrap="square" lIns="0" rIns="0" tIns="0" bIns="0">
+          <a:bodyPr wrap="square" lIns="0" tIns="0" rIns="0" bIns="0">
             <a:spAutoFit/>
           </a:bodyPr>
           <a:lstStyle/>
@@ -3436,7 +3458,7 @@
               </a:spcAft>
             </a:pPr>
             <a:r>
-              <a:rPr sz="1600" b="1">
+              <a:rPr sz="1600" b="1" dirty="0">
                 <a:solidFill>
                   <a:srgbClr val="E9EEF4"/>
                 </a:solidFill>
@@ -3455,7 +3477,7 @@
               </a:spcAft>
             </a:pPr>
             <a:r>
-              <a:rPr sz="1200" b="0">
+              <a:rPr sz="1200" b="0" dirty="0">
                 <a:solidFill>
                   <a:srgbClr val="98A3B0"/>
                 </a:solidFill>
@@ -3474,7 +3496,7 @@
               </a:spcAft>
             </a:pPr>
             <a:r>
-              <a:rPr sz="1200" b="0">
+              <a:rPr sz="1200" b="0" dirty="0">
                 <a:solidFill>
                   <a:srgbClr val="98A3B0"/>
                 </a:solidFill>
@@ -3502,7 +3524,7 @@
           <a:noFill/>
         </p:spPr>
         <p:txBody>
-          <a:bodyPr wrap="square" lIns="0" rIns="0" tIns="0" bIns="0">
+          <a:bodyPr wrap="square" lIns="0" tIns="0" rIns="0" bIns="0">
             <a:spAutoFit/>
           </a:bodyPr>
           <a:lstStyle/>
@@ -3513,7 +3535,7 @@
               </a:spcAft>
             </a:pPr>
             <a:r>
-              <a:rPr sz="1300" b="1">
+              <a:rPr sz="1300" b="1" dirty="0">
                 <a:solidFill>
                   <a:srgbClr val="F0C040"/>
                 </a:solidFill>
@@ -3529,14 +3551,47 @@
               </a:spcAft>
             </a:pPr>
             <a:r>
-              <a:rPr sz="1150" b="0">
+              <a:rPr sz="1150" b="0" dirty="0">
                 <a:solidFill>
                   <a:srgbClr val="98A3B0"/>
                 </a:solidFill>
                 <a:latin typeface="Consolas"/>
               </a:rPr>
-              <a:t>github.com/UbaJaz/Digital_Minds_Research</a:t>
-            </a:r>
+              <a:t>github.com/</a:t>
+            </a:r>
+            <a:r>
+              <a:rPr sz="1150" b="0" dirty="0" err="1">
+                <a:solidFill>
+                  <a:srgbClr val="98A3B0"/>
+                </a:solidFill>
+                <a:latin typeface="Consolas"/>
+              </a:rPr>
+              <a:t>UbaJaz</a:t>
+            </a:r>
+            <a:r>
+              <a:rPr sz="1150" b="0" dirty="0">
+                <a:solidFill>
+                  <a:srgbClr val="98A3B0"/>
+                </a:solidFill>
+                <a:latin typeface="Consolas"/>
+              </a:rPr>
+              <a:t>/</a:t>
+            </a:r>
+            <a:r>
+              <a:rPr sz="1150" b="0" dirty="0" err="1">
+                <a:solidFill>
+                  <a:srgbClr val="98A3B0"/>
+                </a:solidFill>
+                <a:latin typeface="Consolas"/>
+              </a:rPr>
+              <a:t>Digital_Minds_Research</a:t>
+            </a:r>
+            <a:endParaRPr sz="1150" b="0" dirty="0">
+              <a:solidFill>
+                <a:srgbClr val="98A3B0"/>
+              </a:solidFill>
+              <a:latin typeface="Consolas"/>
+            </a:endParaRPr>
           </a:p>
         </p:txBody>
       </p:sp>
@@ -3581,6 +3636,7 @@
           <a:lstStyle/>
           <a:p>
             <a:pPr algn="ctr"/>
+            <a:endParaRPr/>
           </a:p>
         </p:txBody>
       </p:sp>
@@ -3601,7 +3657,7 @@
           <a:noFill/>
         </p:spPr>
         <p:txBody>
-          <a:bodyPr wrap="square" lIns="0" rIns="0" tIns="0" bIns="0">
+          <a:bodyPr wrap="square" lIns="0" tIns="0" rIns="0" bIns="0">
             <a:spAutoFit/>
           </a:bodyPr>
           <a:lstStyle/>
@@ -3630,7 +3686,7 @@
                 </a:solidFill>
                 <a:latin typeface="Consolas"/>
               </a:rPr>
-              <a:t>  /  6     Beaten by Eighteen Features</a:t>
+              <a:t>  /  6     Beaten by a Cheap Surface Classifier</a:t>
             </a:r>
           </a:p>
         </p:txBody>
@@ -3644,7 +3700,7 @@
 </file>
 
 <file path=ppt/slides/slide2.xml><?xml version="1.0" encoding="utf-8"?>
-<p:sld xmlns:a="http://schemas.openxmlformats.org/drawingml/2006/main" xmlns:p="http://schemas.openxmlformats.org/presentationml/2006/main" xmlns:r="http://schemas.openxmlformats.org/officeDocument/2006/relationships">
+<p:sld xmlns:a="http://schemas.openxmlformats.org/drawingml/2006/main" xmlns:r="http://schemas.openxmlformats.org/officeDocument/2006/relationships" xmlns:p="http://schemas.openxmlformats.org/presentationml/2006/main">
   <p:cSld>
     <p:bg>
       <p:bgPr>
@@ -3660,7 +3716,14 @@
         <p:cNvGrpSpPr/>
         <p:nvPr/>
       </p:nvGrpSpPr>
-      <p:grpSpPr/>
+      <p:grpSpPr>
+        <a:xfrm>
+          <a:off x="0" y="0"/>
+          <a:ext cx="0" cy="0"/>
+          <a:chOff x="0" y="0"/>
+          <a:chExt cx="0" cy="0"/>
+        </a:xfrm>
+      </p:grpSpPr>
       <p:sp>
         <p:nvSpPr>
           <p:cNvPr id="2" name="TextBox 1"/>
@@ -3678,7 +3741,7 @@
           <a:noFill/>
         </p:spPr>
         <p:txBody>
-          <a:bodyPr wrap="square" lIns="0" rIns="0" tIns="0" bIns="0">
+          <a:bodyPr wrap="square" lIns="0" tIns="0" rIns="0" bIns="0">
             <a:spAutoFit/>
           </a:bodyPr>
           <a:lstStyle/>
@@ -3717,7 +3780,7 @@
           <a:noFill/>
         </p:spPr>
         <p:txBody>
-          <a:bodyPr wrap="square" lIns="0" rIns="0" tIns="0" bIns="0">
+          <a:bodyPr wrap="square" lIns="0" tIns="0" rIns="0" bIns="0">
             <a:spAutoFit/>
           </a:bodyPr>
           <a:lstStyle/>
@@ -3759,7 +3822,7 @@
           <a:noFill/>
         </p:spPr>
         <p:txBody>
-          <a:bodyPr wrap="square" lIns="0" rIns="0" tIns="0" bIns="0">
+          <a:bodyPr wrap="square" lIns="0" tIns="0" rIns="0" bIns="0">
             <a:spAutoFit/>
           </a:bodyPr>
           <a:lstStyle/>
@@ -3836,6 +3899,7 @@
           <a:lstStyle/>
           <a:p>
             <a:pPr algn="ctr"/>
+            <a:endParaRPr/>
           </a:p>
         </p:txBody>
       </p:sp>
@@ -3856,7 +3920,7 @@
           <a:noFill/>
         </p:spPr>
         <p:txBody>
-          <a:bodyPr wrap="square" lIns="0" rIns="0" tIns="0" bIns="0">
+          <a:bodyPr wrap="square" lIns="0" tIns="0" rIns="0" bIns="0">
             <a:spAutoFit/>
           </a:bodyPr>
           <a:lstStyle/>
@@ -3907,7 +3971,7 @@
           <a:noFill/>
         </p:spPr>
         <p:txBody>
-          <a:bodyPr wrap="square" lIns="0" rIns="0" tIns="0" bIns="0">
+          <a:bodyPr wrap="square" lIns="0" tIns="0" rIns="0" bIns="0">
             <a:spAutoFit/>
           </a:bodyPr>
           <a:lstStyle/>
@@ -4010,6 +4074,7 @@
           <a:lstStyle/>
           <a:p>
             <a:pPr algn="ctr"/>
+            <a:endParaRPr/>
           </a:p>
         </p:txBody>
       </p:sp>
@@ -4030,7 +4095,7 @@
           <a:noFill/>
         </p:spPr>
         <p:txBody>
-          <a:bodyPr wrap="square" lIns="0" rIns="0" tIns="0" bIns="0">
+          <a:bodyPr wrap="square" lIns="0" tIns="0" rIns="0" bIns="0">
             <a:spAutoFit/>
           </a:bodyPr>
           <a:lstStyle/>
@@ -4044,7 +4109,7 @@
               </a:spcAft>
             </a:pPr>
             <a:r>
-              <a:rPr sz="2000" b="1">
+              <a:rPr sz="2000" b="1" dirty="0">
                 <a:solidFill>
                   <a:srgbClr val="4A90D9"/>
                 </a:solidFill>
@@ -4053,7 +4118,7 @@
               <a:t>N   </a:t>
             </a:r>
             <a:r>
-              <a:rPr sz="1000" b="1">
+              <a:rPr sz="1000" b="1" dirty="0">
                 <a:solidFill>
                   <a:srgbClr val="6B7683"/>
                 </a:solidFill>
@@ -4081,7 +4146,7 @@
           <a:noFill/>
         </p:spPr>
         <p:txBody>
-          <a:bodyPr wrap="square" lIns="0" rIns="0" tIns="0" bIns="0">
+          <a:bodyPr wrap="square" lIns="0" tIns="0" rIns="0" bIns="0">
             <a:spAutoFit/>
           </a:bodyPr>
           <a:lstStyle/>
@@ -4184,6 +4249,7 @@
           <a:lstStyle/>
           <a:p>
             <a:pPr algn="ctr"/>
+            <a:endParaRPr/>
           </a:p>
         </p:txBody>
       </p:sp>
@@ -4204,7 +4270,7 @@
           <a:noFill/>
         </p:spPr>
         <p:txBody>
-          <a:bodyPr wrap="square" lIns="0" rIns="0" tIns="0" bIns="0">
+          <a:bodyPr wrap="square" lIns="0" tIns="0" rIns="0" bIns="0">
             <a:spAutoFit/>
           </a:bodyPr>
           <a:lstStyle/>
@@ -4255,7 +4321,7 @@
           <a:noFill/>
         </p:spPr>
         <p:txBody>
-          <a:bodyPr wrap="square" lIns="0" rIns="0" tIns="0" bIns="0">
+          <a:bodyPr wrap="square" lIns="0" tIns="0" rIns="0" bIns="0">
             <a:spAutoFit/>
           </a:bodyPr>
           <a:lstStyle/>
@@ -4323,7 +4389,7 @@
         </p:nvSpPr>
         <p:spPr>
           <a:xfrm>
-            <a:off x="8110728" y="1993392"/>
+            <a:off x="8906256" y="2024549"/>
             <a:ext cx="4023360" cy="256032"/>
           </a:xfrm>
           <a:prstGeom prst="rect">
@@ -4332,7 +4398,7 @@
           <a:noFill/>
         </p:spPr>
         <p:txBody>
-          <a:bodyPr wrap="square" lIns="0" rIns="0" tIns="0" bIns="0">
+          <a:bodyPr wrap="square" lIns="0" tIns="0" rIns="0" bIns="0">
             <a:spAutoFit/>
           </a:bodyPr>
           <a:lstStyle/>
@@ -4343,7 +4409,7 @@
               </a:spcAft>
             </a:pPr>
             <a:r>
-              <a:rPr sz="1050" b="1" spc="120">
+              <a:rPr sz="1050" b="1" spc="120" dirty="0">
                 <a:solidFill>
                   <a:srgbClr val="F0C040"/>
                 </a:solidFill>
@@ -4371,7 +4437,7 @@
           <a:noFill/>
         </p:spPr>
         <p:txBody>
-          <a:bodyPr wrap="square" lIns="0" rIns="0" tIns="0" bIns="0">
+          <a:bodyPr wrap="square" lIns="0" tIns="0" rIns="0" bIns="0">
             <a:spAutoFit/>
           </a:bodyPr>
           <a:lstStyle/>
@@ -4410,7 +4476,7 @@
           <a:noFill/>
         </p:spPr>
         <p:txBody>
-          <a:bodyPr wrap="square" lIns="0" rIns="0" tIns="0" bIns="0">
+          <a:bodyPr wrap="square" lIns="0" tIns="0" rIns="0" bIns="0">
             <a:spAutoFit/>
           </a:bodyPr>
           <a:lstStyle/>
@@ -4471,7 +4537,7 @@
           </a:fontRef>
         </p:style>
         <p:txBody>
-          <a:bodyPr rtlCol="0" anchor="ctr" lIns="0" rIns="0" tIns="0" bIns="0"/>
+          <a:bodyPr lIns="0" tIns="0" rIns="0" bIns="0" rtlCol="0" anchor="ctr"/>
           <a:lstStyle/>
           <a:p>
             <a:pPr algn="ctr">
@@ -4530,7 +4596,7 @@
           </a:fontRef>
         </p:style>
         <p:txBody>
-          <a:bodyPr rtlCol="0" anchor="ctr" lIns="0" rIns="0" tIns="0" bIns="0"/>
+          <a:bodyPr lIns="0" tIns="0" rIns="0" bIns="0" rtlCol="0" anchor="ctr"/>
           <a:lstStyle/>
           <a:p>
             <a:pPr algn="ctr">
@@ -4567,7 +4633,7 @@
           <a:noFill/>
         </p:spPr>
         <p:txBody>
-          <a:bodyPr wrap="square" lIns="0" rIns="0" tIns="0" bIns="0">
+          <a:bodyPr wrap="square" lIns="0" tIns="0" rIns="0" bIns="0">
             <a:spAutoFit/>
           </a:bodyPr>
           <a:lstStyle/>
@@ -4628,7 +4694,7 @@
           </a:fontRef>
         </p:style>
         <p:txBody>
-          <a:bodyPr rtlCol="0" anchor="ctr" lIns="0" rIns="0" tIns="0" bIns="0"/>
+          <a:bodyPr lIns="0" tIns="0" rIns="0" bIns="0" rtlCol="0" anchor="ctr"/>
           <a:lstStyle/>
           <a:p>
             <a:pPr algn="ctr">
@@ -4687,7 +4753,7 @@
           </a:fontRef>
         </p:style>
         <p:txBody>
-          <a:bodyPr rtlCol="0" anchor="ctr" lIns="0" rIns="0" tIns="0" bIns="0"/>
+          <a:bodyPr lIns="0" tIns="0" rIns="0" bIns="0" rtlCol="0" anchor="ctr"/>
           <a:lstStyle/>
           <a:p>
             <a:pPr algn="ctr">
@@ -4724,7 +4790,7 @@
           <a:noFill/>
         </p:spPr>
         <p:txBody>
-          <a:bodyPr wrap="square" lIns="0" rIns="0" tIns="0" bIns="0">
+          <a:bodyPr wrap="square" lIns="0" tIns="0" rIns="0" bIns="0">
             <a:spAutoFit/>
           </a:bodyPr>
           <a:lstStyle/>
@@ -4785,7 +4851,7 @@
           </a:fontRef>
         </p:style>
         <p:txBody>
-          <a:bodyPr rtlCol="0" anchor="ctr" lIns="0" rIns="0" tIns="0" bIns="0"/>
+          <a:bodyPr lIns="0" tIns="0" rIns="0" bIns="0" rtlCol="0" anchor="ctr"/>
           <a:lstStyle/>
           <a:p>
             <a:pPr algn="ctr">
@@ -4844,7 +4910,7 @@
           </a:fontRef>
         </p:style>
         <p:txBody>
-          <a:bodyPr rtlCol="0" anchor="ctr" lIns="0" rIns="0" tIns="0" bIns="0"/>
+          <a:bodyPr lIns="0" tIns="0" rIns="0" bIns="0" rtlCol="0" anchor="ctr"/>
           <a:lstStyle/>
           <a:p>
             <a:pPr algn="ctr">
@@ -4872,7 +4938,7 @@
         </p:nvSpPr>
         <p:spPr>
           <a:xfrm>
-            <a:off x="8110728" y="3822192"/>
+            <a:off x="8140903" y="3822192"/>
             <a:ext cx="3392424" cy="384048"/>
           </a:xfrm>
           <a:prstGeom prst="rect">
@@ -4907,6 +4973,7 @@
           <a:lstStyle/>
           <a:p>
             <a:pPr algn="ctr"/>
+            <a:endParaRPr/>
           </a:p>
         </p:txBody>
       </p:sp>
@@ -4918,7 +4985,7 @@
         </p:nvSpPr>
         <p:spPr>
           <a:xfrm>
-            <a:off x="8238744" y="3913632"/>
+            <a:off x="8339328" y="3874685"/>
             <a:ext cx="3200400" cy="274320"/>
           </a:xfrm>
           <a:prstGeom prst="rect">
@@ -4927,7 +4994,7 @@
           <a:noFill/>
         </p:spPr>
         <p:txBody>
-          <a:bodyPr wrap="square" lIns="0" rIns="0" tIns="0" bIns="0">
+          <a:bodyPr wrap="square" lIns="0" tIns="0" rIns="0" bIns="0">
             <a:spAutoFit/>
           </a:bodyPr>
           <a:lstStyle/>
@@ -4941,7 +5008,7 @@
               </a:spcAft>
             </a:pPr>
             <a:r>
-              <a:rPr sz="1200" b="1">
+              <a:rPr sz="1200" b="1" dirty="0">
                 <a:solidFill>
                   <a:srgbClr val="F0C040"/>
                 </a:solidFill>
@@ -4950,7 +5017,7 @@
               <a:t>D  </a:t>
             </a:r>
             <a:r>
-              <a:rPr sz="1150" b="0">
+              <a:rPr sz="1150" b="0" dirty="0">
                 <a:solidFill>
                   <a:srgbClr val="E9EEF4"/>
                 </a:solidFill>
@@ -4978,7 +5045,7 @@
           <a:noFill/>
         </p:spPr>
         <p:txBody>
-          <a:bodyPr wrap="square" lIns="0" rIns="0" tIns="0" bIns="0">
+          <a:bodyPr wrap="square" lIns="0" tIns="0" rIns="0" bIns="0">
             <a:spAutoFit/>
           </a:bodyPr>
           <a:lstStyle/>
@@ -4992,7 +5059,7 @@
               </a:spcAft>
             </a:pPr>
             <a:r>
-              <a:rPr sz="1400" b="1">
+              <a:rPr sz="1400" b="1" dirty="0">
                 <a:solidFill>
                   <a:srgbClr val="4A9B4A"/>
                 </a:solidFill>
@@ -5001,7 +5068,7 @@
               <a:t>Capability cancels. </a:t>
             </a:r>
             <a:r>
-              <a:rPr sz="1400" b="0">
+              <a:rPr sz="1400" b="0" dirty="0">
                 <a:solidFill>
                   <a:srgbClr val="98A3B0"/>
                 </a:solidFill>
@@ -5010,7 +5077,7 @@
               <a:t>An additive competence edge appears in both of M's cells, so it drops out of the interaction  </a:t>
             </a:r>
             <a:r>
-              <a:rPr sz="1300" b="1">
+              <a:rPr sz="1300" b="1" dirty="0">
                 <a:solidFill>
                   <a:srgbClr val="E9EEF4"/>
                 </a:solidFill>
@@ -5019,7 +5086,7 @@
               <a:t>(M→M − N→M) − (M→N − N→N)</a:t>
             </a:r>
             <a:r>
-              <a:rPr sz="1400" b="0">
+              <a:rPr sz="1400" b="0" dirty="0">
                 <a:solidFill>
                   <a:srgbClr val="98A3B0"/>
                 </a:solidFill>
@@ -5038,7 +5105,7 @@
               </a:spcAft>
             </a:pPr>
             <a:r>
-              <a:rPr sz="1400" b="1">
+              <a:rPr sz="1400" b="1" dirty="0">
                 <a:solidFill>
                   <a:srgbClr val="F0C040"/>
                 </a:solidFill>
@@ -5047,7 +5114,7 @@
               <a:t>Leakage becomes the variable. </a:t>
             </a:r>
             <a:r>
-              <a:rPr sz="1400" b="0">
+              <a:rPr sz="1400" b="0" dirty="0">
                 <a:solidFill>
                   <a:srgbClr val="98A3B0"/>
                 </a:solidFill>
@@ -5056,7 +5123,7 @@
               <a:t>Four stimulus constructions on one shared 200-prompt pool, spanning surface baselines 0.54–0.85, with D fit per target column and gated on </a:t>
             </a:r>
             <a:r>
-              <a:rPr sz="1400" b="1">
+              <a:rPr sz="1400" b="1" dirty="0">
                 <a:solidFill>
                   <a:srgbClr val="E9EEF4"/>
                 </a:solidFill>
@@ -5065,7 +5132,7 @@
               <a:t>before</a:t>
             </a:r>
             <a:r>
-              <a:rPr sz="1400" b="0">
+              <a:rPr sz="1400" b="0" dirty="0">
                 <a:solidFill>
                   <a:srgbClr val="98A3B0"/>
                 </a:solidFill>
@@ -5084,7 +5151,7 @@
               </a:spcAft>
             </a:pPr>
             <a:r>
-              <a:rPr sz="1400" b="1">
+              <a:rPr sz="1400" b="1" dirty="0">
                 <a:solidFill>
                   <a:srgbClr val="4A90D9"/>
                 </a:solidFill>
@@ -5093,7 +5160,7 @@
               <a:t>The criterion. </a:t>
             </a:r>
             <a:r>
-              <a:rPr sz="1400" b="0">
+              <a:rPr sz="1400" b="0" dirty="0">
                 <a:solidFill>
                   <a:srgbClr val="98A3B0"/>
                 </a:solidFill>
@@ -5145,6 +5212,7 @@
           <a:lstStyle/>
           <a:p>
             <a:pPr algn="ctr"/>
+            <a:endParaRPr/>
           </a:p>
         </p:txBody>
       </p:sp>
@@ -5165,7 +5233,7 @@
           <a:noFill/>
         </p:spPr>
         <p:txBody>
-          <a:bodyPr wrap="square" lIns="0" rIns="0" tIns="0" bIns="0">
+          <a:bodyPr wrap="square" lIns="0" tIns="0" rIns="0" bIns="0">
             <a:spAutoFit/>
           </a:bodyPr>
           <a:lstStyle/>
@@ -5240,6 +5308,7 @@
           <a:lstStyle/>
           <a:p>
             <a:pPr algn="ctr"/>
+            <a:endParaRPr/>
           </a:p>
         </p:txBody>
       </p:sp>
@@ -5260,7 +5329,7 @@
           <a:noFill/>
         </p:spPr>
         <p:txBody>
-          <a:bodyPr wrap="square" lIns="0" rIns="0" tIns="0" bIns="0">
+          <a:bodyPr wrap="square" lIns="0" tIns="0" rIns="0" bIns="0">
             <a:spAutoFit/>
           </a:bodyPr>
           <a:lstStyle/>
@@ -5303,7 +5372,7 @@
 </file>
 
 <file path=ppt/slides/slide3.xml><?xml version="1.0" encoding="utf-8"?>
-<p:sld xmlns:a="http://schemas.openxmlformats.org/drawingml/2006/main" xmlns:p="http://schemas.openxmlformats.org/presentationml/2006/main" xmlns:r="http://schemas.openxmlformats.org/officeDocument/2006/relationships">
+<p:sld xmlns:a="http://schemas.openxmlformats.org/drawingml/2006/main" xmlns:r="http://schemas.openxmlformats.org/officeDocument/2006/relationships" xmlns:p="http://schemas.openxmlformats.org/presentationml/2006/main">
   <p:cSld>
     <p:bg>
       <p:bgPr>
@@ -5319,7 +5388,14 @@
         <p:cNvGrpSpPr/>
         <p:nvPr/>
       </p:nvGrpSpPr>
-      <p:grpSpPr/>
+      <p:grpSpPr>
+        <a:xfrm>
+          <a:off x="0" y="0"/>
+          <a:ext cx="0" cy="0"/>
+          <a:chOff x="0" y="0"/>
+          <a:chExt cx="0" cy="0"/>
+        </a:xfrm>
+      </p:grpSpPr>
       <p:sp>
         <p:nvSpPr>
           <p:cNvPr id="2" name="TextBox 1"/>
@@ -5337,7 +5413,7 @@
           <a:noFill/>
         </p:spPr>
         <p:txBody>
-          <a:bodyPr wrap="square" lIns="0" rIns="0" tIns="0" bIns="0">
+          <a:bodyPr wrap="square" lIns="0" tIns="0" rIns="0" bIns="0">
             <a:spAutoFit/>
           </a:bodyPr>
           <a:lstStyle/>
@@ -5376,7 +5452,7 @@
           <a:noFill/>
         </p:spPr>
         <p:txBody>
-          <a:bodyPr wrap="square" lIns="0" rIns="0" tIns="0" bIns="0">
+          <a:bodyPr wrap="square" lIns="0" tIns="0" rIns="0" bIns="0">
             <a:spAutoFit/>
           </a:bodyPr>
           <a:lstStyle/>
@@ -5442,6 +5518,7 @@
           <a:lstStyle/>
           <a:p>
             <a:pPr algn="ctr"/>
+            <a:endParaRPr/>
           </a:p>
         </p:txBody>
       </p:sp>
@@ -5478,7 +5555,7 @@
         <p:spPr>
           <a:xfrm>
             <a:off x="6903720" y="1700784"/>
-            <a:ext cx="4572000" cy="1005840"/>
+            <a:ext cx="4572000" cy="960120"/>
           </a:xfrm>
           <a:prstGeom prst="rect">
             <a:avLst/>
@@ -5486,7 +5563,7 @@
           <a:noFill/>
         </p:spPr>
         <p:txBody>
-          <a:bodyPr wrap="square" lIns="0" rIns="0" tIns="0" bIns="0">
+          <a:bodyPr wrap="square" lIns="0" tIns="0" rIns="0" bIns="0">
             <a:spAutoFit/>
           </a:bodyPr>
           <a:lstStyle/>
@@ -5522,7 +5599,7 @@
                 </a:solidFill>
                 <a:latin typeface="Calibri"/>
               </a:rPr>
-              <a:t>correlation between self-prediction accuracy and the 18-feature surface baseline, across ten columns</a:t>
+              <a:t>correlation between self-prediction accuracy and the 21-feature surface/textual baseline, across ten columns</a:t>
             </a:r>
           </a:p>
         </p:txBody>
@@ -5535,8 +5612,8 @@
         </p:nvSpPr>
         <p:spPr>
           <a:xfrm>
-            <a:off x="6903720" y="2779776"/>
-            <a:ext cx="4572000" cy="1005840"/>
+            <a:off x="6903720" y="2688336"/>
+            <a:ext cx="4572000" cy="960120"/>
           </a:xfrm>
           <a:prstGeom prst="rect">
             <a:avLst/>
@@ -5544,7 +5621,7 @@
           <a:noFill/>
         </p:spPr>
         <p:txBody>
-          <a:bodyPr wrap="square" lIns="0" rIns="0" tIns="0" bIns="0">
+          <a:bodyPr wrap="square" lIns="0" tIns="0" rIns="0" bIns="0">
             <a:spAutoFit/>
           </a:bodyPr>
           <a:lstStyle/>
@@ -5593,8 +5670,8 @@
         </p:nvSpPr>
         <p:spPr>
           <a:xfrm>
-            <a:off x="6903720" y="3858768"/>
-            <a:ext cx="4572000" cy="1005840"/>
+            <a:off x="6903720" y="3675888"/>
+            <a:ext cx="4572000" cy="960120"/>
           </a:xfrm>
           <a:prstGeom prst="rect">
             <a:avLst/>
@@ -5602,7 +5679,7 @@
           <a:noFill/>
         </p:spPr>
         <p:txBody>
-          <a:bodyPr wrap="square" lIns="0" rIns="0" tIns="0" bIns="0">
+          <a:bodyPr wrap="square" lIns="0" tIns="0" rIns="0" bIns="0">
             <a:spAutoFit/>
           </a:bodyPr>
           <a:lstStyle/>
@@ -5645,14 +5722,56 @@
       </p:sp>
       <p:sp>
         <p:nvSpPr>
-          <p:cNvPr id="9" name="Rectangle 8"/>
+          <p:cNvPr id="9" name="TextBox 8"/>
+          <p:cNvSpPr txBox="1"/>
+          <p:nvPr/>
+        </p:nvSpPr>
+        <p:spPr>
+          <a:xfrm>
+            <a:off x="6903720" y="4645152"/>
+            <a:ext cx="4617720" cy="384048"/>
+          </a:xfrm>
+          <a:prstGeom prst="rect">
+            <a:avLst/>
+          </a:prstGeom>
+          <a:noFill/>
+        </p:spPr>
+        <p:txBody>
+          <a:bodyPr wrap="square" lIns="0" tIns="0" rIns="0" bIns="0">
+            <a:spAutoFit/>
+          </a:bodyPr>
+          <a:lstStyle/>
+          <a:p>
+            <a:pPr algn="l">
+              <a:lnSpc>
+                <a:spcPct val="120000"/>
+              </a:lnSpc>
+              <a:spcAft>
+                <a:spcPts val="800"/>
+              </a:spcAft>
+            </a:pPr>
+            <a:r>
+              <a:rPr sz="1150" b="0">
+                <a:solidFill>
+                  <a:srgbClr val="6B7683"/>
+                </a:solidFill>
+                <a:latin typeface="Calibri"/>
+              </a:rPr>
+              <a:t>21 textual features: 18 structural/style + 3 preregistered persona-linked lexical rates</a:t>
+            </a:r>
+          </a:p>
+        </p:txBody>
+      </p:sp>
+      <p:sp>
+        <p:nvSpPr>
+          <p:cNvPr id="10" name="Rectangle 9"/>
           <p:cNvSpPr/>
           <p:nvPr/>
         </p:nvSpPr>
         <p:spPr>
           <a:xfrm>
-            <a:off x="6903720" y="4974336"/>
-            <a:ext cx="4617720" cy="1188720"/>
+            <a:off x="6903720" y="5111495"/>
+            <a:ext cx="4617720" cy="1115568"/>
           </a:xfrm>
           <a:prstGeom prst="rect">
             <a:avLst/>
@@ -5686,57 +5805,7 @@
           <a:lstStyle/>
           <a:p>
             <a:pPr algn="ctr"/>
-          </a:p>
-        </p:txBody>
-      </p:sp>
-      <p:sp>
-        <p:nvSpPr>
-          <p:cNvPr id="10" name="TextBox 9"/>
-          <p:cNvSpPr txBox="1"/>
-          <p:nvPr/>
-        </p:nvSpPr>
-        <p:spPr>
-          <a:xfrm>
-            <a:off x="7068312" y="5102352"/>
-            <a:ext cx="4297680" cy="960120"/>
-          </a:xfrm>
-          <a:prstGeom prst="rect">
-            <a:avLst/>
-          </a:prstGeom>
-          <a:noFill/>
-        </p:spPr>
-        <p:txBody>
-          <a:bodyPr wrap="square" lIns="0" rIns="0" tIns="0" bIns="0">
-            <a:spAutoFit/>
-          </a:bodyPr>
-          <a:lstStyle/>
-          <a:p>
-            <a:pPr algn="l">
-              <a:lnSpc>
-                <a:spcPct val="122000"/>
-              </a:lnSpc>
-              <a:spcAft>
-                <a:spcPts val="0"/>
-              </a:spcAft>
-            </a:pPr>
-            <a:r>
-              <a:rPr sz="1250" b="1">
-                <a:solidFill>
-                  <a:srgbClr val="E24A4A"/>
-                </a:solidFill>
-                <a:latin typeface="Calibri"/>
-              </a:rPr>
-              <a:t>Caveat.  </a:t>
-            </a:r>
-            <a:r>
-              <a:rPr sz="1250" b="0">
-                <a:solidFill>
-                  <a:srgbClr val="E9EEF4"/>
-                </a:solidFill>
-                <a:latin typeface="Calibri"/>
-              </a:rPr>
-              <a:t>VO-D also changed the behavioural expression of the hidden property, so it is not a clean causal isolation of style: the two personas largely converged on the same recommendation.</a:t>
-            </a:r>
+            <a:endParaRPr/>
           </a:p>
         </p:txBody>
       </p:sp>
@@ -5748,8 +5817,8 @@
         </p:nvSpPr>
         <p:spPr>
           <a:xfrm>
-            <a:off x="658368" y="5870448"/>
-            <a:ext cx="6035040" cy="365760"/>
+            <a:off x="7068312" y="5175504"/>
+            <a:ext cx="4297680" cy="914400"/>
           </a:xfrm>
           <a:prstGeom prst="rect">
             <a:avLst/>
@@ -5757,7 +5826,7 @@
           <a:noFill/>
         </p:spPr>
         <p:txBody>
-          <a:bodyPr wrap="square" lIns="0" rIns="0" tIns="0" bIns="0">
+          <a:bodyPr wrap="square" lIns="0" tIns="0" rIns="0" bIns="0">
             <a:spAutoFit/>
           </a:bodyPr>
           <a:lstStyle/>
@@ -5767,24 +5836,93 @@
                 <a:spcPct val="120000"/>
               </a:lnSpc>
               <a:spcAft>
+                <a:spcPts val="0"/>
+              </a:spcAft>
+            </a:pPr>
+            <a:r>
+              <a:rPr sz="1250" b="1" dirty="0">
+                <a:solidFill>
+                  <a:srgbClr val="E24A4A"/>
+                </a:solidFill>
+                <a:latin typeface="Calibri"/>
+              </a:rPr>
+              <a:t>Caveat.  </a:t>
+            </a:r>
+            <a:r>
+              <a:rPr sz="1250" b="0" dirty="0">
+                <a:solidFill>
+                  <a:srgbClr val="E9EEF4"/>
+                </a:solidFill>
+                <a:latin typeface="Calibri"/>
+              </a:rPr>
+              <a:t>VO-D/VO-E also changed the </a:t>
+            </a:r>
+            <a:r>
+              <a:rPr sz="1250" b="0" dirty="0" err="1">
+                <a:solidFill>
+                  <a:srgbClr val="E9EEF4"/>
+                </a:solidFill>
+                <a:latin typeface="Calibri"/>
+              </a:rPr>
+              <a:t>behavioural</a:t>
+            </a:r>
+            <a:r>
+              <a:rPr sz="1250" b="0" dirty="0">
+                <a:solidFill>
+                  <a:srgbClr val="E9EEF4"/>
+                </a:solidFill>
+                <a:latin typeface="Calibri"/>
+              </a:rPr>
+              <a:t> expression of the hidden property, so they are not clean causal isolation of style: the two personas largely converged on the same recommendation.</a:t>
+            </a:r>
+          </a:p>
+        </p:txBody>
+      </p:sp>
+      <p:sp>
+        <p:nvSpPr>
+          <p:cNvPr id="12" name="TextBox 11"/>
+          <p:cNvSpPr txBox="1"/>
+          <p:nvPr/>
+        </p:nvSpPr>
+        <p:spPr>
+          <a:xfrm>
+            <a:off x="658368" y="5870448"/>
+            <a:ext cx="6035040" cy="206851"/>
+          </a:xfrm>
+          <a:prstGeom prst="rect">
+            <a:avLst/>
+          </a:prstGeom>
+          <a:noFill/>
+        </p:spPr>
+        <p:txBody>
+          <a:bodyPr wrap="square" lIns="0" tIns="0" rIns="0" bIns="0">
+            <a:spAutoFit/>
+          </a:bodyPr>
+          <a:lstStyle/>
+          <a:p>
+            <a:pPr algn="l">
+              <a:lnSpc>
+                <a:spcPct val="120000"/>
+              </a:lnSpc>
+              <a:spcAft>
                 <a:spcPts val="800"/>
               </a:spcAft>
             </a:pPr>
             <a:r>
-              <a:rPr sz="1200" b="0">
-                <a:solidFill>
-                  <a:srgbClr val="6B7683"/>
+              <a:rPr sz="1200" b="0" dirty="0">
+                <a:solidFill>
+                  <a:schemeClr val="bg1"/>
                 </a:solidFill>
                 <a:latin typeface="Calibri"/>
               </a:rPr>
-              <a:t>Points at or below the diagonal: a stylometric baseline matches or beats the model.</a:t>
-            </a:r>
-          </a:p>
-        </p:txBody>
-      </p:sp>
-      <p:sp>
-        <p:nvSpPr>
-          <p:cNvPr id="12" name="Rectangle 11"/>
+              <a:t>Points at or below the diagonal: a surface/textual baseline matches or beats the model.</a:t>
+            </a:r>
+          </a:p>
+        </p:txBody>
+      </p:sp>
+      <p:sp>
+        <p:nvSpPr>
+          <p:cNvPr id="13" name="Rectangle 12"/>
           <p:cNvSpPr/>
           <p:nvPr/>
         </p:nvSpPr>
@@ -5823,12 +5961,13 @@
           <a:lstStyle/>
           <a:p>
             <a:pPr algn="ctr"/>
-          </a:p>
-        </p:txBody>
-      </p:sp>
-      <p:sp>
-        <p:nvSpPr>
-          <p:cNvPr id="13" name="TextBox 12"/>
+            <a:endParaRPr/>
+          </a:p>
+        </p:txBody>
+      </p:sp>
+      <p:sp>
+        <p:nvSpPr>
+          <p:cNvPr id="14" name="TextBox 13"/>
           <p:cNvSpPr txBox="1"/>
           <p:nvPr/>
         </p:nvSpPr>
@@ -5843,7 +5982,7 @@
           <a:noFill/>
         </p:spPr>
         <p:txBody>
-          <a:bodyPr wrap="square" lIns="0" rIns="0" tIns="0" bIns="0">
+          <a:bodyPr wrap="square" lIns="0" tIns="0" rIns="0" bIns="0">
             <a:spAutoFit/>
           </a:bodyPr>
           <a:lstStyle/>
@@ -5886,7 +6025,7 @@
 </file>
 
 <file path=ppt/slides/slide4.xml><?xml version="1.0" encoding="utf-8"?>
-<p:sld xmlns:a="http://schemas.openxmlformats.org/drawingml/2006/main" xmlns:p="http://schemas.openxmlformats.org/presentationml/2006/main" xmlns:r="http://schemas.openxmlformats.org/officeDocument/2006/relationships">
+<p:sld xmlns:a="http://schemas.openxmlformats.org/drawingml/2006/main" xmlns:r="http://schemas.openxmlformats.org/officeDocument/2006/relationships" xmlns:p="http://schemas.openxmlformats.org/presentationml/2006/main">
   <p:cSld>
     <p:bg>
       <p:bgPr>
@@ -5902,7 +6041,14 @@
         <p:cNvGrpSpPr/>
         <p:nvPr/>
       </p:nvGrpSpPr>
-      <p:grpSpPr/>
+      <p:grpSpPr>
+        <a:xfrm>
+          <a:off x="0" y="0"/>
+          <a:ext cx="0" cy="0"/>
+          <a:chOff x="0" y="0"/>
+          <a:chExt cx="0" cy="0"/>
+        </a:xfrm>
+      </p:grpSpPr>
       <p:sp>
         <p:nvSpPr>
           <p:cNvPr id="2" name="TextBox 1"/>
@@ -5920,7 +6066,7 @@
           <a:noFill/>
         </p:spPr>
         <p:txBody>
-          <a:bodyPr wrap="square" lIns="0" rIns="0" tIns="0" bIns="0">
+          <a:bodyPr wrap="square" lIns="0" tIns="0" rIns="0" bIns="0">
             <a:spAutoFit/>
           </a:bodyPr>
           <a:lstStyle/>
@@ -5959,7 +6105,7 @@
           <a:noFill/>
         </p:spPr>
         <p:txBody>
-          <a:bodyPr wrap="square" lIns="0" rIns="0" tIns="0" bIns="0">
+          <a:bodyPr wrap="square" lIns="0" tIns="0" rIns="0" bIns="0">
             <a:spAutoFit/>
           </a:bodyPr>
           <a:lstStyle/>
@@ -5979,7 +6125,7 @@
                 </a:solidFill>
                 <a:latin typeface="Calibri"/>
               </a:rPr>
-              <a:t>No self-advantage on the target column — and one positive interaction</a:t>
+              <a:t>No positive raw M-target advantage — and one positive interaction</a:t>
             </a:r>
           </a:p>
         </p:txBody>
@@ -6003,10 +6149,34 @@
                 <a:tableStyleId>{5C22544A-7EE6-4342-B048-85BDC9FD1C3A}</a:tableStyleId>
               </a:tblPr>
               <a:tblGrid>
-                <a:gridCol w="2148840"/>
-                <a:gridCol w="1417320"/>
-                <a:gridCol w="2331720"/>
-                <a:gridCol w="2331720"/>
+                <a:gridCol w="2148840">
+                  <a:extLst>
+                    <a:ext uri="{9D8B030D-6E8A-4147-A177-3AD203B41FA5}">
+                      <a16:colId xmlns:a16="http://schemas.microsoft.com/office/drawing/2014/main" val="20000"/>
+                    </a:ext>
+                  </a:extLst>
+                </a:gridCol>
+                <a:gridCol w="1417320">
+                  <a:extLst>
+                    <a:ext uri="{9D8B030D-6E8A-4147-A177-3AD203B41FA5}">
+                      <a16:colId xmlns:a16="http://schemas.microsoft.com/office/drawing/2014/main" val="20001"/>
+                    </a:ext>
+                  </a:extLst>
+                </a:gridCol>
+                <a:gridCol w="2331720">
+                  <a:extLst>
+                    <a:ext uri="{9D8B030D-6E8A-4147-A177-3AD203B41FA5}">
+                      <a16:colId xmlns:a16="http://schemas.microsoft.com/office/drawing/2014/main" val="20002"/>
+                    </a:ext>
+                  </a:extLst>
+                </a:gridCol>
+                <a:gridCol w="2331720">
+                  <a:extLst>
+                    <a:ext uri="{9D8B030D-6E8A-4147-A177-3AD203B41FA5}">
+                      <a16:colId xmlns:a16="http://schemas.microsoft.com/office/drawing/2014/main" val="20003"/>
+                    </a:ext>
+                  </a:extLst>
+                </a:gridCol>
               </a:tblGrid>
               <a:tr h="457200">
                 <a:tc>
@@ -6026,7 +6196,7 @@
                       </a:r>
                     </a:p>
                   </a:txBody>
-                  <a:tcPr marL="91440" marR="91440" anchor="ctr">
+                  <a:tcPr anchor="ctr">
                     <a:solidFill>
                       <a:srgbClr val="0D1117"/>
                     </a:solidFill>
@@ -6061,7 +6231,7 @@
                       </a:r>
                     </a:p>
                   </a:txBody>
-                  <a:tcPr marL="91440" marR="91440" anchor="ctr">
+                  <a:tcPr anchor="ctr">
                     <a:solidFill>
                       <a:srgbClr val="0D1117"/>
                     </a:solidFill>
@@ -6096,7 +6266,7 @@
                       </a:r>
                     </a:p>
                   </a:txBody>
-                  <a:tcPr marL="91440" marR="91440" anchor="ctr">
+                  <a:tcPr anchor="ctr">
                     <a:solidFill>
                       <a:srgbClr val="0D1117"/>
                     </a:solidFill>
@@ -6131,12 +6301,17 @@
                       </a:r>
                     </a:p>
                   </a:txBody>
-                  <a:tcPr marL="91440" marR="91440" anchor="ctr">
+                  <a:tcPr anchor="ctr">
                     <a:solidFill>
                       <a:srgbClr val="0D1117"/>
                     </a:solidFill>
                   </a:tcPr>
                 </a:tc>
+                <a:extLst>
+                  <a:ext uri="{0D108BD9-81ED-4DB2-BD59-A6C34878D82A}">
+                    <a16:rowId xmlns:a16="http://schemas.microsoft.com/office/drawing/2014/main" val="10000"/>
+                  </a:ext>
+                </a:extLst>
               </a:tr>
               <a:tr h="457200">
                 <a:tc>
@@ -6156,7 +6331,7 @@
                       </a:r>
                     </a:p>
                   </a:txBody>
-                  <a:tcPr marL="91440" marR="91440" anchor="ctr">
+                  <a:tcPr anchor="ctr">
                     <a:solidFill>
                       <a:srgbClr val="161B22"/>
                     </a:solidFill>
@@ -6179,7 +6354,7 @@
                       </a:r>
                     </a:p>
                   </a:txBody>
-                  <a:tcPr marL="91440" marR="91440" anchor="ctr">
+                  <a:tcPr anchor="ctr">
                     <a:solidFill>
                       <a:srgbClr val="161B22"/>
                     </a:solidFill>
@@ -6202,7 +6377,7 @@
                       </a:r>
                     </a:p>
                   </a:txBody>
-                  <a:tcPr marL="91440" marR="91440" anchor="ctr">
+                  <a:tcPr anchor="ctr">
                     <a:solidFill>
                       <a:srgbClr val="161B22"/>
                     </a:solidFill>
@@ -6225,12 +6400,17 @@
                       </a:r>
                     </a:p>
                   </a:txBody>
-                  <a:tcPr marL="91440" marR="91440" anchor="ctr">
+                  <a:tcPr anchor="ctr">
                     <a:solidFill>
                       <a:srgbClr val="161B22"/>
                     </a:solidFill>
                   </a:tcPr>
                 </a:tc>
+                <a:extLst>
+                  <a:ext uri="{0D108BD9-81ED-4DB2-BD59-A6C34878D82A}">
+                    <a16:rowId xmlns:a16="http://schemas.microsoft.com/office/drawing/2014/main" val="10001"/>
+                  </a:ext>
+                </a:extLst>
               </a:tr>
               <a:tr h="457200">
                 <a:tc>
@@ -6250,7 +6430,7 @@
                       </a:r>
                     </a:p>
                   </a:txBody>
-                  <a:tcPr marL="91440" marR="91440" anchor="ctr">
+                  <a:tcPr anchor="ctr">
                     <a:solidFill>
                       <a:srgbClr val="161B22"/>
                     </a:solidFill>
@@ -6273,7 +6453,7 @@
                       </a:r>
                     </a:p>
                   </a:txBody>
-                  <a:tcPr marL="91440" marR="91440" anchor="ctr">
+                  <a:tcPr anchor="ctr">
                     <a:solidFill>
                       <a:srgbClr val="161B22"/>
                     </a:solidFill>
@@ -6296,7 +6476,7 @@
                       </a:r>
                     </a:p>
                   </a:txBody>
-                  <a:tcPr marL="91440" marR="91440" anchor="ctr">
+                  <a:tcPr anchor="ctr">
                     <a:solidFill>
                       <a:srgbClr val="161B22"/>
                     </a:solidFill>
@@ -6319,12 +6499,17 @@
                       </a:r>
                     </a:p>
                   </a:txBody>
-                  <a:tcPr marL="91440" marR="91440" anchor="ctr">
+                  <a:tcPr anchor="ctr">
                     <a:solidFill>
                       <a:srgbClr val="161B22"/>
                     </a:solidFill>
                   </a:tcPr>
                 </a:tc>
+                <a:extLst>
+                  <a:ext uri="{0D108BD9-81ED-4DB2-BD59-A6C34878D82A}">
+                    <a16:rowId xmlns:a16="http://schemas.microsoft.com/office/drawing/2014/main" val="10002"/>
+                  </a:ext>
+                </a:extLst>
               </a:tr>
               <a:tr h="457200">
                 <a:tc>
@@ -6344,7 +6529,7 @@
                       </a:r>
                     </a:p>
                   </a:txBody>
-                  <a:tcPr marL="91440" marR="91440" anchor="ctr">
+                  <a:tcPr anchor="ctr">
                     <a:solidFill>
                       <a:srgbClr val="161B22"/>
                     </a:solidFill>
@@ -6367,7 +6552,7 @@
                       </a:r>
                     </a:p>
                   </a:txBody>
-                  <a:tcPr marL="91440" marR="91440" anchor="ctr">
+                  <a:tcPr anchor="ctr">
                     <a:solidFill>
                       <a:srgbClr val="161B22"/>
                     </a:solidFill>
@@ -6390,7 +6575,7 @@
                       </a:r>
                     </a:p>
                   </a:txBody>
-                  <a:tcPr marL="91440" marR="91440" anchor="ctr">
+                  <a:tcPr anchor="ctr">
                     <a:solidFill>
                       <a:srgbClr val="161B22"/>
                     </a:solidFill>
@@ -6413,12 +6598,17 @@
                       </a:r>
                     </a:p>
                   </a:txBody>
-                  <a:tcPr marL="91440" marR="91440" anchor="ctr">
+                  <a:tcPr anchor="ctr">
                     <a:solidFill>
                       <a:srgbClr val="161B22"/>
                     </a:solidFill>
                   </a:tcPr>
                 </a:tc>
+                <a:extLst>
+                  <a:ext uri="{0D108BD9-81ED-4DB2-BD59-A6C34878D82A}">
+                    <a16:rowId xmlns:a16="http://schemas.microsoft.com/office/drawing/2014/main" val="10003"/>
+                  </a:ext>
+                </a:extLst>
               </a:tr>
               <a:tr h="457200">
                 <a:tc>
@@ -6438,7 +6628,7 @@
                       </a:r>
                     </a:p>
                   </a:txBody>
-                  <a:tcPr marL="91440" marR="91440" anchor="ctr">
+                  <a:tcPr anchor="ctr">
                     <a:solidFill>
                       <a:srgbClr val="1A1F2E"/>
                     </a:solidFill>
@@ -6461,7 +6651,7 @@
                       </a:r>
                     </a:p>
                   </a:txBody>
-                  <a:tcPr marL="91440" marR="91440" anchor="ctr">
+                  <a:tcPr anchor="ctr">
                     <a:solidFill>
                       <a:srgbClr val="1A1F2E"/>
                     </a:solidFill>
@@ -6484,7 +6674,7 @@
                       </a:r>
                     </a:p>
                   </a:txBody>
-                  <a:tcPr marL="91440" marR="91440" anchor="ctr">
+                  <a:tcPr anchor="ctr">
                     <a:solidFill>
                       <a:srgbClr val="1A1F2E"/>
                     </a:solidFill>
@@ -6507,12 +6697,17 @@
                       </a:r>
                     </a:p>
                   </a:txBody>
-                  <a:tcPr marL="91440" marR="91440" anchor="ctr">
+                  <a:tcPr anchor="ctr">
                     <a:solidFill>
                       <a:srgbClr val="1A1F2E"/>
                     </a:solidFill>
                   </a:tcPr>
                 </a:tc>
+                <a:extLst>
+                  <a:ext uri="{0D108BD9-81ED-4DB2-BD59-A6C34878D82A}">
+                    <a16:rowId xmlns:a16="http://schemas.microsoft.com/office/drawing/2014/main" val="10004"/>
+                  </a:ext>
+                </a:extLst>
               </a:tr>
             </a:tbl>
           </a:graphicData>
@@ -6557,7 +6752,7 @@
           </a:fontRef>
         </p:style>
         <p:txBody>
-          <a:bodyPr rtlCol="0" anchor="ctr" wrap="square" lIns="146304" rIns="146304" tIns="146304"/>
+          <a:bodyPr wrap="square" lIns="146304" tIns="146304" rIns="146304" rtlCol="0" anchor="ctr"/>
           <a:lstStyle/>
           <a:p>
             <a:pPr algn="l">
@@ -6629,7 +6824,7 @@
           <a:noFill/>
         </p:spPr>
         <p:txBody>
-          <a:bodyPr wrap="square" lIns="0" rIns="0" tIns="0" bIns="0">
+          <a:bodyPr wrap="square" lIns="0" tIns="0" rIns="0" bIns="0">
             <a:spAutoFit/>
           </a:bodyPr>
           <a:lstStyle/>
@@ -6764,7 +6959,7 @@
           </a:fontRef>
         </p:style>
         <p:txBody>
-          <a:bodyPr rtlCol="0" anchor="ctr" lIns="182880"/>
+          <a:bodyPr lIns="182880" rtlCol="0" anchor="ctr"/>
           <a:lstStyle/>
           <a:p>
             <a:pPr algn="l">
@@ -6837,6 +7032,7 @@
           <a:lstStyle/>
           <a:p>
             <a:pPr algn="ctr"/>
+            <a:endParaRPr/>
           </a:p>
         </p:txBody>
       </p:sp>
@@ -6857,7 +7053,7 @@
           <a:noFill/>
         </p:spPr>
         <p:txBody>
-          <a:bodyPr wrap="square" lIns="0" rIns="0" tIns="0" bIns="0">
+          <a:bodyPr wrap="square" lIns="0" tIns="0" rIns="0" bIns="0">
             <a:spAutoFit/>
           </a:bodyPr>
           <a:lstStyle/>
@@ -6900,7 +7096,7 @@
 </file>
 
 <file path=ppt/slides/slide5.xml><?xml version="1.0" encoding="utf-8"?>
-<p:sld xmlns:a="http://schemas.openxmlformats.org/drawingml/2006/main" xmlns:p="http://schemas.openxmlformats.org/presentationml/2006/main" xmlns:r="http://schemas.openxmlformats.org/officeDocument/2006/relationships">
+<p:sld xmlns:a="http://schemas.openxmlformats.org/drawingml/2006/main" xmlns:r="http://schemas.openxmlformats.org/officeDocument/2006/relationships" xmlns:p="http://schemas.openxmlformats.org/presentationml/2006/main">
   <p:cSld>
     <p:bg>
       <p:bgPr>
@@ -6916,7 +7112,14 @@
         <p:cNvGrpSpPr/>
         <p:nvPr/>
       </p:nvGrpSpPr>
-      <p:grpSpPr/>
+      <p:grpSpPr>
+        <a:xfrm>
+          <a:off x="0" y="0"/>
+          <a:ext cx="0" cy="0"/>
+          <a:chOff x="0" y="0"/>
+          <a:chExt cx="0" cy="0"/>
+        </a:xfrm>
+      </p:grpSpPr>
       <p:sp>
         <p:nvSpPr>
           <p:cNvPr id="2" name="TextBox 1"/>
@@ -6934,7 +7137,7 @@
           <a:noFill/>
         </p:spPr>
         <p:txBody>
-          <a:bodyPr wrap="square" lIns="0" rIns="0" tIns="0" bIns="0">
+          <a:bodyPr wrap="square" lIns="0" tIns="0" rIns="0" bIns="0">
             <a:spAutoFit/>
           </a:bodyPr>
           <a:lstStyle/>
@@ -6973,7 +7176,7 @@
           <a:noFill/>
         </p:spPr>
         <p:txBody>
-          <a:bodyPr wrap="square" lIns="0" rIns="0" tIns="0" bIns="0">
+          <a:bodyPr wrap="square" lIns="0" tIns="0" rIns="0" bIns="0">
             <a:spAutoFit/>
           </a:bodyPr>
           <a:lstStyle/>
@@ -7007,6 +7210,654 @@
         <p:spPr>
           <a:xfrm>
             <a:off x="658368" y="1572768"/>
+            <a:ext cx="3456432" cy="2084831"/>
+          </a:xfrm>
+          <a:prstGeom prst="rect">
+            <a:avLst/>
+          </a:prstGeom>
+          <a:solidFill>
+            <a:srgbClr val="161B22"/>
+          </a:solidFill>
+          <a:ln w="12700">
+            <a:solidFill>
+              <a:srgbClr val="4A9B4A"/>
+            </a:solidFill>
+          </a:ln>
+          <a:effectLst/>
+        </p:spPr>
+        <p:style>
+          <a:lnRef idx="1">
+            <a:schemeClr val="accent1"/>
+          </a:lnRef>
+          <a:fillRef idx="3">
+            <a:schemeClr val="accent1"/>
+          </a:fillRef>
+          <a:effectRef idx="2">
+            <a:schemeClr val="accent1"/>
+          </a:effectRef>
+          <a:fontRef idx="minor">
+            <a:schemeClr val="lt1"/>
+          </a:fontRef>
+        </p:style>
+        <p:txBody>
+          <a:bodyPr rtlCol="0" anchor="ctr"/>
+          <a:lstStyle/>
+          <a:p>
+            <a:pPr algn="ctr"/>
+            <a:endParaRPr/>
+          </a:p>
+        </p:txBody>
+      </p:sp>
+      <p:sp>
+        <p:nvSpPr>
+          <p:cNvPr id="5" name="TextBox 4"/>
+          <p:cNvSpPr txBox="1"/>
+          <p:nvPr/>
+        </p:nvSpPr>
+        <p:spPr>
+          <a:xfrm>
+            <a:off x="841248" y="1664208"/>
+            <a:ext cx="3090672" cy="1463040"/>
+          </a:xfrm>
+          <a:prstGeom prst="rect">
+            <a:avLst/>
+          </a:prstGeom>
+          <a:noFill/>
+        </p:spPr>
+        <p:txBody>
+          <a:bodyPr wrap="square" lIns="0" tIns="0" rIns="0" bIns="0">
+            <a:spAutoFit/>
+          </a:bodyPr>
+          <a:lstStyle/>
+          <a:p>
+            <a:pPr algn="l">
+              <a:spcAft>
+                <a:spcPts val="100"/>
+              </a:spcAft>
+            </a:pPr>
+            <a:r>
+              <a:rPr sz="950" b="1" spc="100">
+                <a:solidFill>
+                  <a:srgbClr val="4A9B4A"/>
+                </a:solidFill>
+                <a:latin typeface="Consolas"/>
+              </a:rPr>
+              <a:t>MODEL RESULT</a:t>
+            </a:r>
+          </a:p>
+          <a:p>
+            <a:pPr algn="l">
+              <a:spcAft>
+                <a:spcPts val="200"/>
+              </a:spcAft>
+            </a:pPr>
+            <a:r>
+              <a:rPr sz="1300" b="1">
+                <a:solidFill>
+                  <a:srgbClr val="E9EEF4"/>
+                </a:solidFill>
+                <a:latin typeface="Calibri"/>
+              </a:rPr>
+              <a:t>Hermes-3 self-prediction</a:t>
+            </a:r>
+          </a:p>
+          <a:p>
+            <a:pPr algn="l">
+              <a:spcAft>
+                <a:spcPts val="200"/>
+              </a:spcAft>
+            </a:pPr>
+            <a:r>
+              <a:rPr sz="3600" b="1">
+                <a:solidFill>
+                  <a:srgbClr val="4A9B4A"/>
+                </a:solidFill>
+                <a:latin typeface="Consolas"/>
+              </a:rPr>
+              <a:t>0.719</a:t>
+            </a:r>
+          </a:p>
+          <a:p>
+            <a:pPr algn="l">
+              <a:lnSpc>
+                <a:spcPct val="116000"/>
+              </a:lnSpc>
+              <a:spcAft>
+                <a:spcPts val="0"/>
+              </a:spcAft>
+            </a:pPr>
+            <a:r>
+              <a:rPr sz="1150" b="0">
+                <a:solidFill>
+                  <a:srgbClr val="98A3B0"/>
+                </a:solidFill>
+                <a:latin typeface="Calibri"/>
+              </a:rPr>
+              <a:t>balanced accuracy [0.675, 0.762]</a:t>
+            </a:r>
+          </a:p>
+          <a:p>
+            <a:pPr algn="l">
+              <a:lnSpc>
+                <a:spcPct val="116000"/>
+              </a:lnSpc>
+              <a:spcAft>
+                <a:spcPts val="0"/>
+              </a:spcAft>
+            </a:pPr>
+            <a:r>
+              <a:rPr sz="1150" b="0">
+                <a:solidFill>
+                  <a:srgbClr val="98A3B0"/>
+                </a:solidFill>
+                <a:latin typeface="Calibri"/>
+              </a:rPr>
+              <a:t>discrimination +0.437</a:t>
+            </a:r>
+          </a:p>
+        </p:txBody>
+      </p:sp>
+      <p:sp>
+        <p:nvSpPr>
+          <p:cNvPr id="6" name="Rectangle 5"/>
+          <p:cNvSpPr/>
+          <p:nvPr/>
+        </p:nvSpPr>
+        <p:spPr>
+          <a:xfrm>
+            <a:off x="841248" y="3145536"/>
+            <a:ext cx="3090672" cy="137160"/>
+          </a:xfrm>
+          <a:prstGeom prst="rect">
+            <a:avLst/>
+          </a:prstGeom>
+          <a:solidFill>
+            <a:srgbClr val="1A1F2E"/>
+          </a:solidFill>
+          <a:ln>
+            <a:noFill/>
+          </a:ln>
+          <a:effectLst/>
+        </p:spPr>
+        <p:style>
+          <a:lnRef idx="1">
+            <a:schemeClr val="accent1"/>
+          </a:lnRef>
+          <a:fillRef idx="3">
+            <a:schemeClr val="accent1"/>
+          </a:fillRef>
+          <a:effectRef idx="2">
+            <a:schemeClr val="accent1"/>
+          </a:effectRef>
+          <a:fontRef idx="minor">
+            <a:schemeClr val="lt1"/>
+          </a:fontRef>
+        </p:style>
+        <p:txBody>
+          <a:bodyPr rtlCol="0" anchor="ctr"/>
+          <a:lstStyle/>
+          <a:p>
+            <a:pPr algn="ctr"/>
+            <a:endParaRPr/>
+          </a:p>
+        </p:txBody>
+      </p:sp>
+      <p:sp>
+        <p:nvSpPr>
+          <p:cNvPr id="7" name="Rectangle 6"/>
+          <p:cNvSpPr/>
+          <p:nvPr/>
+        </p:nvSpPr>
+        <p:spPr>
+          <a:xfrm>
+            <a:off x="841248" y="3145536"/>
+            <a:ext cx="1692142" cy="137160"/>
+          </a:xfrm>
+          <a:prstGeom prst="rect">
+            <a:avLst/>
+          </a:prstGeom>
+          <a:solidFill>
+            <a:srgbClr val="4A9B4A"/>
+          </a:solidFill>
+          <a:ln>
+            <a:noFill/>
+          </a:ln>
+          <a:effectLst/>
+        </p:spPr>
+        <p:style>
+          <a:lnRef idx="1">
+            <a:schemeClr val="accent1"/>
+          </a:lnRef>
+          <a:fillRef idx="3">
+            <a:schemeClr val="accent1"/>
+          </a:fillRef>
+          <a:effectRef idx="2">
+            <a:schemeClr val="accent1"/>
+          </a:effectRef>
+          <a:fontRef idx="minor">
+            <a:schemeClr val="lt1"/>
+          </a:fontRef>
+        </p:style>
+        <p:txBody>
+          <a:bodyPr rtlCol="0" anchor="ctr"/>
+          <a:lstStyle/>
+          <a:p>
+            <a:pPr algn="ctr"/>
+            <a:endParaRPr/>
+          </a:p>
+        </p:txBody>
+      </p:sp>
+      <p:sp>
+        <p:nvSpPr>
+          <p:cNvPr id="8" name="TextBox 7"/>
+          <p:cNvSpPr txBox="1"/>
+          <p:nvPr/>
+        </p:nvSpPr>
+        <p:spPr>
+          <a:xfrm>
+            <a:off x="841248" y="3319272"/>
+            <a:ext cx="3090672" cy="182880"/>
+          </a:xfrm>
+          <a:prstGeom prst="rect">
+            <a:avLst/>
+          </a:prstGeom>
+          <a:noFill/>
+        </p:spPr>
+        <p:txBody>
+          <a:bodyPr wrap="square" lIns="0" tIns="0" rIns="0" bIns="0">
+            <a:spAutoFit/>
+          </a:bodyPr>
+          <a:lstStyle/>
+          <a:p>
+            <a:pPr algn="l">
+              <a:spcAft>
+                <a:spcPts val="0"/>
+              </a:spcAft>
+            </a:pPr>
+            <a:r>
+              <a:rPr sz="950" b="0">
+                <a:solidFill>
+                  <a:srgbClr val="6B7683"/>
+                </a:solidFill>
+                <a:latin typeface="Consolas"/>
+              </a:rPr>
+              <a:t>0.50 chance</a:t>
+            </a:r>
+          </a:p>
+        </p:txBody>
+      </p:sp>
+      <p:sp>
+        <p:nvSpPr>
+          <p:cNvPr id="9" name="TextBox 8"/>
+          <p:cNvSpPr txBox="1"/>
+          <p:nvPr/>
+        </p:nvSpPr>
+        <p:spPr>
+          <a:xfrm>
+            <a:off x="841248" y="3319272"/>
+            <a:ext cx="3090672" cy="182880"/>
+          </a:xfrm>
+          <a:prstGeom prst="rect">
+            <a:avLst/>
+          </a:prstGeom>
+          <a:noFill/>
+        </p:spPr>
+        <p:txBody>
+          <a:bodyPr wrap="square" lIns="0" tIns="0" rIns="0" bIns="0">
+            <a:spAutoFit/>
+          </a:bodyPr>
+          <a:lstStyle/>
+          <a:p>
+            <a:pPr algn="r">
+              <a:spcAft>
+                <a:spcPts val="0"/>
+              </a:spcAft>
+            </a:pPr>
+            <a:r>
+              <a:rPr sz="950" b="0">
+                <a:solidFill>
+                  <a:srgbClr val="6B7683"/>
+                </a:solidFill>
+                <a:latin typeface="Consolas"/>
+              </a:rPr>
+              <a:t>0.90</a:t>
+            </a:r>
+          </a:p>
+        </p:txBody>
+      </p:sp>
+      <p:sp>
+        <p:nvSpPr>
+          <p:cNvPr id="10" name="Rectangle 9"/>
+          <p:cNvSpPr/>
+          <p:nvPr/>
+        </p:nvSpPr>
+        <p:spPr>
+          <a:xfrm>
+            <a:off x="4315968" y="1572768"/>
+            <a:ext cx="3456432" cy="2084831"/>
+          </a:xfrm>
+          <a:prstGeom prst="rect">
+            <a:avLst/>
+          </a:prstGeom>
+          <a:solidFill>
+            <a:srgbClr val="161B22"/>
+          </a:solidFill>
+          <a:ln w="12700">
+            <a:solidFill>
+              <a:srgbClr val="4A90D9"/>
+            </a:solidFill>
+          </a:ln>
+          <a:effectLst/>
+        </p:spPr>
+        <p:style>
+          <a:lnRef idx="1">
+            <a:schemeClr val="accent1"/>
+          </a:lnRef>
+          <a:fillRef idx="3">
+            <a:schemeClr val="accent1"/>
+          </a:fillRef>
+          <a:effectRef idx="2">
+            <a:schemeClr val="accent1"/>
+          </a:effectRef>
+          <a:fontRef idx="minor">
+            <a:schemeClr val="lt1"/>
+          </a:fontRef>
+        </p:style>
+        <p:txBody>
+          <a:bodyPr rtlCol="0" anchor="ctr"/>
+          <a:lstStyle/>
+          <a:p>
+            <a:pPr algn="ctr"/>
+            <a:endParaRPr/>
+          </a:p>
+        </p:txBody>
+      </p:sp>
+      <p:sp>
+        <p:nvSpPr>
+          <p:cNvPr id="11" name="TextBox 10"/>
+          <p:cNvSpPr txBox="1"/>
+          <p:nvPr/>
+        </p:nvSpPr>
+        <p:spPr>
+          <a:xfrm>
+            <a:off x="4498848" y="1664208"/>
+            <a:ext cx="3090672" cy="1463040"/>
+          </a:xfrm>
+          <a:prstGeom prst="rect">
+            <a:avLst/>
+          </a:prstGeom>
+          <a:noFill/>
+        </p:spPr>
+        <p:txBody>
+          <a:bodyPr wrap="square" lIns="0" tIns="0" rIns="0" bIns="0">
+            <a:spAutoFit/>
+          </a:bodyPr>
+          <a:lstStyle/>
+          <a:p>
+            <a:pPr algn="l">
+              <a:spcAft>
+                <a:spcPts val="100"/>
+              </a:spcAft>
+            </a:pPr>
+            <a:r>
+              <a:rPr sz="950" b="1" spc="100">
+                <a:solidFill>
+                  <a:srgbClr val="4A90D9"/>
+                </a:solidFill>
+                <a:latin typeface="Consolas"/>
+              </a:rPr>
+              <a:t>MATCHED COMPARATOR</a:t>
+            </a:r>
+          </a:p>
+          <a:p>
+            <a:pPr algn="l">
+              <a:spcAft>
+                <a:spcPts val="200"/>
+              </a:spcAft>
+            </a:pPr>
+            <a:r>
+              <a:rPr sz="1300" b="1">
+                <a:solidFill>
+                  <a:srgbClr val="E9EEF4"/>
+                </a:solidFill>
+                <a:latin typeface="Calibri"/>
+              </a:rPr>
+              <a:t>Length-only observer</a:t>
+            </a:r>
+          </a:p>
+          <a:p>
+            <a:pPr algn="l">
+              <a:spcAft>
+                <a:spcPts val="200"/>
+              </a:spcAft>
+            </a:pPr>
+            <a:r>
+              <a:rPr sz="3600" b="1">
+                <a:solidFill>
+                  <a:srgbClr val="4A90D9"/>
+                </a:solidFill>
+                <a:latin typeface="Consolas"/>
+              </a:rPr>
+              <a:t>0.808</a:t>
+            </a:r>
+          </a:p>
+          <a:p>
+            <a:pPr algn="l">
+              <a:lnSpc>
+                <a:spcPct val="116000"/>
+              </a:lnSpc>
+              <a:spcAft>
+                <a:spcPts val="0"/>
+              </a:spcAft>
+            </a:pPr>
+            <a:r>
+              <a:rPr sz="1150" b="0">
+                <a:solidFill>
+                  <a:srgbClr val="98A3B0"/>
+                </a:solidFill>
+                <a:latin typeface="Calibri"/>
+              </a:rPr>
+              <a:t>“pick the longer reply”</a:t>
+            </a:r>
+          </a:p>
+          <a:p>
+            <a:pPr algn="l">
+              <a:lnSpc>
+                <a:spcPct val="116000"/>
+              </a:lnSpc>
+              <a:spcAft>
+                <a:spcPts val="0"/>
+              </a:spcAft>
+            </a:pPr>
+            <a:r>
+              <a:rPr sz="1150" b="0">
+                <a:solidFill>
+                  <a:srgbClr val="98A3B0"/>
+                </a:solidFill>
+                <a:latin typeface="Calibri"/>
+              </a:rPr>
+              <a:t>one feature, no training</a:t>
+            </a:r>
+          </a:p>
+        </p:txBody>
+      </p:sp>
+      <p:sp>
+        <p:nvSpPr>
+          <p:cNvPr id="12" name="Rectangle 11"/>
+          <p:cNvSpPr/>
+          <p:nvPr/>
+        </p:nvSpPr>
+        <p:spPr>
+          <a:xfrm>
+            <a:off x="4498848" y="3145536"/>
+            <a:ext cx="3090672" cy="137160"/>
+          </a:xfrm>
+          <a:prstGeom prst="rect">
+            <a:avLst/>
+          </a:prstGeom>
+          <a:solidFill>
+            <a:srgbClr val="1A1F2E"/>
+          </a:solidFill>
+          <a:ln>
+            <a:noFill/>
+          </a:ln>
+          <a:effectLst/>
+        </p:spPr>
+        <p:style>
+          <a:lnRef idx="1">
+            <a:schemeClr val="accent1"/>
+          </a:lnRef>
+          <a:fillRef idx="3">
+            <a:schemeClr val="accent1"/>
+          </a:fillRef>
+          <a:effectRef idx="2">
+            <a:schemeClr val="accent1"/>
+          </a:effectRef>
+          <a:fontRef idx="minor">
+            <a:schemeClr val="lt1"/>
+          </a:fontRef>
+        </p:style>
+        <p:txBody>
+          <a:bodyPr rtlCol="0" anchor="ctr"/>
+          <a:lstStyle/>
+          <a:p>
+            <a:pPr algn="ctr"/>
+            <a:endParaRPr/>
+          </a:p>
+        </p:txBody>
+      </p:sp>
+      <p:sp>
+        <p:nvSpPr>
+          <p:cNvPr id="13" name="Rectangle 12"/>
+          <p:cNvSpPr/>
+          <p:nvPr/>
+        </p:nvSpPr>
+        <p:spPr>
+          <a:xfrm>
+            <a:off x="4498848" y="3145536"/>
+            <a:ext cx="2379817" cy="137160"/>
+          </a:xfrm>
+          <a:prstGeom prst="rect">
+            <a:avLst/>
+          </a:prstGeom>
+          <a:solidFill>
+            <a:srgbClr val="4A90D9"/>
+          </a:solidFill>
+          <a:ln>
+            <a:noFill/>
+          </a:ln>
+          <a:effectLst/>
+        </p:spPr>
+        <p:style>
+          <a:lnRef idx="1">
+            <a:schemeClr val="accent1"/>
+          </a:lnRef>
+          <a:fillRef idx="3">
+            <a:schemeClr val="accent1"/>
+          </a:fillRef>
+          <a:effectRef idx="2">
+            <a:schemeClr val="accent1"/>
+          </a:effectRef>
+          <a:fontRef idx="minor">
+            <a:schemeClr val="lt1"/>
+          </a:fontRef>
+        </p:style>
+        <p:txBody>
+          <a:bodyPr rtlCol="0" anchor="ctr"/>
+          <a:lstStyle/>
+          <a:p>
+            <a:pPr algn="ctr"/>
+            <a:endParaRPr/>
+          </a:p>
+        </p:txBody>
+      </p:sp>
+      <p:sp>
+        <p:nvSpPr>
+          <p:cNvPr id="14" name="TextBox 13"/>
+          <p:cNvSpPr txBox="1"/>
+          <p:nvPr/>
+        </p:nvSpPr>
+        <p:spPr>
+          <a:xfrm>
+            <a:off x="4498848" y="3319272"/>
+            <a:ext cx="3090672" cy="182880"/>
+          </a:xfrm>
+          <a:prstGeom prst="rect">
+            <a:avLst/>
+          </a:prstGeom>
+          <a:noFill/>
+        </p:spPr>
+        <p:txBody>
+          <a:bodyPr wrap="square" lIns="0" tIns="0" rIns="0" bIns="0">
+            <a:spAutoFit/>
+          </a:bodyPr>
+          <a:lstStyle/>
+          <a:p>
+            <a:pPr algn="l">
+              <a:spcAft>
+                <a:spcPts val="0"/>
+              </a:spcAft>
+            </a:pPr>
+            <a:r>
+              <a:rPr sz="950" b="0">
+                <a:solidFill>
+                  <a:srgbClr val="6B7683"/>
+                </a:solidFill>
+                <a:latin typeface="Consolas"/>
+              </a:rPr>
+              <a:t>0.50 chance</a:t>
+            </a:r>
+          </a:p>
+        </p:txBody>
+      </p:sp>
+      <p:sp>
+        <p:nvSpPr>
+          <p:cNvPr id="15" name="TextBox 14"/>
+          <p:cNvSpPr txBox="1"/>
+          <p:nvPr/>
+        </p:nvSpPr>
+        <p:spPr>
+          <a:xfrm>
+            <a:off x="4498848" y="3319272"/>
+            <a:ext cx="3090672" cy="182880"/>
+          </a:xfrm>
+          <a:prstGeom prst="rect">
+            <a:avLst/>
+          </a:prstGeom>
+          <a:noFill/>
+        </p:spPr>
+        <p:txBody>
+          <a:bodyPr wrap="square" lIns="0" tIns="0" rIns="0" bIns="0">
+            <a:spAutoFit/>
+          </a:bodyPr>
+          <a:lstStyle/>
+          <a:p>
+            <a:pPr algn="r">
+              <a:spcAft>
+                <a:spcPts val="0"/>
+              </a:spcAft>
+            </a:pPr>
+            <a:r>
+              <a:rPr sz="950" b="0">
+                <a:solidFill>
+                  <a:srgbClr val="6B7683"/>
+                </a:solidFill>
+                <a:latin typeface="Consolas"/>
+              </a:rPr>
+              <a:t>0.90</a:t>
+            </a:r>
+          </a:p>
+        </p:txBody>
+      </p:sp>
+      <p:sp>
+        <p:nvSpPr>
+          <p:cNvPr id="16" name="Rectangle 15"/>
+          <p:cNvSpPr/>
+          <p:nvPr/>
+        </p:nvSpPr>
+        <p:spPr>
+          <a:xfrm>
+            <a:off x="7973568" y="1572768"/>
             <a:ext cx="3456432" cy="2084831"/>
           </a:xfrm>
           <a:prstGeom prst="rect">
@@ -7041,19 +7892,20 @@
           <a:lstStyle/>
           <a:p>
             <a:pPr algn="ctr"/>
-          </a:p>
-        </p:txBody>
-      </p:sp>
-      <p:sp>
-        <p:nvSpPr>
-          <p:cNvPr id="5" name="TextBox 4"/>
+            <a:endParaRPr/>
+          </a:p>
+        </p:txBody>
+      </p:sp>
+      <p:sp>
+        <p:nvSpPr>
+          <p:cNvPr id="17" name="TextBox 16"/>
           <p:cNvSpPr txBox="1"/>
           <p:nvPr/>
         </p:nvSpPr>
         <p:spPr>
           <a:xfrm>
-            <a:off x="841248" y="1719072"/>
-            <a:ext cx="3090672" cy="1371600"/>
+            <a:off x="8156448" y="1664208"/>
+            <a:ext cx="3090672" cy="1463040"/>
           </a:xfrm>
           <a:prstGeom prst="rect">
             <a:avLst/>
@@ -7061,40 +7913,56 @@
           <a:noFill/>
         </p:spPr>
         <p:txBody>
-          <a:bodyPr wrap="square" lIns="0" rIns="0" tIns="0" bIns="0">
+          <a:bodyPr wrap="square" lIns="0" tIns="0" rIns="0" bIns="0">
             <a:spAutoFit/>
           </a:bodyPr>
           <a:lstStyle/>
           <a:p>
             <a:pPr algn="l">
               <a:spcAft>
+                <a:spcPts val="100"/>
+              </a:spcAft>
+            </a:pPr>
+            <a:r>
+              <a:rPr sz="950" b="1" spc="100">
+                <a:solidFill>
+                  <a:srgbClr val="F0C040"/>
+                </a:solidFill>
+                <a:latin typeface="Consolas"/>
+              </a:rPr>
+              <a:t>COST CRITERION</a:t>
+            </a:r>
+          </a:p>
+          <a:p>
+            <a:pPr algn="l">
+              <a:spcAft>
                 <a:spcPts val="200"/>
               </a:spcAft>
             </a:pPr>
             <a:r>
-              <a:rPr sz="1350" b="1">
+              <a:rPr sz="1300" b="1">
                 <a:solidFill>
                   <a:srgbClr val="E9EEF4"/>
                 </a:solidFill>
                 <a:latin typeface="Calibri"/>
               </a:rPr>
-              <a:t>Hermes-3 self-prediction</a:t>
+              <a:t>21-feature surface classifier</a:t>
             </a:r>
           </a:p>
           <a:p>
             <a:pPr algn="l">
               <a:spcAft>
-                <a:spcPts val="300"/>
-              </a:spcAft>
-            </a:pPr>
-            <a:r>
-              <a:rPr sz="4000" b="1">
-                <a:solidFill>
-                  <a:srgbClr val="4A9B4A"/>
+                <a:spcPts val="200"/>
+              </a:spcAft>
+            </a:pPr>
+            <a:r>
+              <a:rPr sz="3600" b="1">
+                <a:solidFill>
+                  <a:srgbClr val="F0C040"/>
                 </a:solidFill>
                 <a:latin typeface="Consolas"/>
               </a:rPr>
-              <a:t>0.719</a:t>
+              <a:t>0.831</a:t>
             </a:r>
           </a:p>
           <a:p>
@@ -7113,7 +7981,7 @@
                 </a:solidFill>
                 <a:latin typeface="Calibri"/>
               </a:rPr>
-              <a:t>balanced accuracy [0.675, 0.762]</a:t>
+              <a:t>supervised single-text</a:t>
             </a:r>
           </a:p>
           <a:p>
@@ -7132,20 +8000,20 @@
                 </a:solidFill>
                 <a:latin typeface="Calibri"/>
               </a:rPr>
-              <a:t>discrimination +0.437</a:t>
-            </a:r>
-          </a:p>
-        </p:txBody>
-      </p:sp>
-      <p:sp>
-        <p:nvSpPr>
-          <p:cNvPr id="6" name="Rectangle 5"/>
+              <a:t>authorship labelling</a:t>
+            </a:r>
+          </a:p>
+        </p:txBody>
+      </p:sp>
+      <p:sp>
+        <p:nvSpPr>
+          <p:cNvPr id="18" name="Rectangle 17"/>
           <p:cNvSpPr/>
           <p:nvPr/>
         </p:nvSpPr>
         <p:spPr>
           <a:xfrm>
-            <a:off x="841248" y="3145536"/>
+            <a:off x="8156448" y="3145536"/>
             <a:ext cx="3090672" cy="137160"/>
           </a:xfrm>
           <a:prstGeom prst="rect">
@@ -7178,616 +8046,7 @@
           <a:lstStyle/>
           <a:p>
             <a:pPr algn="ctr"/>
-          </a:p>
-        </p:txBody>
-      </p:sp>
-      <p:sp>
-        <p:nvSpPr>
-          <p:cNvPr id="7" name="Rectangle 6"/>
-          <p:cNvSpPr/>
-          <p:nvPr/>
-        </p:nvSpPr>
-        <p:spPr>
-          <a:xfrm>
-            <a:off x="841248" y="3145536"/>
-            <a:ext cx="1692142" cy="137160"/>
-          </a:xfrm>
-          <a:prstGeom prst="rect">
-            <a:avLst/>
-          </a:prstGeom>
-          <a:solidFill>
-            <a:srgbClr val="4A9B4A"/>
-          </a:solidFill>
-          <a:ln>
-            <a:noFill/>
-          </a:ln>
-          <a:effectLst/>
-        </p:spPr>
-        <p:style>
-          <a:lnRef idx="1">
-            <a:schemeClr val="accent1"/>
-          </a:lnRef>
-          <a:fillRef idx="3">
-            <a:schemeClr val="accent1"/>
-          </a:fillRef>
-          <a:effectRef idx="2">
-            <a:schemeClr val="accent1"/>
-          </a:effectRef>
-          <a:fontRef idx="minor">
-            <a:schemeClr val="lt1"/>
-          </a:fontRef>
-        </p:style>
-        <p:txBody>
-          <a:bodyPr rtlCol="0" anchor="ctr"/>
-          <a:lstStyle/>
-          <a:p>
-            <a:pPr algn="ctr"/>
-          </a:p>
-        </p:txBody>
-      </p:sp>
-      <p:sp>
-        <p:nvSpPr>
-          <p:cNvPr id="8" name="TextBox 7"/>
-          <p:cNvSpPr txBox="1"/>
-          <p:nvPr/>
-        </p:nvSpPr>
-        <p:spPr>
-          <a:xfrm>
-            <a:off x="841248" y="3319272"/>
-            <a:ext cx="3090672" cy="182880"/>
-          </a:xfrm>
-          <a:prstGeom prst="rect">
-            <a:avLst/>
-          </a:prstGeom>
-          <a:noFill/>
-        </p:spPr>
-        <p:txBody>
-          <a:bodyPr wrap="square" lIns="0" rIns="0" tIns="0" bIns="0">
-            <a:spAutoFit/>
-          </a:bodyPr>
-          <a:lstStyle/>
-          <a:p>
-            <a:pPr algn="l">
-              <a:spcAft>
-                <a:spcPts val="0"/>
-              </a:spcAft>
-            </a:pPr>
-            <a:r>
-              <a:rPr sz="950" b="0">
-                <a:solidFill>
-                  <a:srgbClr val="6B7683"/>
-                </a:solidFill>
-                <a:latin typeface="Consolas"/>
-              </a:rPr>
-              <a:t>0.50 chance</a:t>
-            </a:r>
-          </a:p>
-        </p:txBody>
-      </p:sp>
-      <p:sp>
-        <p:nvSpPr>
-          <p:cNvPr id="9" name="TextBox 8"/>
-          <p:cNvSpPr txBox="1"/>
-          <p:nvPr/>
-        </p:nvSpPr>
-        <p:spPr>
-          <a:xfrm>
-            <a:off x="841248" y="3319272"/>
-            <a:ext cx="3090672" cy="182880"/>
-          </a:xfrm>
-          <a:prstGeom prst="rect">
-            <a:avLst/>
-          </a:prstGeom>
-          <a:noFill/>
-        </p:spPr>
-        <p:txBody>
-          <a:bodyPr wrap="square" lIns="0" rIns="0" tIns="0" bIns="0">
-            <a:spAutoFit/>
-          </a:bodyPr>
-          <a:lstStyle/>
-          <a:p>
-            <a:pPr algn="r">
-              <a:spcAft>
-                <a:spcPts val="0"/>
-              </a:spcAft>
-            </a:pPr>
-            <a:r>
-              <a:rPr sz="950" b="0">
-                <a:solidFill>
-                  <a:srgbClr val="6B7683"/>
-                </a:solidFill>
-                <a:latin typeface="Consolas"/>
-              </a:rPr>
-              <a:t>0.90</a:t>
-            </a:r>
-          </a:p>
-        </p:txBody>
-      </p:sp>
-      <p:sp>
-        <p:nvSpPr>
-          <p:cNvPr id="10" name="Rectangle 9"/>
-          <p:cNvSpPr/>
-          <p:nvPr/>
-        </p:nvSpPr>
-        <p:spPr>
-          <a:xfrm>
-            <a:off x="4315968" y="1572768"/>
-            <a:ext cx="3456432" cy="2084831"/>
-          </a:xfrm>
-          <a:prstGeom prst="rect">
-            <a:avLst/>
-          </a:prstGeom>
-          <a:solidFill>
-            <a:srgbClr val="161B22"/>
-          </a:solidFill>
-          <a:ln w="12700">
-            <a:solidFill>
-              <a:srgbClr val="2A323C"/>
-            </a:solidFill>
-          </a:ln>
-          <a:effectLst/>
-        </p:spPr>
-        <p:style>
-          <a:lnRef idx="1">
-            <a:schemeClr val="accent1"/>
-          </a:lnRef>
-          <a:fillRef idx="3">
-            <a:schemeClr val="accent1"/>
-          </a:fillRef>
-          <a:effectRef idx="2">
-            <a:schemeClr val="accent1"/>
-          </a:effectRef>
-          <a:fontRef idx="minor">
-            <a:schemeClr val="lt1"/>
-          </a:fontRef>
-        </p:style>
-        <p:txBody>
-          <a:bodyPr rtlCol="0" anchor="ctr"/>
-          <a:lstStyle/>
-          <a:p>
-            <a:pPr algn="ctr"/>
-          </a:p>
-        </p:txBody>
-      </p:sp>
-      <p:sp>
-        <p:nvSpPr>
-          <p:cNvPr id="11" name="TextBox 10"/>
-          <p:cNvSpPr txBox="1"/>
-          <p:nvPr/>
-        </p:nvSpPr>
-        <p:spPr>
-          <a:xfrm>
-            <a:off x="4498848" y="1719072"/>
-            <a:ext cx="3090672" cy="1371600"/>
-          </a:xfrm>
-          <a:prstGeom prst="rect">
-            <a:avLst/>
-          </a:prstGeom>
-          <a:noFill/>
-        </p:spPr>
-        <p:txBody>
-          <a:bodyPr wrap="square" lIns="0" rIns="0" tIns="0" bIns="0">
-            <a:spAutoFit/>
-          </a:bodyPr>
-          <a:lstStyle/>
-          <a:p>
-            <a:pPr algn="l">
-              <a:spcAft>
-                <a:spcPts val="200"/>
-              </a:spcAft>
-            </a:pPr>
-            <a:r>
-              <a:rPr sz="1350" b="1">
-                <a:solidFill>
-                  <a:srgbClr val="E9EEF4"/>
-                </a:solidFill>
-                <a:latin typeface="Calibri"/>
-              </a:rPr>
-              <a:t>Length-only observer</a:t>
-            </a:r>
-          </a:p>
-          <a:p>
-            <a:pPr algn="l">
-              <a:spcAft>
-                <a:spcPts val="300"/>
-              </a:spcAft>
-            </a:pPr>
-            <a:r>
-              <a:rPr sz="4000" b="1">
-                <a:solidFill>
-                  <a:srgbClr val="4A90D9"/>
-                </a:solidFill>
-                <a:latin typeface="Consolas"/>
-              </a:rPr>
-              <a:t>0.808</a:t>
-            </a:r>
-          </a:p>
-          <a:p>
-            <a:pPr algn="l">
-              <a:lnSpc>
-                <a:spcPct val="116000"/>
-              </a:lnSpc>
-              <a:spcAft>
-                <a:spcPts val="0"/>
-              </a:spcAft>
-            </a:pPr>
-            <a:r>
-              <a:rPr sz="1150" b="0">
-                <a:solidFill>
-                  <a:srgbClr val="98A3B0"/>
-                </a:solidFill>
-                <a:latin typeface="Calibri"/>
-              </a:rPr>
-              <a:t>“pick the longer reply”</a:t>
-            </a:r>
-          </a:p>
-          <a:p>
-            <a:pPr algn="l">
-              <a:lnSpc>
-                <a:spcPct val="116000"/>
-              </a:lnSpc>
-              <a:spcAft>
-                <a:spcPts val="0"/>
-              </a:spcAft>
-            </a:pPr>
-            <a:r>
-              <a:rPr sz="1150" b="0">
-                <a:solidFill>
-                  <a:srgbClr val="98A3B0"/>
-                </a:solidFill>
-                <a:latin typeface="Calibri"/>
-              </a:rPr>
-              <a:t>one feature, no training</a:t>
-            </a:r>
-          </a:p>
-        </p:txBody>
-      </p:sp>
-      <p:sp>
-        <p:nvSpPr>
-          <p:cNvPr id="12" name="Rectangle 11"/>
-          <p:cNvSpPr/>
-          <p:nvPr/>
-        </p:nvSpPr>
-        <p:spPr>
-          <a:xfrm>
-            <a:off x="4498848" y="3145536"/>
-            <a:ext cx="3090672" cy="137160"/>
-          </a:xfrm>
-          <a:prstGeom prst="rect">
-            <a:avLst/>
-          </a:prstGeom>
-          <a:solidFill>
-            <a:srgbClr val="1A1F2E"/>
-          </a:solidFill>
-          <a:ln>
-            <a:noFill/>
-          </a:ln>
-          <a:effectLst/>
-        </p:spPr>
-        <p:style>
-          <a:lnRef idx="1">
-            <a:schemeClr val="accent1"/>
-          </a:lnRef>
-          <a:fillRef idx="3">
-            <a:schemeClr val="accent1"/>
-          </a:fillRef>
-          <a:effectRef idx="2">
-            <a:schemeClr val="accent1"/>
-          </a:effectRef>
-          <a:fontRef idx="minor">
-            <a:schemeClr val="lt1"/>
-          </a:fontRef>
-        </p:style>
-        <p:txBody>
-          <a:bodyPr rtlCol="0" anchor="ctr"/>
-          <a:lstStyle/>
-          <a:p>
-            <a:pPr algn="ctr"/>
-          </a:p>
-        </p:txBody>
-      </p:sp>
-      <p:sp>
-        <p:nvSpPr>
-          <p:cNvPr id="13" name="Rectangle 12"/>
-          <p:cNvSpPr/>
-          <p:nvPr/>
-        </p:nvSpPr>
-        <p:spPr>
-          <a:xfrm>
-            <a:off x="4498848" y="3145536"/>
-            <a:ext cx="2379817" cy="137160"/>
-          </a:xfrm>
-          <a:prstGeom prst="rect">
-            <a:avLst/>
-          </a:prstGeom>
-          <a:solidFill>
-            <a:srgbClr val="4A90D9"/>
-          </a:solidFill>
-          <a:ln>
-            <a:noFill/>
-          </a:ln>
-          <a:effectLst/>
-        </p:spPr>
-        <p:style>
-          <a:lnRef idx="1">
-            <a:schemeClr val="accent1"/>
-          </a:lnRef>
-          <a:fillRef idx="3">
-            <a:schemeClr val="accent1"/>
-          </a:fillRef>
-          <a:effectRef idx="2">
-            <a:schemeClr val="accent1"/>
-          </a:effectRef>
-          <a:fontRef idx="minor">
-            <a:schemeClr val="lt1"/>
-          </a:fontRef>
-        </p:style>
-        <p:txBody>
-          <a:bodyPr rtlCol="0" anchor="ctr"/>
-          <a:lstStyle/>
-          <a:p>
-            <a:pPr algn="ctr"/>
-          </a:p>
-        </p:txBody>
-      </p:sp>
-      <p:sp>
-        <p:nvSpPr>
-          <p:cNvPr id="14" name="TextBox 13"/>
-          <p:cNvSpPr txBox="1"/>
-          <p:nvPr/>
-        </p:nvSpPr>
-        <p:spPr>
-          <a:xfrm>
-            <a:off x="4498848" y="3319272"/>
-            <a:ext cx="3090672" cy="182880"/>
-          </a:xfrm>
-          <a:prstGeom prst="rect">
-            <a:avLst/>
-          </a:prstGeom>
-          <a:noFill/>
-        </p:spPr>
-        <p:txBody>
-          <a:bodyPr wrap="square" lIns="0" rIns="0" tIns="0" bIns="0">
-            <a:spAutoFit/>
-          </a:bodyPr>
-          <a:lstStyle/>
-          <a:p>
-            <a:pPr algn="l">
-              <a:spcAft>
-                <a:spcPts val="0"/>
-              </a:spcAft>
-            </a:pPr>
-            <a:r>
-              <a:rPr sz="950" b="0">
-                <a:solidFill>
-                  <a:srgbClr val="6B7683"/>
-                </a:solidFill>
-                <a:latin typeface="Consolas"/>
-              </a:rPr>
-              <a:t>0.50 chance</a:t>
-            </a:r>
-          </a:p>
-        </p:txBody>
-      </p:sp>
-      <p:sp>
-        <p:nvSpPr>
-          <p:cNvPr id="15" name="TextBox 14"/>
-          <p:cNvSpPr txBox="1"/>
-          <p:nvPr/>
-        </p:nvSpPr>
-        <p:spPr>
-          <a:xfrm>
-            <a:off x="4498848" y="3319272"/>
-            <a:ext cx="3090672" cy="182880"/>
-          </a:xfrm>
-          <a:prstGeom prst="rect">
-            <a:avLst/>
-          </a:prstGeom>
-          <a:noFill/>
-        </p:spPr>
-        <p:txBody>
-          <a:bodyPr wrap="square" lIns="0" rIns="0" tIns="0" bIns="0">
-            <a:spAutoFit/>
-          </a:bodyPr>
-          <a:lstStyle/>
-          <a:p>
-            <a:pPr algn="r">
-              <a:spcAft>
-                <a:spcPts val="0"/>
-              </a:spcAft>
-            </a:pPr>
-            <a:r>
-              <a:rPr sz="950" b="0">
-                <a:solidFill>
-                  <a:srgbClr val="6B7683"/>
-                </a:solidFill>
-                <a:latin typeface="Consolas"/>
-              </a:rPr>
-              <a:t>0.90</a:t>
-            </a:r>
-          </a:p>
-        </p:txBody>
-      </p:sp>
-      <p:sp>
-        <p:nvSpPr>
-          <p:cNvPr id="16" name="Rectangle 15"/>
-          <p:cNvSpPr/>
-          <p:nvPr/>
-        </p:nvSpPr>
-        <p:spPr>
-          <a:xfrm>
-            <a:off x="7973568" y="1572768"/>
-            <a:ext cx="3456432" cy="2084831"/>
-          </a:xfrm>
-          <a:prstGeom prst="rect">
-            <a:avLst/>
-          </a:prstGeom>
-          <a:solidFill>
-            <a:srgbClr val="161B22"/>
-          </a:solidFill>
-          <a:ln w="12700">
-            <a:solidFill>
-              <a:srgbClr val="2A323C"/>
-            </a:solidFill>
-          </a:ln>
-          <a:effectLst/>
-        </p:spPr>
-        <p:style>
-          <a:lnRef idx="1">
-            <a:schemeClr val="accent1"/>
-          </a:lnRef>
-          <a:fillRef idx="3">
-            <a:schemeClr val="accent1"/>
-          </a:fillRef>
-          <a:effectRef idx="2">
-            <a:schemeClr val="accent1"/>
-          </a:effectRef>
-          <a:fontRef idx="minor">
-            <a:schemeClr val="lt1"/>
-          </a:fontRef>
-        </p:style>
-        <p:txBody>
-          <a:bodyPr rtlCol="0" anchor="ctr"/>
-          <a:lstStyle/>
-          <a:p>
-            <a:pPr algn="ctr"/>
-          </a:p>
-        </p:txBody>
-      </p:sp>
-      <p:sp>
-        <p:nvSpPr>
-          <p:cNvPr id="17" name="TextBox 16"/>
-          <p:cNvSpPr txBox="1"/>
-          <p:nvPr/>
-        </p:nvSpPr>
-        <p:spPr>
-          <a:xfrm>
-            <a:off x="8156448" y="1719072"/>
-            <a:ext cx="3090672" cy="1371600"/>
-          </a:xfrm>
-          <a:prstGeom prst="rect">
-            <a:avLst/>
-          </a:prstGeom>
-          <a:noFill/>
-        </p:spPr>
-        <p:txBody>
-          <a:bodyPr wrap="square" lIns="0" rIns="0" tIns="0" bIns="0">
-            <a:spAutoFit/>
-          </a:bodyPr>
-          <a:lstStyle/>
-          <a:p>
-            <a:pPr algn="l">
-              <a:spcAft>
-                <a:spcPts val="200"/>
-              </a:spcAft>
-            </a:pPr>
-            <a:r>
-              <a:rPr sz="1350" b="1">
-                <a:solidFill>
-                  <a:srgbClr val="E9EEF4"/>
-                </a:solidFill>
-                <a:latin typeface="Calibri"/>
-              </a:rPr>
-              <a:t>18-feature surface classifier</a:t>
-            </a:r>
-          </a:p>
-          <a:p>
-            <a:pPr algn="l">
-              <a:spcAft>
-                <a:spcPts val="300"/>
-              </a:spcAft>
-            </a:pPr>
-            <a:r>
-              <a:rPr sz="4000" b="1">
-                <a:solidFill>
-                  <a:srgbClr val="F0C040"/>
-                </a:solidFill>
-                <a:latin typeface="Consolas"/>
-              </a:rPr>
-              <a:t>0.831</a:t>
-            </a:r>
-          </a:p>
-          <a:p>
-            <a:pPr algn="l">
-              <a:lnSpc>
-                <a:spcPct val="116000"/>
-              </a:lnSpc>
-              <a:spcAft>
-                <a:spcPts val="0"/>
-              </a:spcAft>
-            </a:pPr>
-            <a:r>
-              <a:rPr sz="1150" b="0">
-                <a:solidFill>
-                  <a:srgbClr val="98A3B0"/>
-                </a:solidFill>
-                <a:latin typeface="Calibri"/>
-              </a:rPr>
-              <a:t>supervised single-text</a:t>
-            </a:r>
-          </a:p>
-          <a:p>
-            <a:pPr algn="l">
-              <a:lnSpc>
-                <a:spcPct val="116000"/>
-              </a:lnSpc>
-              <a:spcAft>
-                <a:spcPts val="0"/>
-              </a:spcAft>
-            </a:pPr>
-            <a:r>
-              <a:rPr sz="1150" b="0">
-                <a:solidFill>
-                  <a:srgbClr val="98A3B0"/>
-                </a:solidFill>
-                <a:latin typeface="Calibri"/>
-              </a:rPr>
-              <a:t>authorship labelling</a:t>
-            </a:r>
-          </a:p>
-        </p:txBody>
-      </p:sp>
-      <p:sp>
-        <p:nvSpPr>
-          <p:cNvPr id="18" name="Rectangle 17"/>
-          <p:cNvSpPr/>
-          <p:nvPr/>
-        </p:nvSpPr>
-        <p:spPr>
-          <a:xfrm>
-            <a:off x="8156448" y="3145536"/>
-            <a:ext cx="3090672" cy="137160"/>
-          </a:xfrm>
-          <a:prstGeom prst="rect">
-            <a:avLst/>
-          </a:prstGeom>
-          <a:solidFill>
-            <a:srgbClr val="1A1F2E"/>
-          </a:solidFill>
-          <a:ln>
-            <a:noFill/>
-          </a:ln>
-          <a:effectLst/>
-        </p:spPr>
-        <p:style>
-          <a:lnRef idx="1">
-            <a:schemeClr val="accent1"/>
-          </a:lnRef>
-          <a:fillRef idx="3">
-            <a:schemeClr val="accent1"/>
-          </a:fillRef>
-          <a:effectRef idx="2">
-            <a:schemeClr val="accent1"/>
-          </a:effectRef>
-          <a:fontRef idx="minor">
-            <a:schemeClr val="lt1"/>
-          </a:fontRef>
-        </p:style>
-        <p:txBody>
-          <a:bodyPr rtlCol="0" anchor="ctr"/>
-          <a:lstStyle/>
-          <a:p>
-            <a:pPr algn="ctr"/>
+            <a:endParaRPr/>
           </a:p>
         </p:txBody>
       </p:sp>
@@ -7832,6 +8091,7 @@
           <a:lstStyle/>
           <a:p>
             <a:pPr algn="ctr"/>
+            <a:endParaRPr/>
           </a:p>
         </p:txBody>
       </p:sp>
@@ -7852,7 +8112,7 @@
           <a:noFill/>
         </p:spPr>
         <p:txBody>
-          <a:bodyPr wrap="square" lIns="0" rIns="0" tIns="0" bIns="0">
+          <a:bodyPr wrap="square" lIns="0" tIns="0" rIns="0" bIns="0">
             <a:spAutoFit/>
           </a:bodyPr>
           <a:lstStyle/>
@@ -7891,7 +8151,7 @@
           <a:noFill/>
         </p:spPr>
         <p:txBody>
-          <a:bodyPr wrap="square" lIns="0" rIns="0" tIns="0" bIns="0">
+          <a:bodyPr wrap="square" lIns="0" tIns="0" rIns="0" bIns="0">
             <a:spAutoFit/>
           </a:bodyPr>
           <a:lstStyle/>
@@ -7930,7 +8190,7 @@
           <a:noFill/>
         </p:spPr>
         <p:txBody>
-          <a:bodyPr wrap="square" lIns="0" rIns="0" tIns="0" bIns="0">
+          <a:bodyPr wrap="square" lIns="0" tIns="0" rIns="0" bIns="0">
             <a:spAutoFit/>
           </a:bodyPr>
           <a:lstStyle/>
@@ -7950,7 +8210,7 @@
                 </a:solidFill>
                 <a:latin typeface="Calibri"/>
               </a:rPr>
-              <a:t>Only the length rule is matched to the model's task item-for-item </a:t>
+              <a:t>The 0.831 classifier is a different evaluation procedure; the only matched comparator is the length rule </a:t>
             </a:r>
             <a:r>
               <a:rPr sz="1250" b="0">
@@ -7968,7 +8228,7 @@
                 </a:solidFill>
                 <a:latin typeface="Calibri"/>
               </a:rPr>
-              <a:t>.  The classifier is a different evaluation procedure — a cost criterion, not a matched score.</a:t>
+              <a:t>.</a:t>
             </a:r>
           </a:p>
         </p:txBody>
@@ -8016,6 +8276,7 @@
           <a:lstStyle/>
           <a:p>
             <a:pPr algn="ctr"/>
+            <a:endParaRPr/>
           </a:p>
         </p:txBody>
       </p:sp>
@@ -8036,7 +8297,7 @@
           <a:noFill/>
         </p:spPr>
         <p:txBody>
-          <a:bodyPr wrap="square" lIns="0" rIns="0" tIns="0" bIns="0">
+          <a:bodyPr wrap="square" lIns="0" tIns="0" rIns="0" bIns="0">
             <a:spAutoFit/>
           </a:bodyPr>
           <a:lstStyle/>
@@ -8069,7 +8330,7 @@
                 </a:solidFill>
                 <a:latin typeface="Consolas"/>
               </a:rPr>
-              <a:t>+0.381 [0.188, 0.566]</a:t>
+              <a:t>+0.381 [+0.188, +0.566]</a:t>
             </a:r>
           </a:p>
           <a:p>
@@ -8136,6 +8397,7 @@
           <a:lstStyle/>
           <a:p>
             <a:pPr algn="ctr"/>
+            <a:endParaRPr/>
           </a:p>
         </p:txBody>
       </p:sp>
@@ -8156,7 +8418,7 @@
           <a:noFill/>
         </p:spPr>
         <p:txBody>
-          <a:bodyPr wrap="square" lIns="0" rIns="0" tIns="0" bIns="0">
+          <a:bodyPr wrap="square" lIns="0" tIns="0" rIns="0" bIns="0">
             <a:spAutoFit/>
           </a:bodyPr>
           <a:lstStyle/>
@@ -8240,6 +8502,7 @@
           <a:lstStyle/>
           <a:p>
             <a:pPr algn="ctr"/>
+            <a:endParaRPr/>
           </a:p>
         </p:txBody>
       </p:sp>
@@ -8260,7 +8523,7 @@
           <a:noFill/>
         </p:spPr>
         <p:txBody>
-          <a:bodyPr wrap="square" lIns="0" rIns="0" tIns="0" bIns="0">
+          <a:bodyPr wrap="square" lIns="0" tIns="0" rIns="0" bIns="0">
             <a:spAutoFit/>
           </a:bodyPr>
           <a:lstStyle/>
@@ -8311,7 +8574,7 @@
           <a:noFill/>
         </p:spPr>
         <p:txBody>
-          <a:bodyPr wrap="square" lIns="0" rIns="0" tIns="0" bIns="0">
+          <a:bodyPr wrap="square" lIns="0" tIns="0" rIns="0" bIns="0">
             <a:spAutoFit/>
           </a:bodyPr>
           <a:lstStyle/>
@@ -8374,6 +8637,7 @@
           <a:lstStyle/>
           <a:p>
             <a:pPr algn="ctr"/>
+            <a:endParaRPr/>
           </a:p>
         </p:txBody>
       </p:sp>
@@ -8394,7 +8658,7 @@
           <a:noFill/>
         </p:spPr>
         <p:txBody>
-          <a:bodyPr wrap="square" lIns="0" rIns="0" tIns="0" bIns="0">
+          <a:bodyPr wrap="square" lIns="0" tIns="0" rIns="0" bIns="0">
             <a:spAutoFit/>
           </a:bodyPr>
           <a:lstStyle/>
@@ -8437,7 +8701,7 @@
 </file>
 
 <file path=ppt/slides/slide6.xml><?xml version="1.0" encoding="utf-8"?>
-<p:sld xmlns:a="http://schemas.openxmlformats.org/drawingml/2006/main" xmlns:p="http://schemas.openxmlformats.org/presentationml/2006/main" xmlns:r="http://schemas.openxmlformats.org/officeDocument/2006/relationships">
+<p:sld xmlns:a="http://schemas.openxmlformats.org/drawingml/2006/main" xmlns:r="http://schemas.openxmlformats.org/officeDocument/2006/relationships" xmlns:p="http://schemas.openxmlformats.org/presentationml/2006/main">
   <p:cSld>
     <p:bg>
       <p:bgPr>
@@ -8453,7 +8717,14 @@
         <p:cNvGrpSpPr/>
         <p:nvPr/>
       </p:nvGrpSpPr>
-      <p:grpSpPr/>
+      <p:grpSpPr>
+        <a:xfrm>
+          <a:off x="0" y="0"/>
+          <a:ext cx="0" cy="0"/>
+          <a:chOff x="0" y="0"/>
+          <a:chExt cx="0" cy="0"/>
+        </a:xfrm>
+      </p:grpSpPr>
       <p:sp>
         <p:nvSpPr>
           <p:cNvPr id="2" name="TextBox 1"/>
@@ -8471,7 +8742,7 @@
           <a:noFill/>
         </p:spPr>
         <p:txBody>
-          <a:bodyPr wrap="square" lIns="0" rIns="0" tIns="0" bIns="0">
+          <a:bodyPr wrap="square" lIns="0" tIns="0" rIns="0" bIns="0">
             <a:spAutoFit/>
           </a:bodyPr>
           <a:lstStyle/>
@@ -8510,7 +8781,7 @@
           <a:noFill/>
         </p:spPr>
         <p:txBody>
-          <a:bodyPr wrap="square" lIns="0" rIns="0" tIns="0" bIns="0">
+          <a:bodyPr wrap="square" lIns="0" tIns="0" rIns="0" bIns="0">
             <a:spAutoFit/>
           </a:bodyPr>
           <a:lstStyle/>
@@ -8552,7 +8823,7 @@
           <a:noFill/>
         </p:spPr>
         <p:txBody>
-          <a:bodyPr wrap="square" lIns="0" rIns="0" tIns="0" bIns="0">
+          <a:bodyPr wrap="square" lIns="0" tIns="0" rIns="0" bIns="0">
             <a:spAutoFit/>
           </a:bodyPr>
           <a:lstStyle/>
@@ -8629,6 +8900,7 @@
           <a:lstStyle/>
           <a:p>
             <a:pPr algn="ctr"/>
+            <a:endParaRPr/>
           </a:p>
         </p:txBody>
       </p:sp>
@@ -8673,6 +8945,7 @@
           <a:lstStyle/>
           <a:p>
             <a:pPr algn="ctr"/>
+            <a:endParaRPr/>
           </a:p>
         </p:txBody>
       </p:sp>
@@ -8693,7 +8966,7 @@
           <a:noFill/>
         </p:spPr>
         <p:txBody>
-          <a:bodyPr wrap="square" lIns="0" rIns="0" tIns="0" bIns="0">
+          <a:bodyPr wrap="square" lIns="0" tIns="0" rIns="0" bIns="0">
             <a:spAutoFit/>
           </a:bodyPr>
           <a:lstStyle/>
@@ -8744,7 +9017,7 @@
           <a:noFill/>
         </p:spPr>
         <p:txBody>
-          <a:bodyPr wrap="square" lIns="0" rIns="0" tIns="0" bIns="0">
+          <a:bodyPr wrap="square" lIns="0" tIns="0" rIns="0" bIns="0">
             <a:spAutoFit/>
           </a:bodyPr>
           <a:lstStyle/>
@@ -8786,7 +9059,7 @@
           <a:noFill/>
         </p:spPr>
         <p:txBody>
-          <a:bodyPr wrap="square" lIns="0" rIns="0" tIns="0" bIns="0">
+          <a:bodyPr wrap="square" lIns="0" tIns="0" rIns="0" bIns="0">
             <a:spAutoFit/>
           </a:bodyPr>
           <a:lstStyle/>
@@ -8828,7 +9101,7 @@
           <a:noFill/>
         </p:spPr>
         <p:txBody>
-          <a:bodyPr wrap="square" lIns="0" rIns="0" tIns="0" bIns="0">
+          <a:bodyPr wrap="square" lIns="0" tIns="0" rIns="0" bIns="0">
             <a:spAutoFit/>
           </a:bodyPr>
           <a:lstStyle/>
@@ -8893,6 +9166,7 @@
           <a:lstStyle/>
           <a:p>
             <a:pPr algn="ctr"/>
+            <a:endParaRPr/>
           </a:p>
         </p:txBody>
       </p:sp>
@@ -8937,6 +9211,7 @@
           <a:lstStyle/>
           <a:p>
             <a:pPr algn="ctr"/>
+            <a:endParaRPr/>
           </a:p>
         </p:txBody>
       </p:sp>
@@ -8957,7 +9232,7 @@
           <a:noFill/>
         </p:spPr>
         <p:txBody>
-          <a:bodyPr wrap="square" lIns="0" rIns="0" tIns="0" bIns="0">
+          <a:bodyPr wrap="square" lIns="0" tIns="0" rIns="0" bIns="0">
             <a:spAutoFit/>
           </a:bodyPr>
           <a:lstStyle/>
@@ -9008,7 +9283,7 @@
           <a:noFill/>
         </p:spPr>
         <p:txBody>
-          <a:bodyPr wrap="square" lIns="0" rIns="0" tIns="0" bIns="0">
+          <a:bodyPr wrap="square" lIns="0" tIns="0" rIns="0" bIns="0">
             <a:spAutoFit/>
           </a:bodyPr>
           <a:lstStyle/>
@@ -9050,7 +9325,7 @@
           <a:noFill/>
         </p:spPr>
         <p:txBody>
-          <a:bodyPr wrap="square" lIns="0" rIns="0" tIns="0" bIns="0">
+          <a:bodyPr wrap="square" lIns="0" tIns="0" rIns="0" bIns="0">
             <a:spAutoFit/>
           </a:bodyPr>
           <a:lstStyle/>
@@ -9092,7 +9367,7 @@
           <a:noFill/>
         </p:spPr>
         <p:txBody>
-          <a:bodyPr wrap="square" lIns="0" rIns="0" tIns="0" bIns="0">
+          <a:bodyPr wrap="square" lIns="0" tIns="0" rIns="0" bIns="0">
             <a:spAutoFit/>
           </a:bodyPr>
           <a:lstStyle/>
@@ -9157,6 +9432,7 @@
           <a:lstStyle/>
           <a:p>
             <a:pPr algn="ctr"/>
+            <a:endParaRPr/>
           </a:p>
         </p:txBody>
       </p:sp>
@@ -9201,6 +9477,7 @@
           <a:lstStyle/>
           <a:p>
             <a:pPr algn="ctr"/>
+            <a:endParaRPr/>
           </a:p>
         </p:txBody>
       </p:sp>
@@ -9221,7 +9498,7 @@
           <a:noFill/>
         </p:spPr>
         <p:txBody>
-          <a:bodyPr wrap="square" lIns="0" rIns="0" tIns="0" bIns="0">
+          <a:bodyPr wrap="square" lIns="0" tIns="0" rIns="0" bIns="0">
             <a:spAutoFit/>
           </a:bodyPr>
           <a:lstStyle/>
@@ -9272,7 +9549,7 @@
           <a:noFill/>
         </p:spPr>
         <p:txBody>
-          <a:bodyPr wrap="square" lIns="0" rIns="0" tIns="0" bIns="0">
+          <a:bodyPr wrap="square" lIns="0" tIns="0" rIns="0" bIns="0">
             <a:spAutoFit/>
           </a:bodyPr>
           <a:lstStyle/>
@@ -9314,7 +9591,7 @@
           <a:noFill/>
         </p:spPr>
         <p:txBody>
-          <a:bodyPr wrap="square" lIns="0" rIns="0" tIns="0" bIns="0">
+          <a:bodyPr wrap="square" lIns="0" tIns="0" rIns="0" bIns="0">
             <a:spAutoFit/>
           </a:bodyPr>
           <a:lstStyle/>
@@ -9356,7 +9633,7 @@
           <a:noFill/>
         </p:spPr>
         <p:txBody>
-          <a:bodyPr wrap="square" lIns="0" rIns="0" tIns="0" bIns="0">
+          <a:bodyPr wrap="square" lIns="0" tIns="0" rIns="0" bIns="0">
             <a:spAutoFit/>
           </a:bodyPr>
           <a:lstStyle/>
@@ -9424,6 +9701,7 @@
           <a:lstStyle/>
           <a:p>
             <a:pPr algn="ctr"/>
+            <a:endParaRPr/>
           </a:p>
         </p:txBody>
       </p:sp>
@@ -9444,7 +9722,7 @@
           <a:noFill/>
         </p:spPr>
         <p:txBody>
-          <a:bodyPr wrap="square" lIns="0" rIns="0" tIns="0" bIns="0">
+          <a:bodyPr wrap="square" lIns="0" tIns="0" rIns="0" bIns="0">
             <a:spAutoFit/>
           </a:bodyPr>
           <a:lstStyle/>
@@ -9507,6 +9785,7 @@
           <a:lstStyle/>
           <a:p>
             <a:pPr algn="ctr"/>
+            <a:endParaRPr/>
           </a:p>
         </p:txBody>
       </p:sp>
@@ -9527,7 +9806,7 @@
           <a:noFill/>
         </p:spPr>
         <p:txBody>
-          <a:bodyPr wrap="square" lIns="0" rIns="0" tIns="0" bIns="0">
+          <a:bodyPr wrap="square" lIns="0" tIns="0" rIns="0" bIns="0">
             <a:spAutoFit/>
           </a:bodyPr>
           <a:lstStyle/>

</xml_diff>

<commit_message>
Digital Minds submission completed and final repository update
</commit_message>
<xml_diff>
--- a/Digital_Minds_Track3_Slides.pptx
+++ b/Digital_Minds_Track3_Slides.pptx
@@ -3156,8 +3156,8 @@
         </p:nvSpPr>
         <p:spPr>
           <a:xfrm>
-            <a:off x="658368" y="658368"/>
-            <a:ext cx="10874959" cy="274320"/>
+            <a:off x="870034" y="521208"/>
+            <a:ext cx="10874959" cy="215444"/>
           </a:xfrm>
           <a:prstGeom prst="rect">
             <a:avLst/>
@@ -3176,9 +3176,9 @@
               </a:spcAft>
             </a:pPr>
             <a:r>
-              <a:rPr sz="1200" b="0" spc="100">
-                <a:solidFill>
-                  <a:srgbClr val="98A3B0"/>
+              <a:rPr sz="1400" b="0" spc="100" dirty="0">
+                <a:solidFill>
+                  <a:schemeClr val="bg1"/>
                 </a:solidFill>
                 <a:latin typeface="Consolas"/>
               </a:rPr>
@@ -3218,7 +3218,7 @@
               </a:spcAft>
             </a:pPr>
             <a:r>
-              <a:rPr sz="5000" b="1">
+              <a:rPr sz="5000" b="1" dirty="0">
                 <a:solidFill>
                   <a:srgbClr val="E9EEF4"/>
                 </a:solidFill>
@@ -3237,7 +3237,7 @@
               </a:spcAft>
             </a:pPr>
             <a:r>
-              <a:rPr sz="3000" b="0">
+              <a:rPr sz="3000" b="0" dirty="0">
                 <a:solidFill>
                   <a:srgbClr val="F0C040"/>
                 </a:solidFill>
@@ -3256,7 +3256,7 @@
         </p:nvSpPr>
         <p:spPr>
           <a:xfrm>
-            <a:off x="658368" y="3401568"/>
+            <a:off x="658368" y="2928213"/>
             <a:ext cx="2377440" cy="19050"/>
           </a:xfrm>
           <a:prstGeom prst="rect">
@@ -3301,8 +3301,8 @@
         </p:nvSpPr>
         <p:spPr>
           <a:xfrm>
-            <a:off x="658368" y="3703320"/>
-            <a:ext cx="8778240" cy="914400"/>
+            <a:off x="658368" y="3272356"/>
+            <a:ext cx="8778240" cy="795026"/>
           </a:xfrm>
           <a:prstGeom prst="rect">
             <a:avLst/>
@@ -3326,7 +3326,7 @@
             <a:r>
               <a:rPr sz="2100" b="0" dirty="0">
                 <a:solidFill>
-                  <a:srgbClr val="98A3B0"/>
+                  <a:schemeClr val="bg1"/>
                 </a:solidFill>
                 <a:latin typeface="Calibri"/>
               </a:rPr>
@@ -3335,7 +3335,7 @@
             <a:r>
               <a:rPr sz="2100" b="0" dirty="0" err="1">
                 <a:solidFill>
-                  <a:srgbClr val="98A3B0"/>
+                  <a:schemeClr val="bg1"/>
                 </a:solidFill>
                 <a:latin typeface="Calibri"/>
               </a:rPr>
@@ -3344,7 +3344,7 @@
             <a:r>
               <a:rPr sz="2100" b="0" dirty="0">
                 <a:solidFill>
-                  <a:srgbClr val="98A3B0"/>
+                  <a:schemeClr val="bg1"/>
                 </a:solidFill>
                 <a:latin typeface="Calibri"/>
               </a:rPr>
@@ -3361,8 +3361,8 @@
         </p:nvSpPr>
         <p:spPr>
           <a:xfrm>
-            <a:off x="658368" y="5074920"/>
-            <a:ext cx="3657600" cy="1005840"/>
+            <a:off x="658368" y="4818211"/>
+            <a:ext cx="3657600" cy="868699"/>
           </a:xfrm>
           <a:prstGeom prst="rect">
             <a:avLst/>
@@ -3381,7 +3381,7 @@
               </a:spcAft>
             </a:pPr>
             <a:r>
-              <a:rPr sz="1600" b="1">
+              <a:rPr sz="1600" b="1" dirty="0">
                 <a:solidFill>
                   <a:srgbClr val="E9EEF4"/>
                 </a:solidFill>
@@ -3400,7 +3400,7 @@
               </a:spcAft>
             </a:pPr>
             <a:r>
-              <a:rPr sz="1200" b="0">
+              <a:rPr sz="1600" b="0" dirty="0">
                 <a:solidFill>
                   <a:srgbClr val="98A3B0"/>
                 </a:solidFill>
@@ -3419,7 +3419,7 @@
               </a:spcAft>
             </a:pPr>
             <a:r>
-              <a:rPr sz="1200" b="0">
+              <a:rPr sz="1600" b="0" dirty="0">
                 <a:solidFill>
                   <a:srgbClr val="98A3B0"/>
                 </a:solidFill>
@@ -3438,8 +3438,8 @@
         </p:nvSpPr>
         <p:spPr>
           <a:xfrm>
-            <a:off x="4590288" y="5074920"/>
-            <a:ext cx="3657600" cy="1005840"/>
+            <a:off x="4590288" y="4818211"/>
+            <a:ext cx="3657600" cy="817660"/>
           </a:xfrm>
           <a:prstGeom prst="rect">
             <a:avLst/>
@@ -3458,7 +3458,7 @@
               </a:spcAft>
             </a:pPr>
             <a:r>
-              <a:rPr sz="1600" b="1" dirty="0">
+              <a:rPr sz="1500" b="1" dirty="0">
                 <a:solidFill>
                   <a:srgbClr val="E9EEF4"/>
                 </a:solidFill>
@@ -3477,7 +3477,7 @@
               </a:spcAft>
             </a:pPr>
             <a:r>
-              <a:rPr sz="1200" b="0" dirty="0">
+              <a:rPr sz="1500" b="0" dirty="0">
                 <a:solidFill>
                   <a:srgbClr val="98A3B0"/>
                 </a:solidFill>
@@ -3496,7 +3496,7 @@
               </a:spcAft>
             </a:pPr>
             <a:r>
-              <a:rPr sz="1200" b="0" dirty="0">
+              <a:rPr sz="1500" b="0" dirty="0">
                 <a:solidFill>
                   <a:srgbClr val="98A3B0"/>
                 </a:solidFill>
@@ -3515,8 +3515,8 @@
         </p:nvSpPr>
         <p:spPr>
           <a:xfrm>
-            <a:off x="8241487" y="5074920"/>
-            <a:ext cx="3291840" cy="1005840"/>
+            <a:off x="7653867" y="5074920"/>
+            <a:ext cx="4091126" cy="469359"/>
           </a:xfrm>
           <a:prstGeom prst="rect">
             <a:avLst/>
@@ -3535,7 +3535,7 @@
               </a:spcAft>
             </a:pPr>
             <a:r>
-              <a:rPr sz="1300" b="1" dirty="0">
+              <a:rPr sz="1400" b="1" dirty="0">
                 <a:solidFill>
                   <a:srgbClr val="F0C040"/>
                 </a:solidFill>
@@ -3551,44 +3551,44 @@
               </a:spcAft>
             </a:pPr>
             <a:r>
-              <a:rPr sz="1150" b="0" dirty="0">
-                <a:solidFill>
-                  <a:srgbClr val="98A3B0"/>
+              <a:rPr sz="1400" b="0" dirty="0">
+                <a:solidFill>
+                  <a:schemeClr val="bg1"/>
                 </a:solidFill>
                 <a:latin typeface="Consolas"/>
               </a:rPr>
               <a:t>github.com/</a:t>
             </a:r>
             <a:r>
-              <a:rPr sz="1150" b="0" dirty="0" err="1">
-                <a:solidFill>
-                  <a:srgbClr val="98A3B0"/>
+              <a:rPr sz="1400" b="0" dirty="0" err="1">
+                <a:solidFill>
+                  <a:schemeClr val="bg1"/>
                 </a:solidFill>
                 <a:latin typeface="Consolas"/>
               </a:rPr>
               <a:t>UbaJaz</a:t>
             </a:r>
             <a:r>
-              <a:rPr sz="1150" b="0" dirty="0">
-                <a:solidFill>
-                  <a:srgbClr val="98A3B0"/>
+              <a:rPr sz="1400" b="0" dirty="0">
+                <a:solidFill>
+                  <a:schemeClr val="bg1"/>
                 </a:solidFill>
                 <a:latin typeface="Consolas"/>
               </a:rPr>
               <a:t>/</a:t>
             </a:r>
             <a:r>
-              <a:rPr sz="1150" b="0" dirty="0" err="1">
-                <a:solidFill>
-                  <a:srgbClr val="98A3B0"/>
+              <a:rPr sz="1400" b="0" dirty="0" err="1">
+                <a:solidFill>
+                  <a:schemeClr val="bg1"/>
                 </a:solidFill>
                 <a:latin typeface="Consolas"/>
               </a:rPr>
               <a:t>Digital_Minds_Research</a:t>
             </a:r>
-            <a:endParaRPr sz="1150" b="0" dirty="0">
+            <a:endParaRPr sz="1400" b="0" dirty="0">
               <a:solidFill>
-                <a:srgbClr val="98A3B0"/>
+                <a:schemeClr val="bg1"/>
               </a:solidFill>
               <a:latin typeface="Consolas"/>
             </a:endParaRPr>
@@ -3648,8 +3648,8 @@
         </p:nvSpPr>
         <p:spPr>
           <a:xfrm>
-            <a:off x="658368" y="6400800"/>
-            <a:ext cx="10874959" cy="274320"/>
+            <a:off x="658368" y="6426555"/>
+            <a:ext cx="10874959" cy="216854"/>
           </a:xfrm>
           <a:prstGeom prst="rect">
             <a:avLst/>
@@ -3671,18 +3671,18 @@
               </a:spcAft>
             </a:pPr>
             <a:r>
-              <a:rPr sz="1050" b="1">
-                <a:solidFill>
-                  <a:srgbClr val="F0C040"/>
+              <a:rPr sz="1200" b="1" dirty="0">
+                <a:solidFill>
+                  <a:schemeClr val="bg1"/>
                 </a:solidFill>
                 <a:latin typeface="Consolas"/>
               </a:rPr>
               <a:t>1</a:t>
             </a:r>
             <a:r>
-              <a:rPr sz="1050" b="0">
-                <a:solidFill>
-                  <a:srgbClr val="6B7683"/>
+              <a:rPr sz="1200" b="0" dirty="0">
+                <a:solidFill>
+                  <a:schemeClr val="bg1"/>
                 </a:solidFill>
                 <a:latin typeface="Consolas"/>
               </a:rPr>
@@ -3752,7 +3752,7 @@
               </a:spcAft>
             </a:pPr>
             <a:r>
-              <a:rPr sz="1150" b="0" spc="160">
+              <a:rPr sz="1150" b="0" spc="160" dirty="0">
                 <a:solidFill>
                   <a:srgbClr val="F0C040"/>
                 </a:solidFill>
@@ -3794,7 +3794,7 @@
               </a:spcAft>
             </a:pPr>
             <a:r>
-              <a:rPr sz="3100" b="1">
+              <a:rPr sz="3100" b="1" dirty="0">
                 <a:solidFill>
                   <a:srgbClr val="E9EEF4"/>
                 </a:solidFill>
@@ -3836,7 +3836,7 @@
               </a:spcAft>
             </a:pPr>
             <a:r>
-              <a:rPr sz="1450" b="1">
+              <a:rPr sz="1450" b="1" dirty="0">
                 <a:solidFill>
                   <a:srgbClr val="E9EEF4"/>
                 </a:solidFill>
@@ -3845,7 +3845,7 @@
               <a:t>Two confounds block any black-box test. </a:t>
             </a:r>
             <a:r>
-              <a:rPr sz="1450" b="0">
+              <a:rPr sz="1450" b="0" dirty="0">
                 <a:solidFill>
                   <a:srgbClr val="98A3B0"/>
                 </a:solidFill>
@@ -3912,7 +3912,7 @@
         <p:spPr>
           <a:xfrm>
             <a:off x="804672" y="2395728"/>
-            <a:ext cx="1920240" cy="310896"/>
+            <a:ext cx="1920240" cy="271100"/>
           </a:xfrm>
           <a:prstGeom prst="rect">
             <a:avLst/>
@@ -3934,7 +3934,7 @@
               </a:spcAft>
             </a:pPr>
             <a:r>
-              <a:rPr sz="2000" b="1">
+              <a:rPr sz="1500" b="1" dirty="0">
                 <a:solidFill>
                   <a:srgbClr val="4A9B4A"/>
                 </a:solidFill>
@@ -3943,7 +3943,7 @@
               <a:t>M   </a:t>
             </a:r>
             <a:r>
-              <a:rPr sz="1000" b="1">
+              <a:rPr sz="1500" b="1" dirty="0">
                 <a:solidFill>
                   <a:srgbClr val="6B7683"/>
                 </a:solidFill>
@@ -3963,7 +3963,7 @@
         <p:spPr>
           <a:xfrm>
             <a:off x="804672" y="2834640"/>
-            <a:ext cx="1920240" cy="868680"/>
+            <a:ext cx="1920240" cy="751552"/>
           </a:xfrm>
           <a:prstGeom prst="rect">
             <a:avLst/>
@@ -3982,7 +3982,7 @@
               </a:spcAft>
             </a:pPr>
             <a:r>
-              <a:rPr sz="1350" b="1">
+              <a:rPr sz="1400" b="1" dirty="0">
                 <a:solidFill>
                   <a:srgbClr val="E9EEF4"/>
                 </a:solidFill>
@@ -4001,7 +4001,7 @@
               </a:spcAft>
             </a:pPr>
             <a:r>
-              <a:rPr sz="1150" b="0">
+              <a:rPr sz="1400" b="0" dirty="0">
                 <a:solidFill>
                   <a:srgbClr val="98A3B0"/>
                 </a:solidFill>
@@ -4020,7 +4020,7 @@
               </a:spcAft>
             </a:pPr>
             <a:r>
-              <a:rPr sz="1150" b="0">
+              <a:rPr sz="1400" b="0" dirty="0">
                 <a:solidFill>
                   <a:srgbClr val="98A3B0"/>
                 </a:solidFill>
@@ -4087,7 +4087,7 @@
         <p:spPr>
           <a:xfrm>
             <a:off x="3200400" y="2395728"/>
-            <a:ext cx="1920240" cy="310896"/>
+            <a:ext cx="1920240" cy="271100"/>
           </a:xfrm>
           <a:prstGeom prst="rect">
             <a:avLst/>
@@ -4109,7 +4109,7 @@
               </a:spcAft>
             </a:pPr>
             <a:r>
-              <a:rPr sz="2000" b="1" dirty="0">
+              <a:rPr sz="1500" b="1" dirty="0">
                 <a:solidFill>
                   <a:srgbClr val="4A90D9"/>
                 </a:solidFill>
@@ -4118,7 +4118,7 @@
               <a:t>N   </a:t>
             </a:r>
             <a:r>
-              <a:rPr sz="1000" b="1" dirty="0">
+              <a:rPr sz="1500" b="1" dirty="0">
                 <a:solidFill>
                   <a:srgbClr val="6B7683"/>
                 </a:solidFill>
@@ -4138,7 +4138,7 @@
         <p:spPr>
           <a:xfrm>
             <a:off x="3200400" y="2834640"/>
-            <a:ext cx="1920240" cy="868680"/>
+            <a:ext cx="1920240" cy="751552"/>
           </a:xfrm>
           <a:prstGeom prst="rect">
             <a:avLst/>
@@ -4157,7 +4157,7 @@
               </a:spcAft>
             </a:pPr>
             <a:r>
-              <a:rPr sz="1350" b="1">
+              <a:rPr sz="1400" b="1" dirty="0">
                 <a:solidFill>
                   <a:srgbClr val="E9EEF4"/>
                 </a:solidFill>
@@ -4176,7 +4176,7 @@
               </a:spcAft>
             </a:pPr>
             <a:r>
-              <a:rPr sz="1150" b="0">
+              <a:rPr sz="1400" b="0" dirty="0">
                 <a:solidFill>
                   <a:srgbClr val="98A3B0"/>
                 </a:solidFill>
@@ -4195,7 +4195,7 @@
               </a:spcAft>
             </a:pPr>
             <a:r>
-              <a:rPr sz="1150" b="0">
+              <a:rPr sz="1400" b="0" dirty="0">
                 <a:solidFill>
                   <a:srgbClr val="98A3B0"/>
                 </a:solidFill>
@@ -4262,7 +4262,7 @@
         <p:spPr>
           <a:xfrm>
             <a:off x="5596128" y="2395728"/>
-            <a:ext cx="1920240" cy="310896"/>
+            <a:ext cx="1920240" cy="271100"/>
           </a:xfrm>
           <a:prstGeom prst="rect">
             <a:avLst/>
@@ -4284,7 +4284,7 @@
               </a:spcAft>
             </a:pPr>
             <a:r>
-              <a:rPr sz="2000" b="1">
+              <a:rPr sz="1500" b="1" dirty="0">
                 <a:solidFill>
                   <a:srgbClr val="98A3B0"/>
                 </a:solidFill>
@@ -4293,7 +4293,7 @@
               <a:t>F   </a:t>
             </a:r>
             <a:r>
-              <a:rPr sz="1000" b="1">
+              <a:rPr sz="1500" b="1" dirty="0">
                 <a:solidFill>
                   <a:srgbClr val="6B7683"/>
                 </a:solidFill>
@@ -4313,7 +4313,7 @@
         <p:spPr>
           <a:xfrm>
             <a:off x="5596128" y="2834640"/>
-            <a:ext cx="1920240" cy="868680"/>
+            <a:ext cx="1920240" cy="751552"/>
           </a:xfrm>
           <a:prstGeom prst="rect">
             <a:avLst/>
@@ -4332,7 +4332,7 @@
               </a:spcAft>
             </a:pPr>
             <a:r>
-              <a:rPr sz="1350" b="1">
+              <a:rPr sz="1400" b="1" dirty="0">
                 <a:solidFill>
                   <a:srgbClr val="E9EEF4"/>
                 </a:solidFill>
@@ -4351,13 +4351,31 @@
               </a:spcAft>
             </a:pPr>
             <a:r>
-              <a:rPr sz="1150" b="0">
+              <a:rPr sz="1400" b="0" dirty="0">
                 <a:solidFill>
                   <a:srgbClr val="98A3B0"/>
                 </a:solidFill>
                 <a:latin typeface="Calibri"/>
               </a:rPr>
-              <a:t>different organisation,</a:t>
+              <a:t>different </a:t>
+            </a:r>
+            <a:r>
+              <a:rPr sz="1400" b="0" dirty="0" err="1">
+                <a:solidFill>
+                  <a:srgbClr val="98A3B0"/>
+                </a:solidFill>
+                <a:latin typeface="Calibri"/>
+              </a:rPr>
+              <a:t>organisation</a:t>
+            </a:r>
+            <a:r>
+              <a:rPr sz="1400" b="0" dirty="0">
+                <a:solidFill>
+                  <a:srgbClr val="98A3B0"/>
+                </a:solidFill>
+                <a:latin typeface="Calibri"/>
+              </a:rPr>
+              <a:t>,</a:t>
             </a:r>
           </a:p>
           <a:p>
@@ -4370,7 +4388,7 @@
               </a:spcAft>
             </a:pPr>
             <a:r>
-              <a:rPr sz="1150" b="0">
+              <a:rPr sz="1400" b="0" dirty="0">
                 <a:solidFill>
                   <a:srgbClr val="98A3B0"/>
                 </a:solidFill>
@@ -4985,8 +5003,8 @@
         </p:nvSpPr>
         <p:spPr>
           <a:xfrm>
-            <a:off x="8339328" y="3874685"/>
-            <a:ext cx="3200400" cy="274320"/>
+            <a:off x="8345458" y="3890963"/>
+            <a:ext cx="3200400" cy="235834"/>
           </a:xfrm>
           <a:prstGeom prst="rect">
             <a:avLst/>
@@ -5008,7 +5026,7 @@
               </a:spcAft>
             </a:pPr>
             <a:r>
-              <a:rPr sz="1200" b="1" dirty="0">
+              <a:rPr lang="en-US" sz="1300" b="1" dirty="0">
                 <a:solidFill>
                   <a:srgbClr val="F0C040"/>
                 </a:solidFill>
@@ -5017,7 +5035,7 @@
               <a:t>D  </a:t>
             </a:r>
             <a:r>
-              <a:rPr sz="1150" b="0" dirty="0">
+              <a:rPr lang="en-US" sz="1300" b="0" dirty="0">
                 <a:solidFill>
                   <a:srgbClr val="E9EEF4"/>
                 </a:solidFill>
@@ -5025,6 +5043,12 @@
               </a:rPr>
               <a:t>surface baseline — the cheap third party</a:t>
             </a:r>
+            <a:endParaRPr sz="1300" b="0" dirty="0">
+              <a:solidFill>
+                <a:srgbClr val="E9EEF4"/>
+              </a:solidFill>
+              <a:latin typeface="Calibri"/>
+            </a:endParaRPr>
           </a:p>
         </p:txBody>
       </p:sp>
@@ -5036,7 +5060,7 @@
         </p:nvSpPr>
         <p:spPr>
           <a:xfrm>
-            <a:off x="658368" y="4224528"/>
+            <a:off x="651967" y="4279392"/>
             <a:ext cx="10881360" cy="1371600"/>
           </a:xfrm>
           <a:prstGeom prst="rect">
@@ -5247,7 +5271,7 @@
               </a:spcAft>
             </a:pPr>
             <a:r>
-              <a:rPr sz="1250" b="1">
+              <a:rPr sz="1250" b="1" dirty="0">
                 <a:solidFill>
                   <a:srgbClr val="E9EEF4"/>
                 </a:solidFill>
@@ -5256,7 +5280,7 @@
               <a:t>Ground truth is constructed, not elicited. </a:t>
             </a:r>
             <a:r>
-              <a:rPr sz="1250" b="0">
+              <a:rPr sz="1250" b="0" dirty="0">
                 <a:solidFill>
                   <a:srgbClr val="98A3B0"/>
                 </a:solidFill>
@@ -5321,7 +5345,7 @@
         <p:spPr>
           <a:xfrm>
             <a:off x="658368" y="6400800"/>
-            <a:ext cx="10874959" cy="274320"/>
+            <a:ext cx="10874959" cy="216854"/>
           </a:xfrm>
           <a:prstGeom prst="rect">
             <a:avLst/>
@@ -5343,7 +5367,7 @@
               </a:spcAft>
             </a:pPr>
             <a:r>
-              <a:rPr sz="1050" b="1">
+              <a:rPr sz="1200" b="1" dirty="0">
                 <a:solidFill>
                   <a:srgbClr val="F0C040"/>
                 </a:solidFill>
@@ -5352,13 +5376,22 @@
               <a:t>2</a:t>
             </a:r>
             <a:r>
-              <a:rPr sz="1050" b="0">
+              <a:rPr sz="1200" b="0" dirty="0">
                 <a:solidFill>
                   <a:srgbClr val="6B7683"/>
                 </a:solidFill>
                 <a:latin typeface="Consolas"/>
               </a:rPr>
-              <a:t>  /  6     Question and design</a:t>
+              <a:t>  </a:t>
+            </a:r>
+            <a:r>
+              <a:rPr sz="1200" b="0" dirty="0">
+                <a:solidFill>
+                  <a:schemeClr val="bg1"/>
+                </a:solidFill>
+                <a:latin typeface="Consolas"/>
+              </a:rPr>
+              <a:t>/  6     Question and design</a:t>
             </a:r>
           </a:p>
         </p:txBody>
@@ -5555,7 +5588,7 @@
         <p:spPr>
           <a:xfrm>
             <a:off x="6903720" y="1700784"/>
-            <a:ext cx="4572000" cy="960120"/>
+            <a:ext cx="4572000" cy="909544"/>
           </a:xfrm>
           <a:prstGeom prst="rect">
             <a:avLst/>
@@ -5574,7 +5607,7 @@
               </a:spcAft>
             </a:pPr>
             <a:r>
-              <a:rPr sz="2800" b="1">
+              <a:rPr sz="2800" b="1" dirty="0">
                 <a:solidFill>
                   <a:srgbClr val="F0C040"/>
                 </a:solidFill>
@@ -5593,9 +5626,9 @@
               </a:spcAft>
             </a:pPr>
             <a:r>
-              <a:rPr sz="1250" b="0">
-                <a:solidFill>
-                  <a:srgbClr val="98A3B0"/>
+              <a:rPr sz="1250" b="0" dirty="0">
+                <a:solidFill>
+                  <a:schemeClr val="bg1"/>
                 </a:solidFill>
                 <a:latin typeface="Calibri"/>
               </a:rPr>
@@ -5613,7 +5646,7 @@
         <p:spPr>
           <a:xfrm>
             <a:off x="6903720" y="2688336"/>
-            <a:ext cx="4572000" cy="960120"/>
+            <a:ext cx="4572000" cy="909544"/>
           </a:xfrm>
           <a:prstGeom prst="rect">
             <a:avLst/>
@@ -5632,7 +5665,7 @@
               </a:spcAft>
             </a:pPr>
             <a:r>
-              <a:rPr sz="2800" b="1">
+              <a:rPr sz="2800" b="1" dirty="0">
                 <a:solidFill>
                   <a:srgbClr val="F0C040"/>
                 </a:solidFill>
@@ -5651,9 +5684,9 @@
               </a:spcAft>
             </a:pPr>
             <a:r>
-              <a:rPr sz="1250" b="0">
-                <a:solidFill>
-                  <a:srgbClr val="98A3B0"/>
+              <a:rPr sz="1250" b="0" dirty="0">
+                <a:solidFill>
+                  <a:schemeClr val="bg1"/>
                 </a:solidFill>
                 <a:latin typeface="Calibri"/>
               </a:rPr>
@@ -5671,7 +5704,7 @@
         <p:spPr>
           <a:xfrm>
             <a:off x="6903720" y="3675888"/>
-            <a:ext cx="4572000" cy="960120"/>
+            <a:ext cx="4572000" cy="909544"/>
           </a:xfrm>
           <a:prstGeom prst="rect">
             <a:avLst/>
@@ -5690,7 +5723,7 @@
               </a:spcAft>
             </a:pPr>
             <a:r>
-              <a:rPr sz="2800" b="1">
+              <a:rPr sz="2800" b="1" dirty="0">
                 <a:solidFill>
                   <a:srgbClr val="4A90D9"/>
                 </a:solidFill>
@@ -5709,13 +5742,31 @@
               </a:spcAft>
             </a:pPr>
             <a:r>
-              <a:rPr sz="1250" b="0">
-                <a:solidFill>
-                  <a:srgbClr val="98A3B0"/>
+              <a:rPr sz="1250" b="0" dirty="0">
+                <a:solidFill>
+                  <a:schemeClr val="bg1"/>
                 </a:solidFill>
                 <a:latin typeface="Calibri"/>
               </a:rPr>
-              <a:t>surface baseline on VO-D's M column once style is equalised — and the model falls to 0.500 with it</a:t>
+              <a:t>surface baseline on VO-D's M column once style is </a:t>
+            </a:r>
+            <a:r>
+              <a:rPr sz="1250" b="0" dirty="0" err="1">
+                <a:solidFill>
+                  <a:schemeClr val="bg1"/>
+                </a:solidFill>
+                <a:latin typeface="Calibri"/>
+              </a:rPr>
+              <a:t>equalised</a:t>
+            </a:r>
+            <a:r>
+              <a:rPr sz="1250" b="0" dirty="0">
+                <a:solidFill>
+                  <a:schemeClr val="bg1"/>
+                </a:solidFill>
+                <a:latin typeface="Calibri"/>
+              </a:rPr>
+              <a:t> — and the model falls to 0.500 with it</a:t>
             </a:r>
           </a:p>
         </p:txBody>
@@ -5729,7 +5780,7 @@
         <p:spPr>
           <a:xfrm>
             <a:off x="6903720" y="4645152"/>
-            <a:ext cx="4617720" cy="384048"/>
+            <a:ext cx="4617720" cy="410562"/>
           </a:xfrm>
           <a:prstGeom prst="rect">
             <a:avLst/>
@@ -5751,9 +5802,9 @@
               </a:spcAft>
             </a:pPr>
             <a:r>
-              <a:rPr sz="1150" b="0">
-                <a:solidFill>
-                  <a:srgbClr val="6B7683"/>
+              <a:rPr sz="1150" b="0" dirty="0">
+                <a:solidFill>
+                  <a:schemeClr val="bg1"/>
                 </a:solidFill>
                 <a:latin typeface="Calibri"/>
               </a:rPr>
@@ -5818,7 +5869,7 @@
         <p:spPr>
           <a:xfrm>
             <a:off x="7068312" y="5175504"/>
-            <a:ext cx="4297680" cy="914400"/>
+            <a:ext cx="4297680" cy="944233"/>
           </a:xfrm>
           <a:prstGeom prst="rect">
             <a:avLst/>
@@ -5840,7 +5891,7 @@
               </a:spcAft>
             </a:pPr>
             <a:r>
-              <a:rPr sz="1250" b="1" dirty="0">
+              <a:rPr sz="1300" b="1" dirty="0">
                 <a:solidFill>
                   <a:srgbClr val="E24A4A"/>
                 </a:solidFill>
@@ -5849,31 +5900,13 @@
               <a:t>Caveat.  </a:t>
             </a:r>
             <a:r>
-              <a:rPr sz="1250" b="0" dirty="0">
+              <a:rPr sz="1300" b="0" dirty="0">
                 <a:solidFill>
                   <a:srgbClr val="E9EEF4"/>
                 </a:solidFill>
                 <a:latin typeface="Calibri"/>
               </a:rPr>
-              <a:t>VO-D/VO-E also changed the </a:t>
-            </a:r>
-            <a:r>
-              <a:rPr sz="1250" b="0" dirty="0" err="1">
-                <a:solidFill>
-                  <a:srgbClr val="E9EEF4"/>
-                </a:solidFill>
-                <a:latin typeface="Calibri"/>
-              </a:rPr>
-              <a:t>behavioural</a:t>
-            </a:r>
-            <a:r>
-              <a:rPr sz="1250" b="0" dirty="0">
-                <a:solidFill>
-                  <a:srgbClr val="E9EEF4"/>
-                </a:solidFill>
-                <a:latin typeface="Calibri"/>
-              </a:rPr>
-              <a:t> expression of the hidden property, so they are not clean causal isolation of style: the two personas largely converged on the same recommendation.</a:t>
+              <a:t>VO-D/VO-E also changed the behavioral expression of the hidden property, so they are not clean causal isolation of style: the two personas largely converged on the same recommendation.</a:t>
             </a:r>
           </a:p>
         </p:txBody>
@@ -5974,7 +6007,7 @@
         <p:spPr>
           <a:xfrm>
             <a:off x="658368" y="6400800"/>
-            <a:ext cx="10874959" cy="274320"/>
+            <a:ext cx="10874959" cy="216854"/>
           </a:xfrm>
           <a:prstGeom prst="rect">
             <a:avLst/>
@@ -5996,7 +6029,7 @@
               </a:spcAft>
             </a:pPr>
             <a:r>
-              <a:rPr sz="1050" b="1">
+              <a:rPr sz="1200" b="1" dirty="0">
                 <a:solidFill>
                   <a:srgbClr val="F0C040"/>
                 </a:solidFill>
@@ -6005,13 +6038,22 @@
               <a:t>3</a:t>
             </a:r>
             <a:r>
-              <a:rPr sz="1050" b="0">
+              <a:rPr sz="1200" b="0" dirty="0">
                 <a:solidFill>
                   <a:srgbClr val="6B7683"/>
                 </a:solidFill>
                 <a:latin typeface="Consolas"/>
               </a:rPr>
-              <a:t>  /  6     Surface leakage</a:t>
+              <a:t>  </a:t>
+            </a:r>
+            <a:r>
+              <a:rPr sz="1200" b="0" dirty="0">
+                <a:solidFill>
+                  <a:schemeClr val="bg1"/>
+                </a:solidFill>
+                <a:latin typeface="Consolas"/>
+              </a:rPr>
+              <a:t>/  6     Surface leakage</a:t>
             </a:r>
           </a:p>
         </p:txBody>
@@ -6136,11 +6178,17 @@
           <p:cNvGraphicFramePr>
             <a:graphicFrameLocks noGrp="1"/>
           </p:cNvGraphicFramePr>
-          <p:nvPr/>
+          <p:nvPr>
+            <p:extLst>
+              <p:ext uri="{D42A27DB-BD31-4B8C-83A1-F6EECF244321}">
+                <p14:modId xmlns:p14="http://schemas.microsoft.com/office/powerpoint/2010/main" val="1135391230"/>
+              </p:ext>
+            </p:extLst>
+          </p:nvPr>
         </p:nvGraphicFramePr>
         <p:xfrm>
           <a:off x="658368" y="1627632"/>
-          <a:ext cx="8229600" cy="2286000"/>
+          <a:ext cx="8229600" cy="2316480"/>
         </p:xfrm>
         <a:graphic>
           <a:graphicData uri="http://schemas.openxmlformats.org/drawingml/2006/table">
@@ -6186,9 +6234,9 @@
                     <a:p>
                       <a:pPr algn="l"/>
                       <a:r>
-                        <a:rPr sz="1050" b="1">
+                        <a:rPr sz="1300" b="1" dirty="0">
                           <a:solidFill>
-                            <a:srgbClr val="6B7683"/>
+                            <a:schemeClr val="bg1"/>
                           </a:solidFill>
                           <a:latin typeface="Calibri"/>
                         </a:rPr>
@@ -6209,9 +6257,9 @@
                     <a:p>
                       <a:pPr algn="l"/>
                       <a:r>
-                        <a:rPr sz="1050" b="1">
+                        <a:rPr sz="1300" b="1" dirty="0">
                           <a:solidFill>
-                            <a:srgbClr val="6B7683"/>
+                            <a:schemeClr val="bg1"/>
                           </a:solidFill>
                           <a:latin typeface="Calibri"/>
                         </a:rPr>
@@ -6221,9 +6269,9 @@
                     <a:p>
                       <a:pPr algn="l"/>
                       <a:r>
-                        <a:rPr sz="1050" b="1">
+                        <a:rPr sz="1300" b="1" dirty="0">
                           <a:solidFill>
-                            <a:srgbClr val="6B7683"/>
+                            <a:schemeClr val="bg1"/>
                           </a:solidFill>
                           <a:latin typeface="Calibri"/>
                         </a:rPr>
@@ -6244,9 +6292,9 @@
                     <a:p>
                       <a:pPr algn="l"/>
                       <a:r>
-                        <a:rPr sz="1050" b="1">
+                        <a:rPr sz="1300" b="1" dirty="0">
                           <a:solidFill>
-                            <a:srgbClr val="6B7683"/>
+                            <a:schemeClr val="bg1"/>
                           </a:solidFill>
                           <a:latin typeface="Calibri"/>
                         </a:rPr>
@@ -6256,9 +6304,9 @@
                     <a:p>
                       <a:pPr algn="l"/>
                       <a:r>
-                        <a:rPr sz="1050" b="1">
+                        <a:rPr sz="1300" b="1" dirty="0">
                           <a:solidFill>
-                            <a:srgbClr val="6B7683"/>
+                            <a:schemeClr val="bg1"/>
                           </a:solidFill>
                           <a:latin typeface="Calibri"/>
                         </a:rPr>
@@ -6279,9 +6327,9 @@
                     <a:p>
                       <a:pPr algn="l"/>
                       <a:r>
-                        <a:rPr sz="1050" b="1">
+                        <a:rPr sz="1300" b="1" dirty="0">
                           <a:solidFill>
-                            <a:srgbClr val="6B7683"/>
+                            <a:schemeClr val="bg1"/>
                           </a:solidFill>
                           <a:latin typeface="Calibri"/>
                         </a:rPr>
@@ -6291,9 +6339,9 @@
                     <a:p>
                       <a:pPr algn="l"/>
                       <a:r>
-                        <a:rPr sz="1050" b="1">
+                        <a:rPr sz="1300" b="1" dirty="0">
                           <a:solidFill>
-                            <a:srgbClr val="6B7683"/>
+                            <a:schemeClr val="bg1"/>
                           </a:solidFill>
                           <a:latin typeface="Calibri"/>
                         </a:rPr>
@@ -6443,7 +6491,7 @@
                     <a:p>
                       <a:pPr algn="l"/>
                       <a:r>
-                        <a:rPr sz="1200" b="0">
+                        <a:rPr sz="1200" b="0" dirty="0">
                           <a:solidFill>
                             <a:srgbClr val="E9EEF4"/>
                           </a:solidFill>
@@ -6466,7 +6514,7 @@
                     <a:p>
                       <a:pPr algn="l"/>
                       <a:r>
-                        <a:rPr sz="1200" b="0">
+                        <a:rPr sz="1200" b="0" dirty="0">
                           <a:solidFill>
                             <a:srgbClr val="E9EEF4"/>
                           </a:solidFill>
@@ -6664,7 +6712,7 @@
                     <a:p>
                       <a:pPr algn="l"/>
                       <a:r>
-                        <a:rPr sz="1200" b="1">
+                        <a:rPr sz="1200" b="1" dirty="0">
                           <a:solidFill>
                             <a:srgbClr val="F0C040"/>
                           </a:solidFill>
@@ -6687,7 +6735,7 @@
                     <a:p>
                       <a:pPr algn="l"/>
                       <a:r>
-                        <a:rPr sz="1200" b="1">
+                        <a:rPr sz="1200" b="1" dirty="0">
                           <a:solidFill>
                             <a:srgbClr val="F0C040"/>
                           </a:solidFill>
@@ -6761,7 +6809,7 @@
               </a:spcAft>
             </a:pPr>
             <a:r>
-              <a:rPr sz="3000" b="1">
+              <a:rPr sz="3000" b="1" dirty="0">
                 <a:solidFill>
                   <a:srgbClr val="F0C040"/>
                 </a:solidFill>
@@ -6777,7 +6825,7 @@
               </a:spcAft>
             </a:pPr>
             <a:r>
-              <a:rPr sz="1150" b="0">
+              <a:rPr sz="1150" b="0" dirty="0">
                 <a:solidFill>
                   <a:srgbClr val="98A3B0"/>
                 </a:solidFill>
@@ -6796,7 +6844,7 @@
               </a:spcAft>
             </a:pPr>
             <a:r>
-              <a:rPr sz="1200" b="0">
+              <a:rPr sz="1200" b="0" dirty="0">
                 <a:solidFill>
                   <a:srgbClr val="E9EEF4"/>
                 </a:solidFill>
@@ -6838,7 +6886,7 @@
               </a:spcAft>
             </a:pPr>
             <a:r>
-              <a:rPr sz="1500" b="1">
+              <a:rPr sz="1500" b="1" dirty="0">
                 <a:solidFill>
                   <a:srgbClr val="E9EEF4"/>
                 </a:solidFill>
@@ -6847,7 +6895,7 @@
               <a:t>Not one construction shows a positive M-target self-advantage whose interval excludes zero. </a:t>
             </a:r>
             <a:r>
-              <a:rPr sz="1500" b="0">
+              <a:rPr sz="1500" b="0" dirty="0">
                 <a:solidFill>
                   <a:srgbClr val="98A3B0"/>
                 </a:solidFill>
@@ -6856,7 +6904,7 @@
               <a:t>The single significant value on that contrast is </a:t>
             </a:r>
             <a:r>
-              <a:rPr sz="1500" b="1">
+              <a:rPr sz="1500" b="1" dirty="0">
                 <a:solidFill>
                   <a:srgbClr val="E24A4A"/>
                 </a:solidFill>
@@ -6865,7 +6913,7 @@
               <a:t>negative</a:t>
             </a:r>
             <a:r>
-              <a:rPr sz="1500" b="0">
+              <a:rPr sz="1500" b="0" dirty="0">
                 <a:solidFill>
                   <a:srgbClr val="98A3B0"/>
                 </a:solidFill>
@@ -6884,7 +6932,7 @@
               </a:spcAft>
             </a:pPr>
             <a:r>
-              <a:rPr sz="1400" b="1">
+              <a:rPr sz="1400" b="1" dirty="0">
                 <a:solidFill>
                   <a:srgbClr val="F0C040"/>
                 </a:solidFill>
@@ -6893,7 +6941,7 @@
               <a:t>Positive interaction, but predictor-by-column differences prevent it from uniquely identifying privileged access. </a:t>
             </a:r>
             <a:r>
-              <a:rPr sz="1400" b="0">
+              <a:rPr sz="1400" b="0" dirty="0">
                 <a:solidFill>
                   <a:srgbClr val="98A3B0"/>
                 </a:solidFill>
@@ -6902,7 +6950,7 @@
               <a:t>It is positive because M </a:t>
             </a:r>
             <a:r>
-              <a:rPr sz="1400" b="1">
+              <a:rPr sz="1400" b="1" dirty="0">
                 <a:solidFill>
                   <a:srgbClr val="E9EEF4"/>
                 </a:solidFill>
@@ -6911,7 +6959,7 @@
               <a:t>under</a:t>
             </a:r>
             <a:r>
-              <a:rPr sz="1400" b="0">
+              <a:rPr sz="1400" b="0" dirty="0">
                 <a:solidFill>
                   <a:srgbClr val="98A3B0"/>
                 </a:solidFill>
@@ -6930,7 +6978,7 @@
         </p:nvSpPr>
         <p:spPr>
           <a:xfrm>
-            <a:off x="658368" y="5623560"/>
+            <a:off x="646481" y="5683187"/>
             <a:ext cx="10874959" cy="566928"/>
           </a:xfrm>
           <a:prstGeom prst="rect">
@@ -6971,7 +7019,7 @@
               </a:spcAft>
             </a:pPr>
             <a:r>
-              <a:rPr sz="1300" b="1">
+              <a:rPr sz="1300" b="1" dirty="0">
                 <a:solidFill>
                   <a:srgbClr val="E9EEF4"/>
                 </a:solidFill>
@@ -6980,13 +7028,31 @@
               <a:t>Four stimulus constructions  ·  shared 200-prompt pool</a:t>
             </a:r>
             <a:r>
-              <a:rPr sz="1100" b="0">
+              <a:rPr sz="1100" b="0" dirty="0">
                 <a:solidFill>
                   <a:srgbClr val="6B7683"/>
                 </a:solidFill>
                 <a:latin typeface="Calibri"/>
               </a:rPr>
-              <a:t>          Preregistered floor 500/cell; achieved ~400; VO-D N = 323. Prompt-clustered bootstrap throughout.</a:t>
+              <a:t>          </a:t>
+            </a:r>
+            <a:r>
+              <a:rPr sz="1100" b="0" dirty="0">
+                <a:solidFill>
+                  <a:schemeClr val="bg1"/>
+                </a:solidFill>
+                <a:latin typeface="Calibri"/>
+              </a:rPr>
+              <a:t>Preregistered floor 500/cell; achieved ~400; VO-D N = 323. Prompt-clustered bootstrap throughout</a:t>
+            </a:r>
+            <a:r>
+              <a:rPr sz="1100" b="0" dirty="0">
+                <a:solidFill>
+                  <a:srgbClr val="6B7683"/>
+                </a:solidFill>
+                <a:latin typeface="Calibri"/>
+              </a:rPr>
+              <a:t>.</a:t>
             </a:r>
           </a:p>
         </p:txBody>
@@ -7044,8 +7110,8 @@
         </p:nvSpPr>
         <p:spPr>
           <a:xfrm>
-            <a:off x="658368" y="6400800"/>
-            <a:ext cx="10874959" cy="274320"/>
+            <a:off x="664769" y="6382512"/>
+            <a:ext cx="10874959" cy="216854"/>
           </a:xfrm>
           <a:prstGeom prst="rect">
             <a:avLst/>
@@ -7067,7 +7133,7 @@
               </a:spcAft>
             </a:pPr>
             <a:r>
-              <a:rPr sz="1050" b="1">
+              <a:rPr sz="1200" b="1" dirty="0">
                 <a:solidFill>
                   <a:srgbClr val="F0C040"/>
                 </a:solidFill>
@@ -7076,13 +7142,22 @@
               <a:t>4</a:t>
             </a:r>
             <a:r>
-              <a:rPr sz="1050" b="0">
+              <a:rPr sz="1200" b="0" dirty="0">
                 <a:solidFill>
                   <a:srgbClr val="6B7683"/>
                 </a:solidFill>
                 <a:latin typeface="Consolas"/>
               </a:rPr>
-              <a:t>  /  6     Crossed design</a:t>
+              <a:t>  </a:t>
+            </a:r>
+            <a:r>
+              <a:rPr sz="1200" b="0" dirty="0">
+                <a:solidFill>
+                  <a:schemeClr val="bg1"/>
+                </a:solidFill>
+                <a:latin typeface="Consolas"/>
+              </a:rPr>
+              <a:t>/  6     Crossed design</a:t>
             </a:r>
           </a:p>
         </p:txBody>
@@ -7128,7 +7203,7 @@
         </p:nvSpPr>
         <p:spPr>
           <a:xfrm>
-            <a:off x="658368" y="475488"/>
+            <a:off x="658368" y="440944"/>
             <a:ext cx="10874959" cy="310896"/>
           </a:xfrm>
           <a:prstGeom prst="rect">
@@ -7148,7 +7223,7 @@
               </a:spcAft>
             </a:pPr>
             <a:r>
-              <a:rPr sz="1150" b="0" spc="160">
+              <a:rPr sz="1150" b="0" spc="160" dirty="0">
                 <a:solidFill>
                   <a:srgbClr val="F0C040"/>
                 </a:solidFill>
@@ -7167,7 +7242,7 @@
         </p:nvSpPr>
         <p:spPr>
           <a:xfrm>
-            <a:off x="658368" y="868680"/>
+            <a:off x="648898" y="723391"/>
             <a:ext cx="10874959" cy="1005840"/>
           </a:xfrm>
           <a:prstGeom prst="rect">
@@ -7190,7 +7265,7 @@
               </a:spcAft>
             </a:pPr>
             <a:r>
-              <a:rPr sz="3000" b="1">
+              <a:rPr sz="3000" b="1" dirty="0">
                 <a:solidFill>
                   <a:srgbClr val="E9EEF4"/>
                 </a:solidFill>
@@ -7209,7 +7284,7 @@
         </p:nvSpPr>
         <p:spPr>
           <a:xfrm>
-            <a:off x="658368" y="1572768"/>
+            <a:off x="648898" y="1385317"/>
             <a:ext cx="3456432" cy="2084831"/>
           </a:xfrm>
           <a:prstGeom prst="rect">
@@ -7256,8 +7331,8 @@
         </p:nvSpPr>
         <p:spPr>
           <a:xfrm>
-            <a:off x="841248" y="1664208"/>
-            <a:ext cx="3090672" cy="1463040"/>
+            <a:off x="841248" y="1527048"/>
+            <a:ext cx="3090672" cy="1362617"/>
           </a:xfrm>
           <a:prstGeom prst="rect">
             <a:avLst/>
@@ -7276,7 +7351,7 @@
               </a:spcAft>
             </a:pPr>
             <a:r>
-              <a:rPr sz="950" b="1" spc="100">
+              <a:rPr sz="950" b="1" spc="100" dirty="0">
                 <a:solidFill>
                   <a:srgbClr val="4A9B4A"/>
                 </a:solidFill>
@@ -7292,7 +7367,7 @@
               </a:spcAft>
             </a:pPr>
             <a:r>
-              <a:rPr sz="1300" b="1">
+              <a:rPr sz="1300" b="1" dirty="0">
                 <a:solidFill>
                   <a:srgbClr val="E9EEF4"/>
                 </a:solidFill>
@@ -7308,7 +7383,7 @@
               </a:spcAft>
             </a:pPr>
             <a:r>
-              <a:rPr sz="3600" b="1">
+              <a:rPr sz="3600" b="1" dirty="0">
                 <a:solidFill>
                   <a:srgbClr val="4A9B4A"/>
                 </a:solidFill>
@@ -7327,9 +7402,9 @@
               </a:spcAft>
             </a:pPr>
             <a:r>
-              <a:rPr sz="1150" b="0">
-                <a:solidFill>
-                  <a:srgbClr val="98A3B0"/>
+              <a:rPr sz="1150" b="0" dirty="0">
+                <a:solidFill>
+                  <a:schemeClr val="bg1"/>
                 </a:solidFill>
                 <a:latin typeface="Calibri"/>
               </a:rPr>
@@ -7346,9 +7421,9 @@
               </a:spcAft>
             </a:pPr>
             <a:r>
-              <a:rPr sz="1150" b="0">
-                <a:solidFill>
-                  <a:srgbClr val="98A3B0"/>
+              <a:rPr sz="1150" b="0" dirty="0">
+                <a:solidFill>
+                  <a:schemeClr val="bg1"/>
                 </a:solidFill>
                 <a:latin typeface="Calibri"/>
               </a:rPr>
@@ -7533,7 +7608,7 @@
         </p:nvSpPr>
         <p:spPr>
           <a:xfrm>
-            <a:off x="4315968" y="1572768"/>
+            <a:off x="4297680" y="1394968"/>
             <a:ext cx="3456432" cy="2084831"/>
           </a:xfrm>
           <a:prstGeom prst="rect">
@@ -7580,8 +7655,8 @@
         </p:nvSpPr>
         <p:spPr>
           <a:xfrm>
-            <a:off x="4498848" y="1664208"/>
-            <a:ext cx="3090672" cy="1463040"/>
+            <a:off x="4498848" y="1577341"/>
+            <a:ext cx="3090672" cy="1362617"/>
           </a:xfrm>
           <a:prstGeom prst="rect">
             <a:avLst/>
@@ -7600,7 +7675,7 @@
               </a:spcAft>
             </a:pPr>
             <a:r>
-              <a:rPr sz="950" b="1" spc="100">
+              <a:rPr sz="950" b="1" spc="100" dirty="0">
                 <a:solidFill>
                   <a:srgbClr val="4A90D9"/>
                 </a:solidFill>
@@ -7616,7 +7691,7 @@
               </a:spcAft>
             </a:pPr>
             <a:r>
-              <a:rPr sz="1300" b="1">
+              <a:rPr sz="1300" b="1" dirty="0">
                 <a:solidFill>
                   <a:srgbClr val="E9EEF4"/>
                 </a:solidFill>
@@ -7632,7 +7707,7 @@
               </a:spcAft>
             </a:pPr>
             <a:r>
-              <a:rPr sz="3600" b="1">
+              <a:rPr sz="3600" b="1" dirty="0">
                 <a:solidFill>
                   <a:srgbClr val="4A90D9"/>
                 </a:solidFill>
@@ -7651,9 +7726,9 @@
               </a:spcAft>
             </a:pPr>
             <a:r>
-              <a:rPr sz="1150" b="0">
-                <a:solidFill>
-                  <a:srgbClr val="98A3B0"/>
+              <a:rPr sz="1150" b="0" dirty="0">
+                <a:solidFill>
+                  <a:schemeClr val="bg1"/>
                 </a:solidFill>
                 <a:latin typeface="Calibri"/>
               </a:rPr>
@@ -7670,9 +7745,9 @@
               </a:spcAft>
             </a:pPr>
             <a:r>
-              <a:rPr sz="1150" b="0">
-                <a:solidFill>
-                  <a:srgbClr val="98A3B0"/>
+              <a:rPr sz="1150" b="0" dirty="0">
+                <a:solidFill>
+                  <a:schemeClr val="bg1"/>
                 </a:solidFill>
                 <a:latin typeface="Calibri"/>
               </a:rPr>
@@ -7857,7 +7932,7 @@
         </p:nvSpPr>
         <p:spPr>
           <a:xfrm>
-            <a:off x="7973568" y="1572768"/>
+            <a:off x="7910768" y="1394968"/>
             <a:ext cx="3456432" cy="2084831"/>
           </a:xfrm>
           <a:prstGeom prst="rect">
@@ -7904,8 +7979,8 @@
         </p:nvSpPr>
         <p:spPr>
           <a:xfrm>
-            <a:off x="8156448" y="1664208"/>
-            <a:ext cx="3090672" cy="1463040"/>
+            <a:off x="8093648" y="1554480"/>
+            <a:ext cx="3090672" cy="1362617"/>
           </a:xfrm>
           <a:prstGeom prst="rect">
             <a:avLst/>
@@ -7924,7 +7999,7 @@
               </a:spcAft>
             </a:pPr>
             <a:r>
-              <a:rPr sz="950" b="1" spc="100">
+              <a:rPr sz="950" b="1" spc="100" dirty="0">
                 <a:solidFill>
                   <a:srgbClr val="F0C040"/>
                 </a:solidFill>
@@ -7940,7 +8015,7 @@
               </a:spcAft>
             </a:pPr>
             <a:r>
-              <a:rPr sz="1300" b="1">
+              <a:rPr sz="1300" b="1" dirty="0">
                 <a:solidFill>
                   <a:srgbClr val="E9EEF4"/>
                 </a:solidFill>
@@ -7956,7 +8031,7 @@
               </a:spcAft>
             </a:pPr>
             <a:r>
-              <a:rPr sz="3600" b="1">
+              <a:rPr sz="3600" b="1" dirty="0">
                 <a:solidFill>
                   <a:srgbClr val="F0C040"/>
                 </a:solidFill>
@@ -7975,9 +8050,9 @@
               </a:spcAft>
             </a:pPr>
             <a:r>
-              <a:rPr sz="1150" b="0">
-                <a:solidFill>
-                  <a:srgbClr val="98A3B0"/>
+              <a:rPr sz="1150" b="0" dirty="0">
+                <a:solidFill>
+                  <a:schemeClr val="bg1"/>
                 </a:solidFill>
                 <a:latin typeface="Calibri"/>
               </a:rPr>
@@ -7994,9 +8069,9 @@
               </a:spcAft>
             </a:pPr>
             <a:r>
-              <a:rPr sz="1150" b="0">
-                <a:solidFill>
-                  <a:srgbClr val="98A3B0"/>
+              <a:rPr sz="1150" b="0" dirty="0">
+                <a:solidFill>
+                  <a:schemeClr val="bg1"/>
                 </a:solidFill>
                 <a:latin typeface="Calibri"/>
               </a:rPr>
@@ -8181,7 +8256,7 @@
         </p:nvSpPr>
         <p:spPr>
           <a:xfrm>
-            <a:off x="658368" y="3712463"/>
+            <a:off x="658368" y="3633723"/>
             <a:ext cx="10881360" cy="457200"/>
           </a:xfrm>
           <a:prstGeom prst="rect">
@@ -8204,7 +8279,7 @@
               </a:spcAft>
             </a:pPr>
             <a:r>
-              <a:rPr sz="1250" b="0">
+              <a:rPr sz="1250" b="0" dirty="0">
                 <a:solidFill>
                   <a:srgbClr val="98A3B0"/>
                 </a:solidFill>
@@ -8213,7 +8288,7 @@
               <a:t>The 0.831 classifier is a different evaluation procedure; the only matched comparator is the length rule </a:t>
             </a:r>
             <a:r>
-              <a:rPr sz="1250" b="0">
+              <a:rPr sz="1250" b="0" dirty="0">
                 <a:solidFill>
                   <a:srgbClr val="E9EEF4"/>
                 </a:solidFill>
@@ -8222,7 +8297,7 @@
               <a:t>(paired difference +0.095 [+0.036, +0.155], McNemar p = 0.0018)</a:t>
             </a:r>
             <a:r>
-              <a:rPr sz="1250" b="0">
+              <a:rPr sz="1250" b="0" dirty="0">
                 <a:solidFill>
                   <a:srgbClr val="98A3B0"/>
                 </a:solidFill>
@@ -8242,7 +8317,7 @@
         <p:spPr>
           <a:xfrm>
             <a:off x="658368" y="4206240"/>
-            <a:ext cx="7040880" cy="1207008"/>
+            <a:ext cx="6858000" cy="1005840"/>
           </a:xfrm>
           <a:prstGeom prst="rect">
             <a:avLst/>
@@ -8288,7 +8363,7 @@
         </p:nvSpPr>
         <p:spPr>
           <a:xfrm>
-            <a:off x="841248" y="4325112"/>
+            <a:off x="859536" y="4348312"/>
             <a:ext cx="6675120" cy="1005840"/>
           </a:xfrm>
           <a:prstGeom prst="rect">
@@ -8362,8 +8437,8 @@
         </p:nvSpPr>
         <p:spPr>
           <a:xfrm>
-            <a:off x="7882127" y="4206240"/>
-            <a:ext cx="3657600" cy="1207008"/>
+            <a:off x="7866257" y="4215384"/>
+            <a:ext cx="3508879" cy="1138768"/>
           </a:xfrm>
           <a:prstGeom prst="rect">
             <a:avLst/>
@@ -8566,7 +8641,7 @@
         <p:spPr>
           <a:xfrm>
             <a:off x="658368" y="6053328"/>
-            <a:ext cx="10874959" cy="256032"/>
+            <a:ext cx="10874959" cy="161583"/>
           </a:xfrm>
           <a:prstGeom prst="rect">
             <a:avLst/>
@@ -8585,9 +8660,9 @@
               </a:spcAft>
             </a:pPr>
             <a:r>
-              <a:rPr sz="1050" b="0">
-                <a:solidFill>
-                  <a:srgbClr val="6B7683"/>
+              <a:rPr sz="1050" b="0" dirty="0">
+                <a:solidFill>
+                  <a:schemeClr val="bg1"/>
                 </a:solidFill>
                 <a:latin typeface="Consolas"/>
               </a:rPr>
@@ -8650,7 +8725,7 @@
         <p:spPr>
           <a:xfrm>
             <a:off x="658368" y="6400800"/>
-            <a:ext cx="10874959" cy="274320"/>
+            <a:ext cx="10874959" cy="216854"/>
           </a:xfrm>
           <a:prstGeom prst="rect">
             <a:avLst/>
@@ -8672,7 +8747,7 @@
               </a:spcAft>
             </a:pPr>
             <a:r>
-              <a:rPr sz="1050" b="1">
+              <a:rPr sz="1200" b="1" dirty="0">
                 <a:solidFill>
                   <a:srgbClr val="F0C040"/>
                 </a:solidFill>
@@ -8681,13 +8756,22 @@
               <a:t>5</a:t>
             </a:r>
             <a:r>
-              <a:rPr sz="1050" b="0">
+              <a:rPr sz="1200" b="0" dirty="0">
                 <a:solidFill>
                   <a:srgbClr val="6B7683"/>
                 </a:solidFill>
                 <a:latin typeface="Consolas"/>
               </a:rPr>
-              <a:t>  /  6     Self-prediction</a:t>
+              <a:t>  </a:t>
+            </a:r>
+            <a:r>
+              <a:rPr sz="1200" b="0" dirty="0">
+                <a:solidFill>
+                  <a:schemeClr val="bg1"/>
+                </a:solidFill>
+                <a:latin typeface="Consolas"/>
+              </a:rPr>
+              <a:t>/  6     Self-prediction</a:t>
             </a:r>
           </a:p>
         </p:txBody>
@@ -8733,7 +8817,7 @@
         </p:nvSpPr>
         <p:spPr>
           <a:xfrm>
-            <a:off x="658368" y="475488"/>
+            <a:off x="658367" y="299105"/>
             <a:ext cx="10874959" cy="310896"/>
           </a:xfrm>
           <a:prstGeom prst="rect">
@@ -8772,7 +8856,7 @@
         </p:nvSpPr>
         <p:spPr>
           <a:xfrm>
-            <a:off x="658368" y="868680"/>
+            <a:off x="658368" y="683153"/>
             <a:ext cx="10874959" cy="1005840"/>
           </a:xfrm>
           <a:prstGeom prst="rect">
@@ -8795,7 +8879,7 @@
               </a:spcAft>
             </a:pPr>
             <a:r>
-              <a:rPr sz="3400" b="1">
+              <a:rPr sz="3400" b="1" dirty="0">
                 <a:solidFill>
                   <a:srgbClr val="E9EEF4"/>
                 </a:solidFill>
@@ -8814,8 +8898,8 @@
         </p:nvSpPr>
         <p:spPr>
           <a:xfrm>
-            <a:off x="658368" y="1536192"/>
-            <a:ext cx="10881360" cy="457200"/>
+            <a:off x="658368" y="1403604"/>
+            <a:ext cx="10881360" cy="586892"/>
           </a:xfrm>
           <a:prstGeom prst="rect">
             <a:avLst/>
@@ -8837,7 +8921,7 @@
               </a:spcAft>
             </a:pPr>
             <a:r>
-              <a:rPr sz="1550" b="0">
+              <a:rPr sz="1550" b="0" dirty="0">
                 <a:solidFill>
                   <a:srgbClr val="98A3B0"/>
                 </a:solidFill>
@@ -8846,13 +8930,13 @@
               <a:t>One question is left open by our own data: </a:t>
             </a:r>
             <a:r>
-              <a:rPr sz="1550" b="1">
+              <a:rPr sz="1550" b="1" dirty="0">
                 <a:solidFill>
                   <a:srgbClr val="E9EEF4"/>
                 </a:solidFill>
                 <a:latin typeface="Calibri"/>
               </a:rPr>
-              <a:t>what is the model-specific residual that survives control of cheap surface cues, and can a behavioural test be built in which a positive privileged-access result would be identifiable?</a:t>
+              <a:t>what is the model-specific residual that survives control of cheap surface cues, and can a behavioral test be built in which a positive privileged-access result would be identifiable?</a:t>
             </a:r>
           </a:p>
         </p:txBody>
@@ -8957,7 +9041,7 @@
         </p:nvSpPr>
         <p:spPr>
           <a:xfrm>
-            <a:off x="841248" y="2432304"/>
+            <a:off x="841248" y="2368296"/>
             <a:ext cx="3163824" cy="310896"/>
           </a:xfrm>
           <a:prstGeom prst="rect">
@@ -9008,7 +9092,7 @@
         </p:nvSpPr>
         <p:spPr>
           <a:xfrm>
-            <a:off x="841248" y="2871216"/>
+            <a:off x="841248" y="2800181"/>
             <a:ext cx="3163824" cy="457200"/>
           </a:xfrm>
           <a:prstGeom prst="rect">
@@ -9031,7 +9115,7 @@
               </a:spcAft>
             </a:pPr>
             <a:r>
-              <a:rPr sz="1400" b="1">
+              <a:rPr sz="1400" b="1" dirty="0">
                 <a:solidFill>
                   <a:srgbClr val="E9EEF4"/>
                 </a:solidFill>
@@ -9050,8 +9134,8 @@
         </p:nvSpPr>
         <p:spPr>
           <a:xfrm>
-            <a:off x="841248" y="3401568"/>
-            <a:ext cx="3163824" cy="1463040"/>
+            <a:off x="841248" y="3220005"/>
+            <a:ext cx="3163824" cy="1636025"/>
           </a:xfrm>
           <a:prstGeom prst="rect">
             <a:avLst/>
@@ -9073,13 +9157,31 @@
               </a:spcAft>
             </a:pPr>
             <a:r>
-              <a:rPr sz="1150" b="0">
-                <a:solidFill>
-                  <a:srgbClr val="98A3B0"/>
+              <a:rPr sz="1200" b="0" dirty="0">
+                <a:solidFill>
+                  <a:schemeClr val="bg1"/>
                 </a:solidFill>
                 <a:latin typeface="Calibri"/>
               </a:rPr>
-              <a:t>Re-run the probe on the same pairs under two questions — “which would you produce?” against “which is better?”. A residual as large under the quality question reads as self-preference; one specific to the prediction framing is the discriminating outcome. Needs a behavioural manipulation check run before collection.</a:t>
+              <a:t>Re-run the probe on the same pairs under two questions — “which would you produce?” against “which is better?”. A residual as large under the quality question reads as self-preference; one specific to the prediction framing is the discriminating outcome. Needs a </a:t>
+            </a:r>
+            <a:r>
+              <a:rPr sz="1200" b="0" dirty="0" err="1">
+                <a:solidFill>
+                  <a:schemeClr val="bg1"/>
+                </a:solidFill>
+                <a:latin typeface="Calibri"/>
+              </a:rPr>
+              <a:t>behavioural</a:t>
+            </a:r>
+            <a:r>
+              <a:rPr sz="1200" b="0" dirty="0">
+                <a:solidFill>
+                  <a:schemeClr val="bg1"/>
+                </a:solidFill>
+                <a:latin typeface="Calibri"/>
+              </a:rPr>
+              <a:t> manipulation check run before collection.</a:t>
             </a:r>
           </a:p>
         </p:txBody>
@@ -9223,7 +9325,7 @@
         </p:nvSpPr>
         <p:spPr>
           <a:xfrm>
-            <a:off x="4572000" y="2432304"/>
+            <a:off x="4572000" y="2388934"/>
             <a:ext cx="3163824" cy="310896"/>
           </a:xfrm>
           <a:prstGeom prst="rect">
@@ -9246,7 +9348,7 @@
               </a:spcAft>
             </a:pPr>
             <a:r>
-              <a:rPr sz="2000" b="1">
+              <a:rPr sz="2000" b="1" dirty="0">
                 <a:solidFill>
                   <a:srgbClr val="4A90D9"/>
                 </a:solidFill>
@@ -9255,7 +9357,7 @@
               <a:t>2   </a:t>
             </a:r>
             <a:r>
-              <a:rPr sz="1250" b="1">
+              <a:rPr sz="1250" b="1" dirty="0">
                 <a:solidFill>
                   <a:srgbClr val="4A90D9"/>
                 </a:solidFill>
@@ -9274,7 +9376,7 @@
         </p:nvSpPr>
         <p:spPr>
           <a:xfrm>
-            <a:off x="4572000" y="2871216"/>
+            <a:off x="4572000" y="2827421"/>
             <a:ext cx="3163824" cy="457200"/>
           </a:xfrm>
           <a:prstGeom prst="rect">
@@ -9317,7 +9419,7 @@
         <p:spPr>
           <a:xfrm>
             <a:off x="4572000" y="3401568"/>
-            <a:ext cx="3163824" cy="1463040"/>
+            <a:ext cx="3163824" cy="1163332"/>
           </a:xfrm>
           <a:prstGeom prst="rect">
             <a:avLst/>
@@ -9339,13 +9441,49 @@
               </a:spcAft>
             </a:pPr>
             <a:r>
-              <a:rPr sz="1150" b="0">
-                <a:solidFill>
-                  <a:srgbClr val="98A3B0"/>
+              <a:rPr sz="1200" b="0" dirty="0">
+                <a:solidFill>
+                  <a:schemeClr val="bg1"/>
                 </a:solidFill>
                 <a:latin typeface="Calibri"/>
               </a:rPr>
-              <a:t>Take the leakage gate and the response-bias check to published behavioural introspection results, and ask how many survive controls this cheap. No new model runs; it tests whether the framework generalises beyond our stimuli.</a:t>
+              <a:t>Take the leakage gate and the response-bias check to published </a:t>
+            </a:r>
+            <a:r>
+              <a:rPr sz="1200" b="0" dirty="0" err="1">
+                <a:solidFill>
+                  <a:schemeClr val="bg1"/>
+                </a:solidFill>
+                <a:latin typeface="Calibri"/>
+              </a:rPr>
+              <a:t>behavioural</a:t>
+            </a:r>
+            <a:r>
+              <a:rPr sz="1200" b="0" dirty="0">
+                <a:solidFill>
+                  <a:schemeClr val="bg1"/>
+                </a:solidFill>
+                <a:latin typeface="Calibri"/>
+              </a:rPr>
+              <a:t> introspection results, and ask how many survive controls this cheap. No new model runs; it tests whether the framework </a:t>
+            </a:r>
+            <a:r>
+              <a:rPr sz="1200" b="0" dirty="0" err="1">
+                <a:solidFill>
+                  <a:schemeClr val="bg1"/>
+                </a:solidFill>
+                <a:latin typeface="Calibri"/>
+              </a:rPr>
+              <a:t>generalises</a:t>
+            </a:r>
+            <a:r>
+              <a:rPr sz="1200" b="0" dirty="0">
+                <a:solidFill>
+                  <a:schemeClr val="bg1"/>
+                </a:solidFill>
+                <a:latin typeface="Calibri"/>
+              </a:rPr>
+              <a:t> beyond our stimuli.</a:t>
             </a:r>
           </a:p>
         </p:txBody>
@@ -9489,7 +9627,7 @@
         </p:nvSpPr>
         <p:spPr>
           <a:xfrm>
-            <a:off x="8302752" y="2432304"/>
+            <a:off x="8302752" y="2367915"/>
             <a:ext cx="3163824" cy="310896"/>
           </a:xfrm>
           <a:prstGeom prst="rect">
@@ -9512,7 +9650,7 @@
               </a:spcAft>
             </a:pPr>
             <a:r>
-              <a:rPr sz="2000" b="1">
+              <a:rPr sz="2000" b="1" dirty="0">
                 <a:solidFill>
                   <a:srgbClr val="F0C040"/>
                 </a:solidFill>
@@ -9521,7 +9659,7 @@
               <a:t>3   </a:t>
             </a:r>
             <a:r>
-              <a:rPr sz="1250" b="1">
+              <a:rPr sz="1250" b="1" dirty="0">
                 <a:solidFill>
                   <a:srgbClr val="F0C040"/>
                 </a:solidFill>
@@ -9540,7 +9678,7 @@
         </p:nvSpPr>
         <p:spPr>
           <a:xfrm>
-            <a:off x="8302752" y="2871216"/>
+            <a:off x="8302752" y="2778272"/>
             <a:ext cx="3163824" cy="457200"/>
           </a:xfrm>
           <a:prstGeom prst="rect">
@@ -9563,7 +9701,7 @@
               </a:spcAft>
             </a:pPr>
             <a:r>
-              <a:rPr sz="1400" b="1">
+              <a:rPr sz="1400" b="1" dirty="0">
                 <a:solidFill>
                   <a:srgbClr val="E9EEF4"/>
                 </a:solidFill>
@@ -9582,8 +9720,8 @@
         </p:nvSpPr>
         <p:spPr>
           <a:xfrm>
-            <a:off x="8302752" y="3401568"/>
-            <a:ext cx="3163824" cy="1463040"/>
+            <a:off x="8266176" y="3334933"/>
+            <a:ext cx="3236976" cy="1636025"/>
           </a:xfrm>
           <a:prstGeom prst="rect">
             <a:avLst/>
@@ -9605,9 +9743,9 @@
               </a:spcAft>
             </a:pPr>
             <a:r>
-              <a:rPr sz="1150" b="0">
-                <a:solidFill>
-                  <a:srgbClr val="98A3B0"/>
+              <a:rPr sz="1200" b="0" dirty="0">
+                <a:solidFill>
+                  <a:schemeClr val="bg1"/>
                 </a:solidFill>
                 <a:latin typeface="Calibri"/>
               </a:rPr>
@@ -9625,7 +9763,7 @@
         <p:spPr>
           <a:xfrm>
             <a:off x="658368" y="5193792"/>
-            <a:ext cx="10881360" cy="457200"/>
+            <a:ext cx="10881360" cy="221214"/>
           </a:xfrm>
           <a:prstGeom prst="rect">
             <a:avLst/>
@@ -9647,9 +9785,9 @@
               </a:spcAft>
             </a:pPr>
             <a:r>
-              <a:rPr sz="1250" b="0">
-                <a:solidFill>
-                  <a:srgbClr val="6B7683"/>
+              <a:rPr sz="1250" b="0" dirty="0">
+                <a:solidFill>
+                  <a:schemeClr val="bg1"/>
                 </a:solidFill>
                 <a:latin typeface="Calibri"/>
               </a:rPr>
@@ -9798,7 +9936,7 @@
         <p:spPr>
           <a:xfrm>
             <a:off x="658368" y="6400800"/>
-            <a:ext cx="10874959" cy="274320"/>
+            <a:ext cx="10874959" cy="216854"/>
           </a:xfrm>
           <a:prstGeom prst="rect">
             <a:avLst/>
@@ -9820,7 +9958,7 @@
               </a:spcAft>
             </a:pPr>
             <a:r>
-              <a:rPr sz="1050" b="1">
+              <a:rPr sz="1200" b="1" dirty="0">
                 <a:solidFill>
                   <a:srgbClr val="F0C040"/>
                 </a:solidFill>
@@ -9829,13 +9967,22 @@
               <a:t>6</a:t>
             </a:r>
             <a:r>
-              <a:rPr sz="1050" b="0">
+              <a:rPr sz="1200" b="0" dirty="0">
                 <a:solidFill>
                   <a:srgbClr val="6B7683"/>
                 </a:solidFill>
                 <a:latin typeface="Consolas"/>
               </a:rPr>
-              <a:t>  /  6     Future work</a:t>
+              <a:t> </a:t>
+            </a:r>
+            <a:r>
+              <a:rPr sz="1200" b="0" dirty="0">
+                <a:solidFill>
+                  <a:schemeClr val="bg1"/>
+                </a:solidFill>
+                <a:latin typeface="Consolas"/>
+              </a:rPr>
+              <a:t> /  6     Future work</a:t>
             </a:r>
           </a:p>
         </p:txBody>

</xml_diff>